<commit_message>
Page 1: renumber modules 1-6, rename modules 5 and 6, new module descriptions and value props
Co-authored-by: ersoysarp <ersoysarp@users.noreply.github.com>
</commit_message>
<xml_diff>
--- a/BlueCurrency.pptx
+++ b/BlueCurrency.pptx
@@ -4163,7 +4163,7 @@
                 </a:solidFill>
                 <a:latin typeface="Calibri"/>
               </a:rPr>
-              <a:t>End to End Agentic Orchestration for Construction Lifecycle Management</a:t>
+              <a:t>1     End to End Agentic Orchestration for Construction Lifecycle Management</a:t>
             </a:r>
           </a:p>
         </p:txBody>
@@ -4262,7 +4262,7 @@
                 </a:solidFill>
                 <a:latin typeface="Calibri"/>
               </a:rPr>
-              <a:t>1</a:t>
+              <a:t>2</a:t>
             </a:r>
           </a:p>
         </p:txBody>
@@ -4394,7 +4394,7 @@
                 </a:solidFill>
                 <a:latin typeface="Calibri"/>
               </a:rPr>
-              <a:t>2</a:t>
+              <a:t>3</a:t>
             </a:r>
           </a:p>
         </p:txBody>
@@ -4526,7 +4526,7 @@
                 </a:solidFill>
                 <a:latin typeface="Calibri"/>
               </a:rPr>
-              <a:t>3</a:t>
+              <a:t>4</a:t>
             </a:r>
           </a:p>
         </p:txBody>
@@ -4658,7 +4658,7 @@
                 </a:solidFill>
                 <a:latin typeface="Calibri"/>
               </a:rPr>
-              <a:t>4</a:t>
+              <a:t>5</a:t>
             </a:r>
           </a:p>
         </p:txBody>
@@ -4691,7 +4691,7 @@
                 </a:solidFill>
                 <a:latin typeface="Calibri"/>
               </a:rPr>
-              <a:t>Agentic Procurement and Construction Progress Tracking</a:t>
+              <a:t>Agentic Cost Realization Tracking</a:t>
             </a:r>
           </a:p>
         </p:txBody>
@@ -4751,7 +4751,7 @@
         </p:nvSpPr>
         <p:spPr>
           <a:xfrm>
-            <a:off x="2944368" y="3090672"/>
+            <a:off x="2697480" y="3090672"/>
             <a:ext cx="310896" cy="310896"/>
           </a:xfrm>
           <a:prstGeom prst="ellipse">
@@ -4790,7 +4790,7 @@
                 </a:solidFill>
                 <a:latin typeface="Calibri"/>
               </a:rPr>
-              <a:t>5</a:t>
+              <a:t>6</a:t>
             </a:r>
           </a:p>
         </p:txBody>
@@ -4803,8 +4803,8 @@
         </p:nvSpPr>
         <p:spPr>
           <a:xfrm>
-            <a:off x="3310128" y="3090672"/>
-            <a:ext cx="2194560" cy="310896"/>
+            <a:off x="3063240" y="3090672"/>
+            <a:ext cx="2651760" cy="310896"/>
           </a:xfrm>
           <a:prstGeom prst="rect">
             <a:avLst/>
@@ -4823,7 +4823,7 @@
                 </a:solidFill>
                 <a:latin typeface="Calibri"/>
               </a:rPr>
-              <a:t>Value Optimizer</a:t>
+              <a:t>AI-Based Value Optimizer</a:t>
             </a:r>
           </a:p>
         </p:txBody>
@@ -5418,7 +5418,7 @@
                 </a:solidFill>
                 <a:latin typeface="Calibri"/>
               </a:rPr>
-              <a:t>★</a:t>
+              <a:t>1</a:t>
             </a:r>
           </a:p>
         </p:txBody>
@@ -5484,7 +5484,7 @@
                 </a:solidFill>
                 <a:latin typeface="Calibri"/>
               </a:rPr>
-              <a:t>One governed layer across every stage, learning from each project</a:t>
+              <a:t>Single platform view to manage projects from project brief to end of construction</a:t>
             </a:r>
           </a:p>
         </p:txBody>
@@ -5579,7 +5579,7 @@
                 </a:solidFill>
                 <a:latin typeface="Calibri"/>
               </a:rPr>
-              <a:t>1</a:t>
+              <a:t>2</a:t>
             </a:r>
           </a:p>
         </p:txBody>
@@ -5645,7 +5645,7 @@
                 </a:solidFill>
                 <a:latin typeface="Calibri"/>
               </a:rPr>
-              <a:t>Unique item codes, any format mapped into one standard</a:t>
+              <a:t>AI-based unified BoQ catalog creator and data cleaner at spec level, using the client's dirty historical data</a:t>
             </a:r>
           </a:p>
         </p:txBody>
@@ -5740,7 +5740,7 @@
                 </a:solidFill>
                 <a:latin typeface="Calibri"/>
               </a:rPr>
-              <a:t>2</a:t>
+              <a:t>3</a:t>
             </a:r>
           </a:p>
         </p:txBody>
@@ -5806,7 +5806,7 @@
                 </a:solidFill>
                 <a:latin typeface="Calibri"/>
               </a:rPr>
-              <a:t>Item-level forecasts live with commodity, labor and FX</a:t>
+              <a:t>Item-level cost breakdown structure creator, with live commodity and macro-economic price index integration for forecasting</a:t>
             </a:r>
           </a:p>
         </p:txBody>
@@ -5901,7 +5901,7 @@
                 </a:solidFill>
                 <a:latin typeface="Calibri"/>
               </a:rPr>
-              <a:t>3</a:t>
+              <a:t>4</a:t>
             </a:r>
           </a:p>
         </p:txBody>
@@ -5967,7 +5967,7 @@
                 </a:solidFill>
                 <a:latin typeface="Calibri"/>
               </a:rPr>
-              <a:t>Bids normalized, outliers flagged, ranked in minutes</a:t>
+              <a:t>Automatically collects bids, flags outliers and generates an AI-recommended price range to score each bid</a:t>
             </a:r>
           </a:p>
         </p:txBody>
@@ -6062,7 +6062,7 @@
                 </a:solidFill>
                 <a:latin typeface="Calibri"/>
               </a:rPr>
-              <a:t>4</a:t>
+              <a:t>5</a:t>
             </a:r>
           </a:p>
         </p:txBody>
@@ -6095,7 +6095,7 @@
                 </a:solidFill>
                 <a:latin typeface="Calibri"/>
               </a:rPr>
-              <a:t>Procurement and Progress Tracking</a:t>
+              <a:t>Agentic Cost Realization Tracking</a:t>
             </a:r>
           </a:p>
         </p:txBody>
@@ -6128,7 +6128,7 @@
                 </a:solidFill>
                 <a:latin typeface="Calibri"/>
               </a:rPr>
-              <a:t>Quantities and progress checked, overruns flagged early</a:t>
+              <a:t>Agentic contract and IPC collection to track cost realization and project progress in real time</a:t>
             </a:r>
           </a:p>
         </p:txBody>
@@ -6223,7 +6223,7 @@
                 </a:solidFill>
                 <a:latin typeface="Calibri"/>
               </a:rPr>
-              <a:t>5</a:t>
+              <a:t>6</a:t>
             </a:r>
           </a:p>
         </p:txBody>
@@ -6256,7 +6256,7 @@
                 </a:solidFill>
                 <a:latin typeface="Calibri"/>
               </a:rPr>
-              <a:t>Value Optimizer</a:t>
+              <a:t>AI-Based Value Optimizer</a:t>
             </a:r>
           </a:p>
         </p:txBody>
@@ -6289,7 +6289,7 @@
                 </a:solidFill>
                 <a:latin typeface="Calibri"/>
               </a:rPr>
-              <a:t>Always-on value engineering mined from past projects</a:t>
+              <a:t>Agentic workflow to predict risks and procurement value optimization opportunities by learning from historical data</a:t>
             </a:r>
           </a:p>
         </p:txBody>
@@ -6650,7 +6650,7 @@
                 </a:solidFill>
                 <a:latin typeface="Calibri"/>
               </a:rPr>
-              <a:t>Easy to use — the fundamentals, without suite complexity</a:t>
+              <a:t>Easy to use — covering all the fundamentals, without suite complexities</a:t>
             </a:r>
           </a:p>
         </p:txBody>
@@ -6771,7 +6771,7 @@
                 </a:solidFill>
                 <a:latin typeface="Calibri"/>
               </a:rPr>
-              <a:t>Plug and play, with near zero data prep</a:t>
+              <a:t>Plug and play: limited data prep or integration need</a:t>
             </a:r>
           </a:p>
         </p:txBody>
@@ -7608,7 +7608,7 @@
                 </a:solidFill>
                 <a:latin typeface="Calibri"/>
               </a:rPr>
-              <a:t>★</a:t>
+              <a:t>1</a:t>
             </a:r>
           </a:p>
         </p:txBody>
@@ -8135,7 +8135,7 @@
                 </a:solidFill>
                 <a:latin typeface="Calibri"/>
               </a:rPr>
-              <a:t>1</a:t>
+              <a:t>2</a:t>
             </a:r>
           </a:p>
         </p:txBody>
@@ -8662,7 +8662,7 @@
                 </a:solidFill>
                 <a:latin typeface="Calibri"/>
               </a:rPr>
-              <a:t>2</a:t>
+              <a:t>3</a:t>
             </a:r>
           </a:p>
         </p:txBody>
@@ -9189,7 +9189,7 @@
                 </a:solidFill>
                 <a:latin typeface="Calibri"/>
               </a:rPr>
-              <a:t>3</a:t>
+              <a:t>4</a:t>
             </a:r>
           </a:p>
         </p:txBody>
@@ -9716,7 +9716,7 @@
                 </a:solidFill>
                 <a:latin typeface="Calibri"/>
               </a:rPr>
-              <a:t>4</a:t>
+              <a:t>5</a:t>
             </a:r>
           </a:p>
         </p:txBody>
@@ -9749,7 +9749,7 @@
                 </a:solidFill>
                 <a:latin typeface="Calibri"/>
               </a:rPr>
-              <a:t>Procurement and Progress Tracking</a:t>
+              <a:t>Agentic Cost Realization Tracking</a:t>
             </a:r>
           </a:p>
         </p:txBody>
@@ -10243,7 +10243,7 @@
                 </a:solidFill>
                 <a:latin typeface="Calibri"/>
               </a:rPr>
-              <a:t>5</a:t>
+              <a:t>6</a:t>
             </a:r>
           </a:p>
         </p:txBody>
@@ -10276,7 +10276,7 @@
                 </a:solidFill>
                 <a:latin typeface="Calibri"/>
               </a:rPr>
-              <a:t>Value Optimizer</a:t>
+              <a:t>AI-Based Value Optimizer</a:t>
             </a:r>
           </a:p>
         </p:txBody>
@@ -14009,7 +14009,7 @@
                 </a:solidFill>
                 <a:latin typeface="Calibri"/>
               </a:rPr>
-              <a:t>★</a:t>
+              <a:t>1</a:t>
             </a:r>
           </a:p>
         </p:txBody>
@@ -14666,7 +14666,7 @@
                 </a:solidFill>
                 <a:latin typeface="Calibri"/>
               </a:rPr>
-              <a:t>1</a:t>
+              <a:t>2</a:t>
             </a:r>
           </a:p>
         </p:txBody>
@@ -15323,7 +15323,7 @@
                 </a:solidFill>
                 <a:latin typeface="Calibri"/>
               </a:rPr>
-              <a:t>2</a:t>
+              <a:t>3</a:t>
             </a:r>
           </a:p>
         </p:txBody>
@@ -15980,7 +15980,7 @@
                 </a:solidFill>
                 <a:latin typeface="Calibri"/>
               </a:rPr>
-              <a:t>3</a:t>
+              <a:t>4</a:t>
             </a:r>
           </a:p>
         </p:txBody>
@@ -16637,7 +16637,7 @@
                 </a:solidFill>
                 <a:latin typeface="Calibri"/>
               </a:rPr>
-              <a:t>4</a:t>
+              <a:t>5</a:t>
             </a:r>
           </a:p>
         </p:txBody>
@@ -16670,7 +16670,7 @@
                 </a:solidFill>
                 <a:latin typeface="Calibri"/>
               </a:rPr>
-              <a:t>Procurement and Progress Tracking</a:t>
+              <a:t>Agentic Cost Realization Tracking</a:t>
             </a:r>
           </a:p>
         </p:txBody>
@@ -17294,7 +17294,7 @@
                 </a:solidFill>
                 <a:latin typeface="Calibri"/>
               </a:rPr>
-              <a:t>5</a:t>
+              <a:t>6</a:t>
             </a:r>
           </a:p>
         </p:txBody>
@@ -17327,7 +17327,7 @@
                 </a:solidFill>
                 <a:latin typeface="Calibri"/>
               </a:rPr>
-              <a:t>Value Optimizer</a:t>
+              <a:t>AI-Based Value Optimizer</a:t>
             </a:r>
           </a:p>
         </p:txBody>

</xml_diff>

<commit_message>
Page 2: High/Medium/Low severity per player type, drop cost column and icons, new row copy
Co-authored-by: ersoysarp <ersoysarp@users.noreply.github.com>
</commit_message>
<xml_diff>
--- a/BlueCurrency.pptx
+++ b/BlueCurrency.pptx
@@ -575,7 +575,7 @@
           <a:lstStyle/>
           <a:p>
             <a:r>
-              <a:t>Page 2 — The problem. Even market leaders still run these workflows manually. Severity is shown separately for leaders and developing players. Developing players consistently hurt more. Consequence of each gap is in the third column; Blue Currency response in the last.</a:t>
+              <a:t>Page 2 - The problem. Severity of the pain is rated High / Medium / Low separately for market leaders and developing players. The 'what it costs them' column was removed; severity carries that message.</a:t>
             </a:r>
           </a:p>
         </p:txBody>
@@ -7043,7 +7043,7 @@
         <p:spPr>
           <a:xfrm>
             <a:off x="384048" y="914400"/>
-            <a:ext cx="3108960" cy="237744"/>
+            <a:ext cx="3200400" cy="237744"/>
           </a:xfrm>
           <a:prstGeom prst="rect">
             <a:avLst/>
@@ -7062,7 +7062,7 @@
                 </a:solidFill>
                 <a:latin typeface="Calibri"/>
               </a:rPr>
-              <a:t>Each row carries its own severity bar</a:t>
+              <a:t>Each row carries its own severity of pain</a:t>
             </a:r>
           </a:p>
         </p:txBody>
@@ -7075,7 +7075,7 @@
         </p:nvSpPr>
         <p:spPr>
           <a:xfrm>
-            <a:off x="3657600" y="969264"/>
+            <a:off x="3749039" y="969264"/>
             <a:ext cx="256032" cy="109728"/>
           </a:xfrm>
           <a:prstGeom prst="roundRect">
@@ -7120,7 +7120,7 @@
         </p:nvSpPr>
         <p:spPr>
           <a:xfrm>
-            <a:off x="3968496" y="914400"/>
+            <a:off x="4059935" y="914400"/>
             <a:ext cx="868680" cy="219456"/>
           </a:xfrm>
           <a:prstGeom prst="rect">
@@ -7140,7 +7140,7 @@
                 </a:solidFill>
                 <a:latin typeface="Calibri"/>
               </a:rPr>
-              <a:t>Critical</a:t>
+              <a:t>High</a:t>
             </a:r>
           </a:p>
         </p:txBody>
@@ -7153,7 +7153,7 @@
         </p:nvSpPr>
         <p:spPr>
           <a:xfrm>
-            <a:off x="4892040" y="969264"/>
+            <a:off x="4983479" y="969264"/>
             <a:ext cx="256032" cy="109728"/>
           </a:xfrm>
           <a:prstGeom prst="roundRect">
@@ -7198,7 +7198,7 @@
         </p:nvSpPr>
         <p:spPr>
           <a:xfrm>
-            <a:off x="5202936" y="914400"/>
+            <a:off x="5294375" y="914400"/>
             <a:ext cx="868680" cy="219456"/>
           </a:xfrm>
           <a:prstGeom prst="rect">
@@ -7218,7 +7218,7 @@
                 </a:solidFill>
                 <a:latin typeface="Calibri"/>
               </a:rPr>
-              <a:t>High</a:t>
+              <a:t>Medium</a:t>
             </a:r>
           </a:p>
         </p:txBody>
@@ -7231,7 +7231,7 @@
         </p:nvSpPr>
         <p:spPr>
           <a:xfrm>
-            <a:off x="6126480" y="969264"/>
+            <a:off x="6217919" y="969264"/>
             <a:ext cx="256032" cy="109728"/>
           </a:xfrm>
           <a:prstGeom prst="roundRect">
@@ -7276,7 +7276,7 @@
         </p:nvSpPr>
         <p:spPr>
           <a:xfrm>
-            <a:off x="6437376" y="914400"/>
+            <a:off x="6528815" y="914400"/>
             <a:ext cx="868680" cy="219456"/>
           </a:xfrm>
           <a:prstGeom prst="rect">
@@ -7296,7 +7296,7 @@
                 </a:solidFill>
                 <a:latin typeface="Calibri"/>
               </a:rPr>
-              <a:t>Medium</a:t>
+              <a:t>Low</a:t>
             </a:r>
           </a:p>
         </p:txBody>
@@ -7364,7 +7364,7 @@
         <p:spPr>
           <a:xfrm>
             <a:off x="2423160" y="1207008"/>
-            <a:ext cx="4160520" cy="530352"/>
+            <a:ext cx="6583680" cy="530352"/>
           </a:xfrm>
           <a:prstGeom prst="roundRect">
             <a:avLst>
@@ -7418,8 +7418,8 @@
         </p:nvSpPr>
         <p:spPr>
           <a:xfrm>
-            <a:off x="6656832" y="1207008"/>
-            <a:ext cx="2331720" cy="530352"/>
+            <a:off x="9098280" y="1207008"/>
+            <a:ext cx="2706624" cy="530352"/>
           </a:xfrm>
           <a:prstGeom prst="roundRect">
             <a:avLst>
@@ -7427,7 +7427,7 @@
             </a:avLst>
           </a:prstGeom>
           <a:solidFill>
-            <a:srgbClr val="4C5866"/>
+            <a:srgbClr val="0B7F77"/>
           </a:solidFill>
           <a:ln>
             <a:noFill/>
@@ -7459,29 +7459,27 @@
                 </a:solidFill>
                 <a:latin typeface="Calibri"/>
               </a:rPr>
-              <a:t>What it costs them</a:t>
-            </a:r>
-          </a:p>
-        </p:txBody>
-      </p:sp>
-      <p:sp>
-        <p:nvSpPr>
-          <p:cNvPr id="15" name="Rounded Rectangle 14"/>
+              <a:t>What Blue Currency does</a:t>
+            </a:r>
+          </a:p>
+        </p:txBody>
+      </p:sp>
+      <p:sp>
+        <p:nvSpPr>
+          <p:cNvPr id="15" name="Rectangle 14"/>
           <p:cNvSpPr/>
           <p:nvPr/>
         </p:nvSpPr>
         <p:spPr>
           <a:xfrm>
-            <a:off x="9061704" y="1207008"/>
-            <a:ext cx="2743200" cy="530352"/>
-          </a:xfrm>
-          <a:prstGeom prst="roundRect">
-            <a:avLst>
-              <a:gd name="adj" fmla="val 4000"/>
-            </a:avLst>
-          </a:prstGeom>
-          <a:solidFill>
-            <a:srgbClr val="0B7F77"/>
+            <a:off x="384048" y="2587752"/>
+            <a:ext cx="11420856" cy="9144"/>
+          </a:xfrm>
+          <a:prstGeom prst="rect">
+            <a:avLst/>
+          </a:prstGeom>
+          <a:solidFill>
+            <a:srgbClr val="E3E8E9"/>
           </a:solidFill>
           <a:ln>
             <a:noFill/>
@@ -7502,38 +7500,29 @@
           </a:fontRef>
         </p:style>
         <p:txBody>
-          <a:bodyPr rtlCol="0" anchor="ctr" wrap="square" lIns="73152" rIns="73152" tIns="36576" bIns="36576"/>
-          <a:lstStyle/>
-          <a:p>
-            <a:pPr algn="l"/>
-            <a:r>
-              <a:rPr sz="1400" b="1">
-                <a:solidFill>
-                  <a:srgbClr val="FFFFFF"/>
-                </a:solidFill>
-                <a:latin typeface="Calibri"/>
-              </a:rPr>
-              <a:t>What Blue Currency does</a:t>
-            </a:r>
-          </a:p>
-        </p:txBody>
-      </p:sp>
-      <p:sp>
-        <p:nvSpPr>
-          <p:cNvPr id="16" name="Rectangle 15"/>
+          <a:bodyPr rtlCol="0" anchor="ctr"/>
+          <a:lstStyle/>
+          <a:p>
+            <a:pPr algn="ctr"/>
+          </a:p>
+        </p:txBody>
+      </p:sp>
+      <p:sp>
+        <p:nvSpPr>
+          <p:cNvPr id="16" name="Oval 15"/>
           <p:cNvSpPr/>
           <p:nvPr/>
         </p:nvSpPr>
         <p:spPr>
           <a:xfrm>
-            <a:off x="384048" y="2587752"/>
-            <a:ext cx="11420856" cy="9144"/>
-          </a:xfrm>
-          <a:prstGeom prst="rect">
-            <a:avLst/>
-          </a:prstGeom>
-          <a:solidFill>
-            <a:srgbClr val="E3E8E9"/>
+            <a:off x="457200" y="2048256"/>
+            <a:ext cx="292608" cy="292608"/>
+          </a:xfrm>
+          <a:prstGeom prst="ellipse">
+            <a:avLst/>
+          </a:prstGeom>
+          <a:solidFill>
+            <a:srgbClr val="0A5F59"/>
           </a:solidFill>
           <a:ln>
             <a:noFill/>
@@ -7554,29 +7543,172 @@
           </a:fontRef>
         </p:style>
         <p:txBody>
-          <a:bodyPr rtlCol="0" anchor="ctr"/>
+          <a:bodyPr rtlCol="0" anchor="ctr" wrap="none"/>
           <a:lstStyle/>
           <a:p>
             <a:pPr algn="ctr"/>
-          </a:p>
-        </p:txBody>
-      </p:sp>
-      <p:sp>
-        <p:nvSpPr>
-          <p:cNvPr id="17" name="Oval 16"/>
+            <a:r>
+              <a:rPr sz="1100" b="1">
+                <a:solidFill>
+                  <a:srgbClr val="FFFFFF"/>
+                </a:solidFill>
+                <a:latin typeface="Calibri"/>
+              </a:rPr>
+              <a:t>1</a:t>
+            </a:r>
+          </a:p>
+        </p:txBody>
+      </p:sp>
+      <p:sp>
+        <p:nvSpPr>
+          <p:cNvPr id="17" name="TextBox 16"/>
+          <p:cNvSpPr txBox="1"/>
+          <p:nvPr/>
+        </p:nvSpPr>
+        <p:spPr>
+          <a:xfrm>
+            <a:off x="822960" y="1975104"/>
+            <a:ext cx="1536192" cy="512064"/>
+          </a:xfrm>
+          <a:prstGeom prst="rect">
+            <a:avLst/>
+          </a:prstGeom>
+          <a:noFill/>
+        </p:spPr>
+        <p:txBody>
+          <a:bodyPr wrap="square" anchor="t"/>
+          <a:lstStyle/>
+          <a:p>
+            <a:pPr algn="l"/>
+            <a:r>
+              <a:rPr sz="1300" b="1">
+                <a:solidFill>
+                  <a:srgbClr val="26303A"/>
+                </a:solidFill>
+                <a:latin typeface="Calibri"/>
+              </a:rPr>
+              <a:t>End to End Agentic Orchestration</a:t>
+            </a:r>
+          </a:p>
+        </p:txBody>
+      </p:sp>
+      <p:sp>
+        <p:nvSpPr>
+          <p:cNvPr id="18" name="TextBox 17"/>
+          <p:cNvSpPr txBox="1"/>
+          <p:nvPr/>
+        </p:nvSpPr>
+        <p:spPr>
+          <a:xfrm>
+            <a:off x="2450592" y="1865376"/>
+            <a:ext cx="914400" cy="274320"/>
+          </a:xfrm>
+          <a:prstGeom prst="rect">
+            <a:avLst/>
+          </a:prstGeom>
+          <a:noFill/>
+        </p:spPr>
+        <p:txBody>
+          <a:bodyPr wrap="square" anchor="t"/>
+          <a:lstStyle/>
+          <a:p>
+            <a:pPr algn="l"/>
+            <a:r>
+              <a:rPr sz="1100" b="1">
+                <a:solidFill>
+                  <a:srgbClr val="0A5F59"/>
+                </a:solidFill>
+                <a:latin typeface="Calibri"/>
+              </a:rPr>
+              <a:t>LEADERS</a:t>
+            </a:r>
+          </a:p>
+        </p:txBody>
+      </p:sp>
+      <p:sp>
+        <p:nvSpPr>
+          <p:cNvPr id="19" name="TextBox 18"/>
+          <p:cNvSpPr txBox="1"/>
+          <p:nvPr/>
+        </p:nvSpPr>
+        <p:spPr>
+          <a:xfrm>
+            <a:off x="3383280" y="1865376"/>
+            <a:ext cx="3703320" cy="329184"/>
+          </a:xfrm>
+          <a:prstGeom prst="rect">
+            <a:avLst/>
+          </a:prstGeom>
+          <a:noFill/>
+        </p:spPr>
+        <p:txBody>
+          <a:bodyPr wrap="square" anchor="t"/>
+          <a:lstStyle/>
+          <a:p>
+            <a:pPr algn="l"/>
+            <a:r>
+              <a:rPr sz="1200" b="0">
+                <a:solidFill>
+                  <a:srgbClr val="3A454F"/>
+                </a:solidFill>
+                <a:latin typeface="Calibri"/>
+              </a:rPr>
+              <a:t>Core ERP with ad hoc point tools and limited integration</a:t>
+            </a:r>
+          </a:p>
+        </p:txBody>
+      </p:sp>
+      <p:sp>
+        <p:nvSpPr>
+          <p:cNvPr id="20" name="TextBox 19"/>
+          <p:cNvSpPr txBox="1"/>
+          <p:nvPr/>
+        </p:nvSpPr>
+        <p:spPr>
+          <a:xfrm>
+            <a:off x="7114032" y="1865376"/>
+            <a:ext cx="777240" cy="274320"/>
+          </a:xfrm>
+          <a:prstGeom prst="rect">
+            <a:avLst/>
+          </a:prstGeom>
+          <a:noFill/>
+        </p:spPr>
+        <p:txBody>
+          <a:bodyPr wrap="square" anchor="t"/>
+          <a:lstStyle/>
+          <a:p>
+            <a:pPr algn="r"/>
+            <a:r>
+              <a:rPr sz="1100" b="1">
+                <a:solidFill>
+                  <a:srgbClr val="96641A"/>
+                </a:solidFill>
+                <a:latin typeface="Calibri"/>
+              </a:rPr>
+              <a:t>MEDIUM</a:t>
+            </a:r>
+          </a:p>
+        </p:txBody>
+      </p:sp>
+      <p:sp>
+        <p:nvSpPr>
+          <p:cNvPr id="21" name="Rounded Rectangle 20"/>
           <p:cNvSpPr/>
           <p:nvPr/>
         </p:nvSpPr>
         <p:spPr>
           <a:xfrm>
-            <a:off x="457200" y="2048256"/>
-            <a:ext cx="292608" cy="292608"/>
-          </a:xfrm>
-          <a:prstGeom prst="ellipse">
-            <a:avLst/>
-          </a:prstGeom>
-          <a:solidFill>
-            <a:srgbClr val="0A5F59"/>
+            <a:off x="7973568" y="1938528"/>
+            <a:ext cx="914400" cy="128016"/>
+          </a:xfrm>
+          <a:prstGeom prst="roundRect">
+            <a:avLst>
+              <a:gd name="adj" fmla="val 50000"/>
+            </a:avLst>
+          </a:prstGeom>
+          <a:solidFill>
+            <a:srgbClr val="EDF0F2"/>
           </a:solidFill>
           <a:ln>
             <a:noFill/>
@@ -7597,131 +7729,23 @@
           </a:fontRef>
         </p:style>
         <p:txBody>
-          <a:bodyPr rtlCol="0" anchor="ctr" wrap="none"/>
+          <a:bodyPr rtlCol="0" anchor="ctr"/>
           <a:lstStyle/>
           <a:p>
             <a:pPr algn="ctr"/>
-            <a:r>
-              <a:rPr sz="1100" b="1">
-                <a:solidFill>
-                  <a:srgbClr val="FFFFFF"/>
-                </a:solidFill>
-                <a:latin typeface="Calibri"/>
-              </a:rPr>
-              <a:t>1</a:t>
-            </a:r>
-          </a:p>
-        </p:txBody>
-      </p:sp>
-      <p:sp>
-        <p:nvSpPr>
-          <p:cNvPr id="18" name="TextBox 17"/>
-          <p:cNvSpPr txBox="1"/>
-          <p:nvPr/>
-        </p:nvSpPr>
-        <p:spPr>
-          <a:xfrm>
-            <a:off x="822960" y="1975104"/>
-            <a:ext cx="1536192" cy="512064"/>
-          </a:xfrm>
-          <a:prstGeom prst="rect">
-            <a:avLst/>
-          </a:prstGeom>
-          <a:noFill/>
-        </p:spPr>
-        <p:txBody>
-          <a:bodyPr wrap="square" anchor="t"/>
-          <a:lstStyle/>
-          <a:p>
-            <a:pPr algn="l"/>
-            <a:r>
-              <a:rPr sz="1400" b="1">
-                <a:solidFill>
-                  <a:srgbClr val="26303A"/>
-                </a:solidFill>
-                <a:latin typeface="Calibri"/>
-              </a:rPr>
-              <a:t>End to End Agentic Orchestration</a:t>
-            </a:r>
-          </a:p>
-        </p:txBody>
-      </p:sp>
-      <p:sp>
-        <p:nvSpPr>
-          <p:cNvPr id="19" name="TextBox 18"/>
-          <p:cNvSpPr txBox="1"/>
-          <p:nvPr/>
-        </p:nvSpPr>
-        <p:spPr>
-          <a:xfrm>
-            <a:off x="2450592" y="1865376"/>
-            <a:ext cx="960120" cy="292608"/>
-          </a:xfrm>
-          <a:prstGeom prst="rect">
-            <a:avLst/>
-          </a:prstGeom>
-          <a:noFill/>
-        </p:spPr>
-        <p:txBody>
-          <a:bodyPr wrap="square" anchor="t"/>
-          <a:lstStyle/>
-          <a:p>
-            <a:pPr algn="l"/>
-            <a:r>
-              <a:rPr sz="1200" b="1">
-                <a:solidFill>
-                  <a:srgbClr val="0A5F59"/>
-                </a:solidFill>
-                <a:latin typeface="Calibri"/>
-              </a:rPr>
-              <a:t>LEADERS</a:t>
-            </a:r>
-          </a:p>
-        </p:txBody>
-      </p:sp>
-      <p:sp>
-        <p:nvSpPr>
-          <p:cNvPr id="20" name="TextBox 19"/>
-          <p:cNvSpPr txBox="1"/>
-          <p:nvPr/>
-        </p:nvSpPr>
-        <p:spPr>
-          <a:xfrm>
-            <a:off x="3383280" y="1865376"/>
-            <a:ext cx="2194560" cy="292608"/>
-          </a:xfrm>
-          <a:prstGeom prst="rect">
-            <a:avLst/>
-          </a:prstGeom>
-          <a:noFill/>
-        </p:spPr>
-        <p:txBody>
-          <a:bodyPr wrap="square" anchor="t"/>
-          <a:lstStyle/>
-          <a:p>
-            <a:pPr algn="l"/>
-            <a:r>
-              <a:rPr sz="1400" b="0">
-                <a:solidFill>
-                  <a:srgbClr val="3A454F"/>
-                </a:solidFill>
-                <a:latin typeface="Calibri"/>
-              </a:rPr>
-              <a:t>Point tools stitched by IT.</a:t>
-            </a:r>
-          </a:p>
-        </p:txBody>
-      </p:sp>
-      <p:sp>
-        <p:nvSpPr>
-          <p:cNvPr id="21" name="Rounded Rectangle 20"/>
+          </a:p>
+        </p:txBody>
+      </p:sp>
+      <p:sp>
+        <p:nvSpPr>
+          <p:cNvPr id="22" name="Rounded Rectangle 21"/>
           <p:cNvSpPr/>
           <p:nvPr/>
         </p:nvSpPr>
         <p:spPr>
           <a:xfrm>
-            <a:off x="5632704" y="1920240"/>
-            <a:ext cx="868680" cy="128016"/>
+            <a:off x="7973568" y="1938528"/>
+            <a:ext cx="566928" cy="128016"/>
           </a:xfrm>
           <a:prstGeom prst="roundRect">
             <a:avLst>
@@ -7729,7 +7753,7 @@
             </a:avLst>
           </a:prstGeom>
           <a:solidFill>
-            <a:srgbClr val="EDF0F2"/>
+            <a:srgbClr val="D9982F"/>
           </a:solidFill>
           <a:ln>
             <a:noFill/>
@@ -7759,14 +7783,113 @@
       </p:sp>
       <p:sp>
         <p:nvSpPr>
-          <p:cNvPr id="22" name="Rounded Rectangle 21"/>
+          <p:cNvPr id="23" name="TextBox 22"/>
+          <p:cNvSpPr txBox="1"/>
+          <p:nvPr/>
+        </p:nvSpPr>
+        <p:spPr>
+          <a:xfrm>
+            <a:off x="2450592" y="2231136"/>
+            <a:ext cx="914400" cy="274320"/>
+          </a:xfrm>
+          <a:prstGeom prst="rect">
+            <a:avLst/>
+          </a:prstGeom>
+          <a:noFill/>
+        </p:spPr>
+        <p:txBody>
+          <a:bodyPr wrap="square" anchor="t"/>
+          <a:lstStyle/>
+          <a:p>
+            <a:pPr algn="l"/>
+            <a:r>
+              <a:rPr sz="1100" b="1">
+                <a:solidFill>
+                  <a:srgbClr val="9AA3AC"/>
+                </a:solidFill>
+                <a:latin typeface="Calibri"/>
+              </a:rPr>
+              <a:t>DEVELOPING</a:t>
+            </a:r>
+          </a:p>
+        </p:txBody>
+      </p:sp>
+      <p:sp>
+        <p:nvSpPr>
+          <p:cNvPr id="24" name="TextBox 23"/>
+          <p:cNvSpPr txBox="1"/>
+          <p:nvPr/>
+        </p:nvSpPr>
+        <p:spPr>
+          <a:xfrm>
+            <a:off x="3383280" y="2231136"/>
+            <a:ext cx="3703320" cy="329184"/>
+          </a:xfrm>
+          <a:prstGeom prst="rect">
+            <a:avLst/>
+          </a:prstGeom>
+          <a:noFill/>
+        </p:spPr>
+        <p:txBody>
+          <a:bodyPr wrap="square" anchor="t"/>
+          <a:lstStyle/>
+          <a:p>
+            <a:pPr algn="l"/>
+            <a:r>
+              <a:rPr sz="1200" b="0">
+                <a:solidFill>
+                  <a:srgbClr val="3A454F"/>
+                </a:solidFill>
+                <a:latin typeface="Calibri"/>
+              </a:rPr>
+              <a:t>No end-to-end tracking, only e-mails, Excels and random SharePoints</a:t>
+            </a:r>
+          </a:p>
+        </p:txBody>
+      </p:sp>
+      <p:sp>
+        <p:nvSpPr>
+          <p:cNvPr id="25" name="TextBox 24"/>
+          <p:cNvSpPr txBox="1"/>
+          <p:nvPr/>
+        </p:nvSpPr>
+        <p:spPr>
+          <a:xfrm>
+            <a:off x="7114032" y="2231136"/>
+            <a:ext cx="777240" cy="274320"/>
+          </a:xfrm>
+          <a:prstGeom prst="rect">
+            <a:avLst/>
+          </a:prstGeom>
+          <a:noFill/>
+        </p:spPr>
+        <p:txBody>
+          <a:bodyPr wrap="square" anchor="t"/>
+          <a:lstStyle/>
+          <a:p>
+            <a:pPr algn="r"/>
+            <a:r>
+              <a:rPr sz="1100" b="1">
+                <a:solidFill>
+                  <a:srgbClr val="A8392C"/>
+                </a:solidFill>
+                <a:latin typeface="Calibri"/>
+              </a:rPr>
+              <a:t>HIGH</a:t>
+            </a:r>
+          </a:p>
+        </p:txBody>
+      </p:sp>
+      <p:sp>
+        <p:nvSpPr>
+          <p:cNvPr id="26" name="Rounded Rectangle 25"/>
           <p:cNvSpPr/>
           <p:nvPr/>
         </p:nvSpPr>
         <p:spPr>
           <a:xfrm>
-            <a:off x="5632704" y="1920240"/>
-            <a:ext cx="660196" cy="128016"/>
+            <a:off x="7973568" y="2304288"/>
+            <a:ext cx="914400" cy="128016"/>
           </a:xfrm>
           <a:prstGeom prst="roundRect">
             <a:avLst>
@@ -7774,7 +7897,7 @@
             </a:avLst>
           </a:prstGeom>
           <a:solidFill>
-            <a:srgbClr val="D9982F"/>
+            <a:srgbClr val="EDF0F2"/>
           </a:solidFill>
           <a:ln>
             <a:noFill/>
@@ -7804,80 +7927,14 @@
       </p:sp>
       <p:sp>
         <p:nvSpPr>
-          <p:cNvPr id="23" name="TextBox 22"/>
-          <p:cNvSpPr txBox="1"/>
-          <p:nvPr/>
-        </p:nvSpPr>
-        <p:spPr>
-          <a:xfrm>
-            <a:off x="2450592" y="2231136"/>
-            <a:ext cx="960120" cy="292608"/>
-          </a:xfrm>
-          <a:prstGeom prst="rect">
-            <a:avLst/>
-          </a:prstGeom>
-          <a:noFill/>
-        </p:spPr>
-        <p:txBody>
-          <a:bodyPr wrap="square" anchor="t"/>
-          <a:lstStyle/>
-          <a:p>
-            <a:pPr algn="l"/>
-            <a:r>
-              <a:rPr sz="1200" b="1">
-                <a:solidFill>
-                  <a:srgbClr val="9AA3AC"/>
-                </a:solidFill>
-                <a:latin typeface="Calibri"/>
-              </a:rPr>
-              <a:t>DEVELOPING</a:t>
-            </a:r>
-          </a:p>
-        </p:txBody>
-      </p:sp>
-      <p:sp>
-        <p:nvSpPr>
-          <p:cNvPr id="24" name="TextBox 23"/>
-          <p:cNvSpPr txBox="1"/>
-          <p:nvPr/>
-        </p:nvSpPr>
-        <p:spPr>
-          <a:xfrm>
-            <a:off x="3383280" y="2231136"/>
-            <a:ext cx="2194560" cy="292608"/>
-          </a:xfrm>
-          <a:prstGeom prst="rect">
-            <a:avLst/>
-          </a:prstGeom>
-          <a:noFill/>
-        </p:spPr>
-        <p:txBody>
-          <a:bodyPr wrap="square" anchor="t"/>
-          <a:lstStyle/>
-          <a:p>
-            <a:pPr algn="l"/>
-            <a:r>
-              <a:rPr sz="1400" b="0">
-                <a:solidFill>
-                  <a:srgbClr val="3A454F"/>
-                </a:solidFill>
-                <a:latin typeface="Calibri"/>
-              </a:rPr>
-              <a:t>Isolated stages, email only.</a:t>
-            </a:r>
-          </a:p>
-        </p:txBody>
-      </p:sp>
-      <p:sp>
-        <p:nvSpPr>
-          <p:cNvPr id="25" name="Rounded Rectangle 24"/>
+          <p:cNvPr id="27" name="Rounded Rectangle 26"/>
           <p:cNvSpPr/>
           <p:nvPr/>
         </p:nvSpPr>
         <p:spPr>
           <a:xfrm>
-            <a:off x="5632704" y="2286000"/>
-            <a:ext cx="868680" cy="128016"/>
+            <a:off x="7973568" y="2304288"/>
+            <a:ext cx="841248" cy="128016"/>
           </a:xfrm>
           <a:prstGeom prst="roundRect">
             <a:avLst>
@@ -7885,7 +7942,7 @@
             </a:avLst>
           </a:prstGeom>
           <a:solidFill>
-            <a:srgbClr val="EDF0F2"/>
+            <a:srgbClr val="C0453B"/>
           </a:solidFill>
           <a:ln>
             <a:noFill/>
@@ -7915,22 +7972,22 @@
       </p:sp>
       <p:sp>
         <p:nvSpPr>
-          <p:cNvPr id="26" name="Rounded Rectangle 25"/>
+          <p:cNvPr id="28" name="Rounded Rectangle 27"/>
           <p:cNvSpPr/>
           <p:nvPr/>
         </p:nvSpPr>
         <p:spPr>
           <a:xfrm>
-            <a:off x="5632704" y="2286000"/>
-            <a:ext cx="833932" cy="128016"/>
+            <a:off x="9098280" y="1865376"/>
+            <a:ext cx="2706624" cy="658368"/>
           </a:xfrm>
           <a:prstGeom prst="roundRect">
             <a:avLst>
-              <a:gd name="adj" fmla="val 50000"/>
+              <a:gd name="adj" fmla="val 4000"/>
             </a:avLst>
           </a:prstGeom>
           <a:solidFill>
-            <a:srgbClr val="C0453B"/>
+            <a:srgbClr val="E4F1EF"/>
           </a:solidFill>
           <a:ln>
             <a:noFill/>
@@ -7951,64 +8008,38 @@
           </a:fontRef>
         </p:style>
         <p:txBody>
-          <a:bodyPr rtlCol="0" anchor="ctr"/>
-          <a:lstStyle/>
-          <a:p>
-            <a:pPr algn="ctr"/>
-          </a:p>
-        </p:txBody>
-      </p:sp>
-      <p:sp>
-        <p:nvSpPr>
-          <p:cNvPr id="27" name="TextBox 26"/>
-          <p:cNvSpPr txBox="1"/>
-          <p:nvPr/>
-        </p:nvSpPr>
-        <p:spPr>
-          <a:xfrm>
-            <a:off x="6693408" y="1956816"/>
-            <a:ext cx="2267712" cy="530352"/>
-          </a:xfrm>
-          <a:prstGeom prst="rect">
-            <a:avLst/>
-          </a:prstGeom>
-          <a:noFill/>
-        </p:spPr>
-        <p:txBody>
-          <a:bodyPr wrap="square" anchor="t"/>
+          <a:bodyPr rtlCol="0" anchor="ctr" wrap="square" lIns="73152" rIns="73152" tIns="36576" bIns="36576"/>
           <a:lstStyle/>
           <a:p>
             <a:pPr algn="l"/>
             <a:r>
-              <a:rPr sz="1400" b="0">
-                <a:solidFill>
-                  <a:srgbClr val="26303A"/>
-                </a:solidFill>
-                <a:latin typeface="Calibri"/>
-              </a:rPr>
-              <a:t>Nothing learns from the last project.</a:t>
-            </a:r>
-          </a:p>
-        </p:txBody>
-      </p:sp>
-      <p:sp>
-        <p:nvSpPr>
-          <p:cNvPr id="28" name="Rounded Rectangle 27"/>
+              <a:rPr sz="1200" b="1">
+                <a:solidFill>
+                  <a:srgbClr val="0A5F59"/>
+                </a:solidFill>
+                <a:latin typeface="Calibri"/>
+              </a:rPr>
+              <a:t>One governed agentic layer across every stage, smarter with each project</a:t>
+            </a:r>
+          </a:p>
+        </p:txBody>
+      </p:sp>
+      <p:sp>
+        <p:nvSpPr>
+          <p:cNvPr id="29" name="Rectangle 28"/>
           <p:cNvSpPr/>
           <p:nvPr/>
         </p:nvSpPr>
         <p:spPr>
           <a:xfrm>
-            <a:off x="9061704" y="1883664"/>
-            <a:ext cx="2743200" cy="640080"/>
-          </a:xfrm>
-          <a:prstGeom prst="roundRect">
-            <a:avLst>
-              <a:gd name="adj" fmla="val 4000"/>
-            </a:avLst>
-          </a:prstGeom>
-          <a:solidFill>
-            <a:srgbClr val="E4F1EF"/>
+            <a:off x="384048" y="3374136"/>
+            <a:ext cx="11420856" cy="9144"/>
+          </a:xfrm>
+          <a:prstGeom prst="rect">
+            <a:avLst/>
+          </a:prstGeom>
+          <a:solidFill>
+            <a:srgbClr val="E3E8E9"/>
           </a:solidFill>
           <a:ln>
             <a:noFill/>
@@ -8029,38 +8060,29 @@
           </a:fontRef>
         </p:style>
         <p:txBody>
-          <a:bodyPr rtlCol="0" anchor="ctr" wrap="square" lIns="73152" rIns="73152" tIns="36576" bIns="36576"/>
-          <a:lstStyle/>
-          <a:p>
-            <a:pPr algn="l"/>
-            <a:r>
-              <a:rPr sz="1400" b="1">
-                <a:solidFill>
-                  <a:srgbClr val="0A5F59"/>
-                </a:solidFill>
-                <a:latin typeface="Calibri"/>
-              </a:rPr>
-              <a:t>One governed agentic layer across every stage, smarter with each project.</a:t>
-            </a:r>
-          </a:p>
-        </p:txBody>
-      </p:sp>
-      <p:sp>
-        <p:nvSpPr>
-          <p:cNvPr id="29" name="Rectangle 28"/>
+          <a:bodyPr rtlCol="0" anchor="ctr"/>
+          <a:lstStyle/>
+          <a:p>
+            <a:pPr algn="ctr"/>
+          </a:p>
+        </p:txBody>
+      </p:sp>
+      <p:sp>
+        <p:nvSpPr>
+          <p:cNvPr id="30" name="Oval 29"/>
           <p:cNvSpPr/>
           <p:nvPr/>
         </p:nvSpPr>
         <p:spPr>
           <a:xfrm>
-            <a:off x="384048" y="3374136"/>
-            <a:ext cx="11420856" cy="9144"/>
-          </a:xfrm>
-          <a:prstGeom prst="rect">
-            <a:avLst/>
-          </a:prstGeom>
-          <a:solidFill>
-            <a:srgbClr val="E3E8E9"/>
+            <a:off x="457200" y="2834640"/>
+            <a:ext cx="292608" cy="292608"/>
+          </a:xfrm>
+          <a:prstGeom prst="ellipse">
+            <a:avLst/>
+          </a:prstGeom>
+          <a:solidFill>
+            <a:srgbClr val="0B7F77"/>
           </a:solidFill>
           <a:ln>
             <a:noFill/>
@@ -8081,29 +8103,172 @@
           </a:fontRef>
         </p:style>
         <p:txBody>
-          <a:bodyPr rtlCol="0" anchor="ctr"/>
+          <a:bodyPr rtlCol="0" anchor="ctr" wrap="none"/>
           <a:lstStyle/>
           <a:p>
             <a:pPr algn="ctr"/>
-          </a:p>
-        </p:txBody>
-      </p:sp>
-      <p:sp>
-        <p:nvSpPr>
-          <p:cNvPr id="30" name="Oval 29"/>
+            <a:r>
+              <a:rPr sz="1100" b="1">
+                <a:solidFill>
+                  <a:srgbClr val="FFFFFF"/>
+                </a:solidFill>
+                <a:latin typeface="Calibri"/>
+              </a:rPr>
+              <a:t>2</a:t>
+            </a:r>
+          </a:p>
+        </p:txBody>
+      </p:sp>
+      <p:sp>
+        <p:nvSpPr>
+          <p:cNvPr id="31" name="TextBox 30"/>
+          <p:cNvSpPr txBox="1"/>
+          <p:nvPr/>
+        </p:nvSpPr>
+        <p:spPr>
+          <a:xfrm>
+            <a:off x="822960" y="2761488"/>
+            <a:ext cx="1536192" cy="512064"/>
+          </a:xfrm>
+          <a:prstGeom prst="rect">
+            <a:avLst/>
+          </a:prstGeom>
+          <a:noFill/>
+        </p:spPr>
+        <p:txBody>
+          <a:bodyPr wrap="square" anchor="t"/>
+          <a:lstStyle/>
+          <a:p>
+            <a:pPr algn="l"/>
+            <a:r>
+              <a:rPr sz="1300" b="1">
+                <a:solidFill>
+                  <a:srgbClr val="26303A"/>
+                </a:solidFill>
+                <a:latin typeface="Calibri"/>
+              </a:rPr>
+              <a:t>AI Generated Unified BoQ</a:t>
+            </a:r>
+          </a:p>
+        </p:txBody>
+      </p:sp>
+      <p:sp>
+        <p:nvSpPr>
+          <p:cNvPr id="32" name="TextBox 31"/>
+          <p:cNvSpPr txBox="1"/>
+          <p:nvPr/>
+        </p:nvSpPr>
+        <p:spPr>
+          <a:xfrm>
+            <a:off x="2450592" y="2651760"/>
+            <a:ext cx="914400" cy="274320"/>
+          </a:xfrm>
+          <a:prstGeom prst="rect">
+            <a:avLst/>
+          </a:prstGeom>
+          <a:noFill/>
+        </p:spPr>
+        <p:txBody>
+          <a:bodyPr wrap="square" anchor="t"/>
+          <a:lstStyle/>
+          <a:p>
+            <a:pPr algn="l"/>
+            <a:r>
+              <a:rPr sz="1100" b="1">
+                <a:solidFill>
+                  <a:srgbClr val="0A5F59"/>
+                </a:solidFill>
+                <a:latin typeface="Calibri"/>
+              </a:rPr>
+              <a:t>LEADERS</a:t>
+            </a:r>
+          </a:p>
+        </p:txBody>
+      </p:sp>
+      <p:sp>
+        <p:nvSpPr>
+          <p:cNvPr id="33" name="TextBox 32"/>
+          <p:cNvSpPr txBox="1"/>
+          <p:nvPr/>
+        </p:nvSpPr>
+        <p:spPr>
+          <a:xfrm>
+            <a:off x="3383280" y="2651760"/>
+            <a:ext cx="3703320" cy="329184"/>
+          </a:xfrm>
+          <a:prstGeom prst="rect">
+            <a:avLst/>
+          </a:prstGeom>
+          <a:noFill/>
+        </p:spPr>
+        <p:txBody>
+          <a:bodyPr wrap="square" anchor="t"/>
+          <a:lstStyle/>
+          <a:p>
+            <a:pPr algn="l"/>
+            <a:r>
+              <a:rPr sz="1200" b="0">
+                <a:solidFill>
+                  <a:srgbClr val="3A454F"/>
+                </a:solidFill>
+                <a:latin typeface="Calibri"/>
+              </a:rPr>
+              <a:t>Unified BoQ exists, but not always at spec level and manually maintained</a:t>
+            </a:r>
+          </a:p>
+        </p:txBody>
+      </p:sp>
+      <p:sp>
+        <p:nvSpPr>
+          <p:cNvPr id="34" name="TextBox 33"/>
+          <p:cNvSpPr txBox="1"/>
+          <p:nvPr/>
+        </p:nvSpPr>
+        <p:spPr>
+          <a:xfrm>
+            <a:off x="7114032" y="2651760"/>
+            <a:ext cx="777240" cy="274320"/>
+          </a:xfrm>
+          <a:prstGeom prst="rect">
+            <a:avLst/>
+          </a:prstGeom>
+          <a:noFill/>
+        </p:spPr>
+        <p:txBody>
+          <a:bodyPr wrap="square" anchor="t"/>
+          <a:lstStyle/>
+          <a:p>
+            <a:pPr algn="r"/>
+            <a:r>
+              <a:rPr sz="1100" b="1">
+                <a:solidFill>
+                  <a:srgbClr val="A8392C"/>
+                </a:solidFill>
+                <a:latin typeface="Calibri"/>
+              </a:rPr>
+              <a:t>HIGH</a:t>
+            </a:r>
+          </a:p>
+        </p:txBody>
+      </p:sp>
+      <p:sp>
+        <p:nvSpPr>
+          <p:cNvPr id="35" name="Rounded Rectangle 34"/>
           <p:cNvSpPr/>
           <p:nvPr/>
         </p:nvSpPr>
         <p:spPr>
           <a:xfrm>
-            <a:off x="457200" y="2834640"/>
-            <a:ext cx="292608" cy="292608"/>
-          </a:xfrm>
-          <a:prstGeom prst="ellipse">
-            <a:avLst/>
-          </a:prstGeom>
-          <a:solidFill>
-            <a:srgbClr val="0B7F77"/>
+            <a:off x="7973568" y="2724912"/>
+            <a:ext cx="914400" cy="128016"/>
+          </a:xfrm>
+          <a:prstGeom prst="roundRect">
+            <a:avLst>
+              <a:gd name="adj" fmla="val 50000"/>
+            </a:avLst>
+          </a:prstGeom>
+          <a:solidFill>
+            <a:srgbClr val="EDF0F2"/>
           </a:solidFill>
           <a:ln>
             <a:noFill/>
@@ -8124,131 +8289,23 @@
           </a:fontRef>
         </p:style>
         <p:txBody>
-          <a:bodyPr rtlCol="0" anchor="ctr" wrap="none"/>
+          <a:bodyPr rtlCol="0" anchor="ctr"/>
           <a:lstStyle/>
           <a:p>
             <a:pPr algn="ctr"/>
-            <a:r>
-              <a:rPr sz="1100" b="1">
-                <a:solidFill>
-                  <a:srgbClr val="FFFFFF"/>
-                </a:solidFill>
-                <a:latin typeface="Calibri"/>
-              </a:rPr>
-              <a:t>2</a:t>
-            </a:r>
-          </a:p>
-        </p:txBody>
-      </p:sp>
-      <p:sp>
-        <p:nvSpPr>
-          <p:cNvPr id="31" name="TextBox 30"/>
-          <p:cNvSpPr txBox="1"/>
-          <p:nvPr/>
-        </p:nvSpPr>
-        <p:spPr>
-          <a:xfrm>
-            <a:off x="822960" y="2761488"/>
-            <a:ext cx="1536192" cy="512064"/>
-          </a:xfrm>
-          <a:prstGeom prst="rect">
-            <a:avLst/>
-          </a:prstGeom>
-          <a:noFill/>
-        </p:spPr>
-        <p:txBody>
-          <a:bodyPr wrap="square" anchor="t"/>
-          <a:lstStyle/>
-          <a:p>
-            <a:pPr algn="l"/>
-            <a:r>
-              <a:rPr sz="1400" b="1">
-                <a:solidFill>
-                  <a:srgbClr val="26303A"/>
-                </a:solidFill>
-                <a:latin typeface="Calibri"/>
-              </a:rPr>
-              <a:t>AI Generated Unified BoQ</a:t>
-            </a:r>
-          </a:p>
-        </p:txBody>
-      </p:sp>
-      <p:sp>
-        <p:nvSpPr>
-          <p:cNvPr id="32" name="TextBox 31"/>
-          <p:cNvSpPr txBox="1"/>
-          <p:nvPr/>
-        </p:nvSpPr>
-        <p:spPr>
-          <a:xfrm>
-            <a:off x="2450592" y="2651760"/>
-            <a:ext cx="960120" cy="292608"/>
-          </a:xfrm>
-          <a:prstGeom prst="rect">
-            <a:avLst/>
-          </a:prstGeom>
-          <a:noFill/>
-        </p:spPr>
-        <p:txBody>
-          <a:bodyPr wrap="square" anchor="t"/>
-          <a:lstStyle/>
-          <a:p>
-            <a:pPr algn="l"/>
-            <a:r>
-              <a:rPr sz="1200" b="1">
-                <a:solidFill>
-                  <a:srgbClr val="0A5F59"/>
-                </a:solidFill>
-                <a:latin typeface="Calibri"/>
-              </a:rPr>
-              <a:t>LEADERS</a:t>
-            </a:r>
-          </a:p>
-        </p:txBody>
-      </p:sp>
-      <p:sp>
-        <p:nvSpPr>
-          <p:cNvPr id="33" name="TextBox 32"/>
-          <p:cNvSpPr txBox="1"/>
-          <p:nvPr/>
-        </p:nvSpPr>
-        <p:spPr>
-          <a:xfrm>
-            <a:off x="3383280" y="2651760"/>
-            <a:ext cx="2194560" cy="292608"/>
-          </a:xfrm>
-          <a:prstGeom prst="rect">
-            <a:avLst/>
-          </a:prstGeom>
-          <a:noFill/>
-        </p:spPr>
-        <p:txBody>
-          <a:bodyPr wrap="square" anchor="t"/>
-          <a:lstStyle/>
-          <a:p>
-            <a:pPr algn="l"/>
-            <a:r>
-              <a:rPr sz="1400" b="0">
-                <a:solidFill>
-                  <a:srgbClr val="3A454F"/>
-                </a:solidFill>
-                <a:latin typeface="Calibri"/>
-              </a:rPr>
-              <a:t>In-house coding, kept by hand.</a:t>
-            </a:r>
-          </a:p>
-        </p:txBody>
-      </p:sp>
-      <p:sp>
-        <p:nvSpPr>
-          <p:cNvPr id="34" name="Rounded Rectangle 33"/>
+          </a:p>
+        </p:txBody>
+      </p:sp>
+      <p:sp>
+        <p:nvSpPr>
+          <p:cNvPr id="36" name="Rounded Rectangle 35"/>
           <p:cNvSpPr/>
           <p:nvPr/>
         </p:nvSpPr>
         <p:spPr>
           <a:xfrm>
-            <a:off x="5632704" y="2706624"/>
-            <a:ext cx="868680" cy="128016"/>
+            <a:off x="7973568" y="2724912"/>
+            <a:ext cx="841248" cy="128016"/>
           </a:xfrm>
           <a:prstGeom prst="roundRect">
             <a:avLst>
@@ -8256,7 +8313,7 @@
             </a:avLst>
           </a:prstGeom>
           <a:solidFill>
-            <a:srgbClr val="EDF0F2"/>
+            <a:srgbClr val="C0453B"/>
           </a:solidFill>
           <a:ln>
             <a:noFill/>
@@ -8286,14 +8343,113 @@
       </p:sp>
       <p:sp>
         <p:nvSpPr>
-          <p:cNvPr id="35" name="Rounded Rectangle 34"/>
+          <p:cNvPr id="37" name="TextBox 36"/>
+          <p:cNvSpPr txBox="1"/>
+          <p:nvPr/>
+        </p:nvSpPr>
+        <p:spPr>
+          <a:xfrm>
+            <a:off x="2450592" y="3017520"/>
+            <a:ext cx="914400" cy="274320"/>
+          </a:xfrm>
+          <a:prstGeom prst="rect">
+            <a:avLst/>
+          </a:prstGeom>
+          <a:noFill/>
+        </p:spPr>
+        <p:txBody>
+          <a:bodyPr wrap="square" anchor="t"/>
+          <a:lstStyle/>
+          <a:p>
+            <a:pPr algn="l"/>
+            <a:r>
+              <a:rPr sz="1100" b="1">
+                <a:solidFill>
+                  <a:srgbClr val="9AA3AC"/>
+                </a:solidFill>
+                <a:latin typeface="Calibri"/>
+              </a:rPr>
+              <a:t>DEVELOPING</a:t>
+            </a:r>
+          </a:p>
+        </p:txBody>
+      </p:sp>
+      <p:sp>
+        <p:nvSpPr>
+          <p:cNvPr id="38" name="TextBox 37"/>
+          <p:cNvSpPr txBox="1"/>
+          <p:nvPr/>
+        </p:nvSpPr>
+        <p:spPr>
+          <a:xfrm>
+            <a:off x="3383280" y="3017520"/>
+            <a:ext cx="3703320" cy="329184"/>
+          </a:xfrm>
+          <a:prstGeom prst="rect">
+            <a:avLst/>
+          </a:prstGeom>
+          <a:noFill/>
+        </p:spPr>
+        <p:txBody>
+          <a:bodyPr wrap="square" anchor="t"/>
+          <a:lstStyle/>
+          <a:p>
+            <a:pPr algn="l"/>
+            <a:r>
+              <a:rPr sz="1200" b="0">
+                <a:solidFill>
+                  <a:srgbClr val="3A454F"/>
+                </a:solidFill>
+                <a:latin typeface="Calibri"/>
+              </a:rPr>
+              <a:t>Only standardization in WBS, but near-zero at BoQ level</a:t>
+            </a:r>
+          </a:p>
+        </p:txBody>
+      </p:sp>
+      <p:sp>
+        <p:nvSpPr>
+          <p:cNvPr id="39" name="TextBox 38"/>
+          <p:cNvSpPr txBox="1"/>
+          <p:nvPr/>
+        </p:nvSpPr>
+        <p:spPr>
+          <a:xfrm>
+            <a:off x="7114032" y="3017520"/>
+            <a:ext cx="777240" cy="274320"/>
+          </a:xfrm>
+          <a:prstGeom prst="rect">
+            <a:avLst/>
+          </a:prstGeom>
+          <a:noFill/>
+        </p:spPr>
+        <p:txBody>
+          <a:bodyPr wrap="square" anchor="t"/>
+          <a:lstStyle/>
+          <a:p>
+            <a:pPr algn="r"/>
+            <a:r>
+              <a:rPr sz="1100" b="1">
+                <a:solidFill>
+                  <a:srgbClr val="A8392C"/>
+                </a:solidFill>
+                <a:latin typeface="Calibri"/>
+              </a:rPr>
+              <a:t>HIGH</a:t>
+            </a:r>
+          </a:p>
+        </p:txBody>
+      </p:sp>
+      <p:sp>
+        <p:nvSpPr>
+          <p:cNvPr id="40" name="Rounded Rectangle 39"/>
           <p:cNvSpPr/>
           <p:nvPr/>
         </p:nvSpPr>
         <p:spPr>
           <a:xfrm>
-            <a:off x="5632704" y="2706624"/>
-            <a:ext cx="625449" cy="128016"/>
+            <a:off x="7973568" y="3090672"/>
+            <a:ext cx="914400" cy="128016"/>
           </a:xfrm>
           <a:prstGeom prst="roundRect">
             <a:avLst>
@@ -8301,7 +8457,7 @@
             </a:avLst>
           </a:prstGeom>
           <a:solidFill>
-            <a:srgbClr val="D9982F"/>
+            <a:srgbClr val="EDF0F2"/>
           </a:solidFill>
           <a:ln>
             <a:noFill/>
@@ -8331,80 +8487,14 @@
       </p:sp>
       <p:sp>
         <p:nvSpPr>
-          <p:cNvPr id="36" name="TextBox 35"/>
-          <p:cNvSpPr txBox="1"/>
-          <p:nvPr/>
-        </p:nvSpPr>
-        <p:spPr>
-          <a:xfrm>
-            <a:off x="2450592" y="3017520"/>
-            <a:ext cx="960120" cy="292608"/>
-          </a:xfrm>
-          <a:prstGeom prst="rect">
-            <a:avLst/>
-          </a:prstGeom>
-          <a:noFill/>
-        </p:spPr>
-        <p:txBody>
-          <a:bodyPr wrap="square" anchor="t"/>
-          <a:lstStyle/>
-          <a:p>
-            <a:pPr algn="l"/>
-            <a:r>
-              <a:rPr sz="1200" b="1">
-                <a:solidFill>
-                  <a:srgbClr val="9AA3AC"/>
-                </a:solidFill>
-                <a:latin typeface="Calibri"/>
-              </a:rPr>
-              <a:t>DEVELOPING</a:t>
-            </a:r>
-          </a:p>
-        </p:txBody>
-      </p:sp>
-      <p:sp>
-        <p:nvSpPr>
-          <p:cNvPr id="37" name="TextBox 36"/>
-          <p:cNvSpPr txBox="1"/>
-          <p:nvPr/>
-        </p:nvSpPr>
-        <p:spPr>
-          <a:xfrm>
-            <a:off x="3383280" y="3017520"/>
-            <a:ext cx="2194560" cy="292608"/>
-          </a:xfrm>
-          <a:prstGeom prst="rect">
-            <a:avLst/>
-          </a:prstGeom>
-          <a:noFill/>
-        </p:spPr>
-        <p:txBody>
-          <a:bodyPr wrap="square" anchor="t"/>
-          <a:lstStyle/>
-          <a:p>
-            <a:pPr algn="l"/>
-            <a:r>
-              <a:rPr sz="1400" b="0">
-                <a:solidFill>
-                  <a:srgbClr val="3A454F"/>
-                </a:solidFill>
-                <a:latin typeface="Calibri"/>
-              </a:rPr>
-              <a:t>Cost items as free text.</a:t>
-            </a:r>
-          </a:p>
-        </p:txBody>
-      </p:sp>
-      <p:sp>
-        <p:nvSpPr>
-          <p:cNvPr id="38" name="Rounded Rectangle 37"/>
+          <p:cNvPr id="41" name="Rounded Rectangle 40"/>
           <p:cNvSpPr/>
           <p:nvPr/>
         </p:nvSpPr>
         <p:spPr>
           <a:xfrm>
-            <a:off x="5632704" y="3072384"/>
-            <a:ext cx="868680" cy="128016"/>
+            <a:off x="7973568" y="3090672"/>
+            <a:ext cx="841248" cy="128016"/>
           </a:xfrm>
           <a:prstGeom prst="roundRect">
             <a:avLst>
@@ -8412,7 +8502,7 @@
             </a:avLst>
           </a:prstGeom>
           <a:solidFill>
-            <a:srgbClr val="EDF0F2"/>
+            <a:srgbClr val="C0453B"/>
           </a:solidFill>
           <a:ln>
             <a:noFill/>
@@ -8442,22 +8532,22 @@
       </p:sp>
       <p:sp>
         <p:nvSpPr>
-          <p:cNvPr id="39" name="Rounded Rectangle 38"/>
+          <p:cNvPr id="42" name="Rounded Rectangle 41"/>
           <p:cNvSpPr/>
           <p:nvPr/>
         </p:nvSpPr>
         <p:spPr>
           <a:xfrm>
-            <a:off x="5632704" y="3072384"/>
-            <a:ext cx="799185" cy="128016"/>
+            <a:off x="9098280" y="2651760"/>
+            <a:ext cx="2706624" cy="658368"/>
           </a:xfrm>
           <a:prstGeom prst="roundRect">
             <a:avLst>
-              <a:gd name="adj" fmla="val 50000"/>
+              <a:gd name="adj" fmla="val 4000"/>
             </a:avLst>
           </a:prstGeom>
           <a:solidFill>
-            <a:srgbClr val="C0453B"/>
+            <a:srgbClr val="E4F1EF"/>
           </a:solidFill>
           <a:ln>
             <a:noFill/>
@@ -8478,64 +8568,38 @@
           </a:fontRef>
         </p:style>
         <p:txBody>
-          <a:bodyPr rtlCol="0" anchor="ctr"/>
-          <a:lstStyle/>
-          <a:p>
-            <a:pPr algn="ctr"/>
-          </a:p>
-        </p:txBody>
-      </p:sp>
-      <p:sp>
-        <p:nvSpPr>
-          <p:cNvPr id="40" name="TextBox 39"/>
-          <p:cNvSpPr txBox="1"/>
-          <p:nvPr/>
-        </p:nvSpPr>
-        <p:spPr>
-          <a:xfrm>
-            <a:off x="6693408" y="2743200"/>
-            <a:ext cx="2267712" cy="530352"/>
-          </a:xfrm>
-          <a:prstGeom prst="rect">
-            <a:avLst/>
-          </a:prstGeom>
-          <a:noFill/>
-        </p:spPr>
-        <p:txBody>
-          <a:bodyPr wrap="square" anchor="t"/>
+          <a:bodyPr rtlCol="0" anchor="ctr" wrap="square" lIns="73152" rIns="73152" tIns="36576" bIns="36576"/>
           <a:lstStyle/>
           <a:p>
             <a:pPr algn="l"/>
             <a:r>
-              <a:rPr sz="1400" b="0">
-                <a:solidFill>
-                  <a:srgbClr val="26303A"/>
-                </a:solidFill>
-                <a:latin typeface="Calibri"/>
-              </a:rPr>
-              <a:t>No comparison across projects or bidders.</a:t>
-            </a:r>
-          </a:p>
-        </p:txBody>
-      </p:sp>
-      <p:sp>
-        <p:nvSpPr>
-          <p:cNvPr id="41" name="Rounded Rectangle 40"/>
+              <a:rPr sz="1200" b="1">
+                <a:solidFill>
+                  <a:srgbClr val="0A5F59"/>
+                </a:solidFill>
+                <a:latin typeface="Calibri"/>
+              </a:rPr>
+              <a:t>Using the client's own historical data, an AI gatekeeper maintains the structure</a:t>
+            </a:r>
+          </a:p>
+        </p:txBody>
+      </p:sp>
+      <p:sp>
+        <p:nvSpPr>
+          <p:cNvPr id="43" name="Rectangle 42"/>
           <p:cNvSpPr/>
           <p:nvPr/>
         </p:nvSpPr>
         <p:spPr>
           <a:xfrm>
-            <a:off x="9061704" y="2670048"/>
-            <a:ext cx="2743200" cy="640080"/>
-          </a:xfrm>
-          <a:prstGeom prst="roundRect">
-            <a:avLst>
-              <a:gd name="adj" fmla="val 4000"/>
-            </a:avLst>
-          </a:prstGeom>
-          <a:solidFill>
-            <a:srgbClr val="E4F1EF"/>
+            <a:off x="384048" y="4160520"/>
+            <a:ext cx="11420856" cy="9144"/>
+          </a:xfrm>
+          <a:prstGeom prst="rect">
+            <a:avLst/>
+          </a:prstGeom>
+          <a:solidFill>
+            <a:srgbClr val="E3E8E9"/>
           </a:solidFill>
           <a:ln>
             <a:noFill/>
@@ -8556,38 +8620,29 @@
           </a:fontRef>
         </p:style>
         <p:txBody>
-          <a:bodyPr rtlCol="0" anchor="ctr" wrap="square" lIns="73152" rIns="73152" tIns="36576" bIns="36576"/>
-          <a:lstStyle/>
-          <a:p>
-            <a:pPr algn="l"/>
-            <a:r>
-              <a:rPr sz="1400" b="1">
-                <a:solidFill>
-                  <a:srgbClr val="0A5F59"/>
-                </a:solidFill>
-                <a:latin typeface="Calibri"/>
-              </a:rPr>
-              <a:t>AI codes every item and maps any format into one standard BoQ.</a:t>
-            </a:r>
-          </a:p>
-        </p:txBody>
-      </p:sp>
-      <p:sp>
-        <p:nvSpPr>
-          <p:cNvPr id="42" name="Rectangle 41"/>
+          <a:bodyPr rtlCol="0" anchor="ctr"/>
+          <a:lstStyle/>
+          <a:p>
+            <a:pPr algn="ctr"/>
+          </a:p>
+        </p:txBody>
+      </p:sp>
+      <p:sp>
+        <p:nvSpPr>
+          <p:cNvPr id="44" name="Oval 43"/>
           <p:cNvSpPr/>
           <p:nvPr/>
         </p:nvSpPr>
         <p:spPr>
           <a:xfrm>
-            <a:off x="384048" y="4160520"/>
-            <a:ext cx="11420856" cy="9144"/>
-          </a:xfrm>
-          <a:prstGeom prst="rect">
-            <a:avLst/>
-          </a:prstGeom>
-          <a:solidFill>
-            <a:srgbClr val="E3E8E9"/>
+            <a:off x="457200" y="3621024"/>
+            <a:ext cx="292608" cy="292608"/>
+          </a:xfrm>
+          <a:prstGeom prst="ellipse">
+            <a:avLst/>
+          </a:prstGeom>
+          <a:solidFill>
+            <a:srgbClr val="0B7F77"/>
           </a:solidFill>
           <a:ln>
             <a:noFill/>
@@ -8608,29 +8663,172 @@
           </a:fontRef>
         </p:style>
         <p:txBody>
-          <a:bodyPr rtlCol="0" anchor="ctr"/>
+          <a:bodyPr rtlCol="0" anchor="ctr" wrap="none"/>
           <a:lstStyle/>
           <a:p>
             <a:pPr algn="ctr"/>
-          </a:p>
-        </p:txBody>
-      </p:sp>
-      <p:sp>
-        <p:nvSpPr>
-          <p:cNvPr id="43" name="Oval 42"/>
+            <a:r>
+              <a:rPr sz="1100" b="1">
+                <a:solidFill>
+                  <a:srgbClr val="FFFFFF"/>
+                </a:solidFill>
+                <a:latin typeface="Calibri"/>
+              </a:rPr>
+              <a:t>3</a:t>
+            </a:r>
+          </a:p>
+        </p:txBody>
+      </p:sp>
+      <p:sp>
+        <p:nvSpPr>
+          <p:cNvPr id="45" name="TextBox 44"/>
+          <p:cNvSpPr txBox="1"/>
+          <p:nvPr/>
+        </p:nvSpPr>
+        <p:spPr>
+          <a:xfrm>
+            <a:off x="822960" y="3547872"/>
+            <a:ext cx="1536192" cy="512064"/>
+          </a:xfrm>
+          <a:prstGeom prst="rect">
+            <a:avLst/>
+          </a:prstGeom>
+          <a:noFill/>
+        </p:spPr>
+        <p:txBody>
+          <a:bodyPr wrap="square" anchor="t"/>
+          <a:lstStyle/>
+          <a:p>
+            <a:pPr algn="l"/>
+            <a:r>
+              <a:rPr sz="1300" b="1">
+                <a:solidFill>
+                  <a:srgbClr val="26303A"/>
+                </a:solidFill>
+                <a:latin typeface="Calibri"/>
+              </a:rPr>
+              <a:t>Dynamic Bottom Up CAPEX</a:t>
+            </a:r>
+          </a:p>
+        </p:txBody>
+      </p:sp>
+      <p:sp>
+        <p:nvSpPr>
+          <p:cNvPr id="46" name="TextBox 45"/>
+          <p:cNvSpPr txBox="1"/>
+          <p:nvPr/>
+        </p:nvSpPr>
+        <p:spPr>
+          <a:xfrm>
+            <a:off x="2450592" y="3438144"/>
+            <a:ext cx="914400" cy="274320"/>
+          </a:xfrm>
+          <a:prstGeom prst="rect">
+            <a:avLst/>
+          </a:prstGeom>
+          <a:noFill/>
+        </p:spPr>
+        <p:txBody>
+          <a:bodyPr wrap="square" anchor="t"/>
+          <a:lstStyle/>
+          <a:p>
+            <a:pPr algn="l"/>
+            <a:r>
+              <a:rPr sz="1100" b="1">
+                <a:solidFill>
+                  <a:srgbClr val="0A5F59"/>
+                </a:solidFill>
+                <a:latin typeface="Calibri"/>
+              </a:rPr>
+              <a:t>LEADERS</a:t>
+            </a:r>
+          </a:p>
+        </p:txBody>
+      </p:sp>
+      <p:sp>
+        <p:nvSpPr>
+          <p:cNvPr id="47" name="TextBox 46"/>
+          <p:cNvSpPr txBox="1"/>
+          <p:nvPr/>
+        </p:nvSpPr>
+        <p:spPr>
+          <a:xfrm>
+            <a:off x="3383280" y="3438144"/>
+            <a:ext cx="3703320" cy="329184"/>
+          </a:xfrm>
+          <a:prstGeom prst="rect">
+            <a:avLst/>
+          </a:prstGeom>
+          <a:noFill/>
+        </p:spPr>
+        <p:txBody>
+          <a:bodyPr wrap="square" anchor="t"/>
+          <a:lstStyle/>
+          <a:p>
+            <a:pPr algn="l"/>
+            <a:r>
+              <a:rPr sz="1200" b="0">
+                <a:solidFill>
+                  <a:srgbClr val="3A454F"/>
+                </a:solidFill>
+                <a:latin typeface="Calibri"/>
+              </a:rPr>
+              <a:t>Dependent on expensive cost consultants or top-down estimation models</a:t>
+            </a:r>
+          </a:p>
+        </p:txBody>
+      </p:sp>
+      <p:sp>
+        <p:nvSpPr>
+          <p:cNvPr id="48" name="TextBox 47"/>
+          <p:cNvSpPr txBox="1"/>
+          <p:nvPr/>
+        </p:nvSpPr>
+        <p:spPr>
+          <a:xfrm>
+            <a:off x="7114032" y="3438144"/>
+            <a:ext cx="777240" cy="274320"/>
+          </a:xfrm>
+          <a:prstGeom prst="rect">
+            <a:avLst/>
+          </a:prstGeom>
+          <a:noFill/>
+        </p:spPr>
+        <p:txBody>
+          <a:bodyPr wrap="square" anchor="t"/>
+          <a:lstStyle/>
+          <a:p>
+            <a:pPr algn="r"/>
+            <a:r>
+              <a:rPr sz="1100" b="1">
+                <a:solidFill>
+                  <a:srgbClr val="5C6670"/>
+                </a:solidFill>
+                <a:latin typeface="Calibri"/>
+              </a:rPr>
+              <a:t>LOW</a:t>
+            </a:r>
+          </a:p>
+        </p:txBody>
+      </p:sp>
+      <p:sp>
+        <p:nvSpPr>
+          <p:cNvPr id="49" name="Rounded Rectangle 48"/>
           <p:cNvSpPr/>
           <p:nvPr/>
         </p:nvSpPr>
         <p:spPr>
           <a:xfrm>
-            <a:off x="457200" y="3621024"/>
-            <a:ext cx="292608" cy="292608"/>
-          </a:xfrm>
-          <a:prstGeom prst="ellipse">
-            <a:avLst/>
-          </a:prstGeom>
-          <a:solidFill>
-            <a:srgbClr val="0B7F77"/>
+            <a:off x="7973568" y="3511296"/>
+            <a:ext cx="914400" cy="128016"/>
+          </a:xfrm>
+          <a:prstGeom prst="roundRect">
+            <a:avLst>
+              <a:gd name="adj" fmla="val 50000"/>
+            </a:avLst>
+          </a:prstGeom>
+          <a:solidFill>
+            <a:srgbClr val="EDF0F2"/>
           </a:solidFill>
           <a:ln>
             <a:noFill/>
@@ -8651,131 +8849,23 @@
           </a:fontRef>
         </p:style>
         <p:txBody>
-          <a:bodyPr rtlCol="0" anchor="ctr" wrap="none"/>
+          <a:bodyPr rtlCol="0" anchor="ctr"/>
           <a:lstStyle/>
           <a:p>
             <a:pPr algn="ctr"/>
-            <a:r>
-              <a:rPr sz="1100" b="1">
-                <a:solidFill>
-                  <a:srgbClr val="FFFFFF"/>
-                </a:solidFill>
-                <a:latin typeface="Calibri"/>
-              </a:rPr>
-              <a:t>3</a:t>
-            </a:r>
-          </a:p>
-        </p:txBody>
-      </p:sp>
-      <p:sp>
-        <p:nvSpPr>
-          <p:cNvPr id="44" name="TextBox 43"/>
-          <p:cNvSpPr txBox="1"/>
-          <p:nvPr/>
-        </p:nvSpPr>
-        <p:spPr>
-          <a:xfrm>
-            <a:off x="822960" y="3547872"/>
-            <a:ext cx="1536192" cy="512064"/>
-          </a:xfrm>
-          <a:prstGeom prst="rect">
-            <a:avLst/>
-          </a:prstGeom>
-          <a:noFill/>
-        </p:spPr>
-        <p:txBody>
-          <a:bodyPr wrap="square" anchor="t"/>
-          <a:lstStyle/>
-          <a:p>
-            <a:pPr algn="l"/>
-            <a:r>
-              <a:rPr sz="1400" b="1">
-                <a:solidFill>
-                  <a:srgbClr val="26303A"/>
-                </a:solidFill>
-                <a:latin typeface="Calibri"/>
-              </a:rPr>
-              <a:t>Dynamic Bottom Up CAPEX</a:t>
-            </a:r>
-          </a:p>
-        </p:txBody>
-      </p:sp>
-      <p:sp>
-        <p:nvSpPr>
-          <p:cNvPr id="45" name="TextBox 44"/>
-          <p:cNvSpPr txBox="1"/>
-          <p:nvPr/>
-        </p:nvSpPr>
-        <p:spPr>
-          <a:xfrm>
-            <a:off x="2450592" y="3438144"/>
-            <a:ext cx="960120" cy="292608"/>
-          </a:xfrm>
-          <a:prstGeom prst="rect">
-            <a:avLst/>
-          </a:prstGeom>
-          <a:noFill/>
-        </p:spPr>
-        <p:txBody>
-          <a:bodyPr wrap="square" anchor="t"/>
-          <a:lstStyle/>
-          <a:p>
-            <a:pPr algn="l"/>
-            <a:r>
-              <a:rPr sz="1200" b="1">
-                <a:solidFill>
-                  <a:srgbClr val="0A5F59"/>
-                </a:solidFill>
-                <a:latin typeface="Calibri"/>
-              </a:rPr>
-              <a:t>LEADERS</a:t>
-            </a:r>
-          </a:p>
-        </p:txBody>
-      </p:sp>
-      <p:sp>
-        <p:nvSpPr>
-          <p:cNvPr id="46" name="TextBox 45"/>
-          <p:cNvSpPr txBox="1"/>
-          <p:nvPr/>
-        </p:nvSpPr>
-        <p:spPr>
-          <a:xfrm>
-            <a:off x="3383280" y="3438144"/>
-            <a:ext cx="2194560" cy="292608"/>
-          </a:xfrm>
-          <a:prstGeom prst="rect">
-            <a:avLst/>
-          </a:prstGeom>
-          <a:noFill/>
-        </p:spPr>
-        <p:txBody>
-          <a:bodyPr wrap="square" anchor="t"/>
-          <a:lstStyle/>
-          <a:p>
-            <a:pPr algn="l"/>
-            <a:r>
-              <a:rPr sz="1400" b="0">
-                <a:solidFill>
-                  <a:srgbClr val="3A454F"/>
-                </a:solidFill>
-                <a:latin typeface="Calibri"/>
-              </a:rPr>
-              <a:t>Estimating on old rates.</a:t>
-            </a:r>
-          </a:p>
-        </p:txBody>
-      </p:sp>
-      <p:sp>
-        <p:nvSpPr>
-          <p:cNvPr id="47" name="Rounded Rectangle 46"/>
+          </a:p>
+        </p:txBody>
+      </p:sp>
+      <p:sp>
+        <p:nvSpPr>
+          <p:cNvPr id="50" name="Rounded Rectangle 49"/>
           <p:cNvSpPr/>
           <p:nvPr/>
         </p:nvSpPr>
         <p:spPr>
           <a:xfrm>
-            <a:off x="5632704" y="3493008"/>
-            <a:ext cx="868680" cy="128016"/>
+            <a:off x="7973568" y="3511296"/>
+            <a:ext cx="292608" cy="128016"/>
           </a:xfrm>
           <a:prstGeom prst="roundRect">
             <a:avLst>
@@ -8783,7 +8873,7 @@
             </a:avLst>
           </a:prstGeom>
           <a:solidFill>
-            <a:srgbClr val="EDF0F2"/>
+            <a:srgbClr val="98A2AB"/>
           </a:solidFill>
           <a:ln>
             <a:noFill/>
@@ -8813,14 +8903,113 @@
       </p:sp>
       <p:sp>
         <p:nvSpPr>
-          <p:cNvPr id="48" name="Rounded Rectangle 47"/>
+          <p:cNvPr id="51" name="TextBox 50"/>
+          <p:cNvSpPr txBox="1"/>
+          <p:nvPr/>
+        </p:nvSpPr>
+        <p:spPr>
+          <a:xfrm>
+            <a:off x="2450592" y="3803904"/>
+            <a:ext cx="914400" cy="274320"/>
+          </a:xfrm>
+          <a:prstGeom prst="rect">
+            <a:avLst/>
+          </a:prstGeom>
+          <a:noFill/>
+        </p:spPr>
+        <p:txBody>
+          <a:bodyPr wrap="square" anchor="t"/>
+          <a:lstStyle/>
+          <a:p>
+            <a:pPr algn="l"/>
+            <a:r>
+              <a:rPr sz="1100" b="1">
+                <a:solidFill>
+                  <a:srgbClr val="9AA3AC"/>
+                </a:solidFill>
+                <a:latin typeface="Calibri"/>
+              </a:rPr>
+              <a:t>DEVELOPING</a:t>
+            </a:r>
+          </a:p>
+        </p:txBody>
+      </p:sp>
+      <p:sp>
+        <p:nvSpPr>
+          <p:cNvPr id="52" name="TextBox 51"/>
+          <p:cNvSpPr txBox="1"/>
+          <p:nvPr/>
+        </p:nvSpPr>
+        <p:spPr>
+          <a:xfrm>
+            <a:off x="3383280" y="3803904"/>
+            <a:ext cx="3703320" cy="329184"/>
+          </a:xfrm>
+          <a:prstGeom prst="rect">
+            <a:avLst/>
+          </a:prstGeom>
+          <a:noFill/>
+        </p:spPr>
+        <p:txBody>
+          <a:bodyPr wrap="square" anchor="t"/>
+          <a:lstStyle/>
+          <a:p>
+            <a:pPr algn="l"/>
+            <a:r>
+              <a:rPr sz="1200" b="0">
+                <a:solidFill>
+                  <a:srgbClr val="3A454F"/>
+                </a:solidFill>
+                <a:latin typeface="Calibri"/>
+              </a:rPr>
+              <a:t>Last cost plus inflation, with no accuracy tracking</a:t>
+            </a:r>
+          </a:p>
+        </p:txBody>
+      </p:sp>
+      <p:sp>
+        <p:nvSpPr>
+          <p:cNvPr id="53" name="TextBox 52"/>
+          <p:cNvSpPr txBox="1"/>
+          <p:nvPr/>
+        </p:nvSpPr>
+        <p:spPr>
+          <a:xfrm>
+            <a:off x="7114032" y="3803904"/>
+            <a:ext cx="777240" cy="274320"/>
+          </a:xfrm>
+          <a:prstGeom prst="rect">
+            <a:avLst/>
+          </a:prstGeom>
+          <a:noFill/>
+        </p:spPr>
+        <p:txBody>
+          <a:bodyPr wrap="square" anchor="t"/>
+          <a:lstStyle/>
+          <a:p>
+            <a:pPr algn="r"/>
+            <a:r>
+              <a:rPr sz="1100" b="1">
+                <a:solidFill>
+                  <a:srgbClr val="96641A"/>
+                </a:solidFill>
+                <a:latin typeface="Calibri"/>
+              </a:rPr>
+              <a:t>MEDIUM</a:t>
+            </a:r>
+          </a:p>
+        </p:txBody>
+      </p:sp>
+      <p:sp>
+        <p:nvSpPr>
+          <p:cNvPr id="54" name="Rounded Rectangle 53"/>
           <p:cNvSpPr/>
           <p:nvPr/>
         </p:nvSpPr>
         <p:spPr>
           <a:xfrm>
-            <a:off x="5632704" y="3493008"/>
-            <a:ext cx="469087" cy="128016"/>
+            <a:off x="7973568" y="3877056"/>
+            <a:ext cx="914400" cy="128016"/>
           </a:xfrm>
           <a:prstGeom prst="roundRect">
             <a:avLst>
@@ -8828,7 +9017,7 @@
             </a:avLst>
           </a:prstGeom>
           <a:solidFill>
-            <a:srgbClr val="98A2AB"/>
+            <a:srgbClr val="EDF0F2"/>
           </a:solidFill>
           <a:ln>
             <a:noFill/>
@@ -8858,80 +9047,14 @@
       </p:sp>
       <p:sp>
         <p:nvSpPr>
-          <p:cNvPr id="49" name="TextBox 48"/>
-          <p:cNvSpPr txBox="1"/>
-          <p:nvPr/>
-        </p:nvSpPr>
-        <p:spPr>
-          <a:xfrm>
-            <a:off x="2450592" y="3803904"/>
-            <a:ext cx="960120" cy="292608"/>
-          </a:xfrm>
-          <a:prstGeom prst="rect">
-            <a:avLst/>
-          </a:prstGeom>
-          <a:noFill/>
-        </p:spPr>
-        <p:txBody>
-          <a:bodyPr wrap="square" anchor="t"/>
-          <a:lstStyle/>
-          <a:p>
-            <a:pPr algn="l"/>
-            <a:r>
-              <a:rPr sz="1200" b="1">
-                <a:solidFill>
-                  <a:srgbClr val="9AA3AC"/>
-                </a:solidFill>
-                <a:latin typeface="Calibri"/>
-              </a:rPr>
-              <a:t>DEVELOPING</a:t>
-            </a:r>
-          </a:p>
-        </p:txBody>
-      </p:sp>
-      <p:sp>
-        <p:nvSpPr>
-          <p:cNvPr id="50" name="TextBox 49"/>
-          <p:cNvSpPr txBox="1"/>
-          <p:nvPr/>
-        </p:nvSpPr>
-        <p:spPr>
-          <a:xfrm>
-            <a:off x="3383280" y="3803904"/>
-            <a:ext cx="2194560" cy="292608"/>
-          </a:xfrm>
-          <a:prstGeom prst="rect">
-            <a:avLst/>
-          </a:prstGeom>
-          <a:noFill/>
-        </p:spPr>
-        <p:txBody>
-          <a:bodyPr wrap="square" anchor="t"/>
-          <a:lstStyle/>
-          <a:p>
-            <a:pPr algn="l"/>
-            <a:r>
-              <a:rPr sz="1400" b="0">
-                <a:solidFill>
-                  <a:srgbClr val="3A454F"/>
-                </a:solidFill>
-                <a:latin typeface="Calibri"/>
-              </a:rPr>
-              <a:t>Last cost plus inflation.</a:t>
-            </a:r>
-          </a:p>
-        </p:txBody>
-      </p:sp>
-      <p:sp>
-        <p:nvSpPr>
-          <p:cNvPr id="51" name="Rounded Rectangle 50"/>
+          <p:cNvPr id="55" name="Rounded Rectangle 54"/>
           <p:cNvSpPr/>
           <p:nvPr/>
         </p:nvSpPr>
         <p:spPr>
           <a:xfrm>
-            <a:off x="5632704" y="3858768"/>
-            <a:ext cx="868680" cy="128016"/>
+            <a:off x="7973568" y="3877056"/>
+            <a:ext cx="566928" cy="128016"/>
           </a:xfrm>
           <a:prstGeom prst="roundRect">
             <a:avLst>
@@ -8939,7 +9062,7 @@
             </a:avLst>
           </a:prstGeom>
           <a:solidFill>
-            <a:srgbClr val="EDF0F2"/>
+            <a:srgbClr val="D9982F"/>
           </a:solidFill>
           <a:ln>
             <a:noFill/>
@@ -8969,22 +9092,22 @@
       </p:sp>
       <p:sp>
         <p:nvSpPr>
-          <p:cNvPr id="52" name="Rounded Rectangle 51"/>
+          <p:cNvPr id="56" name="Rounded Rectangle 55"/>
           <p:cNvSpPr/>
           <p:nvPr/>
         </p:nvSpPr>
         <p:spPr>
           <a:xfrm>
-            <a:off x="5632704" y="3858768"/>
-            <a:ext cx="729691" cy="128016"/>
+            <a:off x="9098280" y="3438144"/>
+            <a:ext cx="2706624" cy="658368"/>
           </a:xfrm>
           <a:prstGeom prst="roundRect">
             <a:avLst>
-              <a:gd name="adj" fmla="val 50000"/>
+              <a:gd name="adj" fmla="val 4000"/>
             </a:avLst>
           </a:prstGeom>
           <a:solidFill>
-            <a:srgbClr val="D9982F"/>
+            <a:srgbClr val="E4F1EF"/>
           </a:solidFill>
           <a:ln>
             <a:noFill/>
@@ -9005,64 +9128,38 @@
           </a:fontRef>
         </p:style>
         <p:txBody>
-          <a:bodyPr rtlCol="0" anchor="ctr"/>
-          <a:lstStyle/>
-          <a:p>
-            <a:pPr algn="ctr"/>
-          </a:p>
-        </p:txBody>
-      </p:sp>
-      <p:sp>
-        <p:nvSpPr>
-          <p:cNvPr id="53" name="TextBox 52"/>
-          <p:cNvSpPr txBox="1"/>
-          <p:nvPr/>
-        </p:nvSpPr>
-        <p:spPr>
-          <a:xfrm>
-            <a:off x="6693408" y="3529584"/>
-            <a:ext cx="2267712" cy="530352"/>
-          </a:xfrm>
-          <a:prstGeom prst="rect">
-            <a:avLst/>
-          </a:prstGeom>
-          <a:noFill/>
-        </p:spPr>
-        <p:txBody>
-          <a:bodyPr wrap="square" anchor="t"/>
+          <a:bodyPr rtlCol="0" anchor="ctr" wrap="square" lIns="73152" rIns="73152" tIns="36576" bIns="36576"/>
           <a:lstStyle/>
           <a:p>
             <a:pPr algn="l"/>
             <a:r>
-              <a:rPr sz="1400" b="0">
-                <a:solidFill>
-                  <a:srgbClr val="26303A"/>
-                </a:solidFill>
-                <a:latin typeface="Calibri"/>
-              </a:rPr>
-              <a:t>Budgets set on prices already stale.</a:t>
-            </a:r>
-          </a:p>
-        </p:txBody>
-      </p:sp>
-      <p:sp>
-        <p:nvSpPr>
-          <p:cNvPr id="54" name="Rounded Rectangle 53"/>
+              <a:rPr sz="1200" b="1">
+                <a:solidFill>
+                  <a:srgbClr val="0A5F59"/>
+                </a:solidFill>
+                <a:latin typeface="Calibri"/>
+              </a:rPr>
+              <a:t>Item-level bottom-up cost breakdown with live index data integration</a:t>
+            </a:r>
+          </a:p>
+        </p:txBody>
+      </p:sp>
+      <p:sp>
+        <p:nvSpPr>
+          <p:cNvPr id="57" name="Rectangle 56"/>
           <p:cNvSpPr/>
           <p:nvPr/>
         </p:nvSpPr>
         <p:spPr>
           <a:xfrm>
-            <a:off x="9061704" y="3456432"/>
-            <a:ext cx="2743200" cy="640080"/>
-          </a:xfrm>
-          <a:prstGeom prst="roundRect">
-            <a:avLst>
-              <a:gd name="adj" fmla="val 4000"/>
-            </a:avLst>
-          </a:prstGeom>
-          <a:solidFill>
-            <a:srgbClr val="E4F1EF"/>
+            <a:off x="384048" y="4946904"/>
+            <a:ext cx="11420856" cy="9144"/>
+          </a:xfrm>
+          <a:prstGeom prst="rect">
+            <a:avLst/>
+          </a:prstGeom>
+          <a:solidFill>
+            <a:srgbClr val="E3E8E9"/>
           </a:solidFill>
           <a:ln>
             <a:noFill/>
@@ -9083,38 +9180,29 @@
           </a:fontRef>
         </p:style>
         <p:txBody>
-          <a:bodyPr rtlCol="0" anchor="ctr" wrap="square" lIns="73152" rIns="73152" tIns="36576" bIns="36576"/>
-          <a:lstStyle/>
-          <a:p>
-            <a:pPr algn="l"/>
-            <a:r>
-              <a:rPr sz="1400" b="1">
-                <a:solidFill>
-                  <a:srgbClr val="0A5F59"/>
-                </a:solidFill>
-                <a:latin typeface="Calibri"/>
-              </a:rPr>
-              <a:t>Item-level forecasts kept live with commodity, labor and FX.</a:t>
-            </a:r>
-          </a:p>
-        </p:txBody>
-      </p:sp>
-      <p:sp>
-        <p:nvSpPr>
-          <p:cNvPr id="55" name="Rectangle 54"/>
+          <a:bodyPr rtlCol="0" anchor="ctr"/>
+          <a:lstStyle/>
+          <a:p>
+            <a:pPr algn="ctr"/>
+          </a:p>
+        </p:txBody>
+      </p:sp>
+      <p:sp>
+        <p:nvSpPr>
+          <p:cNvPr id="58" name="Oval 57"/>
           <p:cNvSpPr/>
           <p:nvPr/>
         </p:nvSpPr>
         <p:spPr>
           <a:xfrm>
-            <a:off x="384048" y="4946904"/>
-            <a:ext cx="11420856" cy="9144"/>
-          </a:xfrm>
-          <a:prstGeom prst="rect">
-            <a:avLst/>
-          </a:prstGeom>
-          <a:solidFill>
-            <a:srgbClr val="E3E8E9"/>
+            <a:off x="457200" y="4407408"/>
+            <a:ext cx="292608" cy="292608"/>
+          </a:xfrm>
+          <a:prstGeom prst="ellipse">
+            <a:avLst/>
+          </a:prstGeom>
+          <a:solidFill>
+            <a:srgbClr val="0B7F77"/>
           </a:solidFill>
           <a:ln>
             <a:noFill/>
@@ -9135,29 +9223,172 @@
           </a:fontRef>
         </p:style>
         <p:txBody>
-          <a:bodyPr rtlCol="0" anchor="ctr"/>
+          <a:bodyPr rtlCol="0" anchor="ctr" wrap="none"/>
           <a:lstStyle/>
           <a:p>
             <a:pPr algn="ctr"/>
-          </a:p>
-        </p:txBody>
-      </p:sp>
-      <p:sp>
-        <p:nvSpPr>
-          <p:cNvPr id="56" name="Oval 55"/>
+            <a:r>
+              <a:rPr sz="1100" b="1">
+                <a:solidFill>
+                  <a:srgbClr val="FFFFFF"/>
+                </a:solidFill>
+                <a:latin typeface="Calibri"/>
+              </a:rPr>
+              <a:t>4</a:t>
+            </a:r>
+          </a:p>
+        </p:txBody>
+      </p:sp>
+      <p:sp>
+        <p:nvSpPr>
+          <p:cNvPr id="59" name="TextBox 58"/>
+          <p:cNvSpPr txBox="1"/>
+          <p:nvPr/>
+        </p:nvSpPr>
+        <p:spPr>
+          <a:xfrm>
+            <a:off x="822960" y="4334256"/>
+            <a:ext cx="1536192" cy="512064"/>
+          </a:xfrm>
+          <a:prstGeom prst="rect">
+            <a:avLst/>
+          </a:prstGeom>
+          <a:noFill/>
+        </p:spPr>
+        <p:txBody>
+          <a:bodyPr wrap="square" anchor="t"/>
+          <a:lstStyle/>
+          <a:p>
+            <a:pPr algn="l"/>
+            <a:r>
+              <a:rPr sz="1300" b="1">
+                <a:solidFill>
+                  <a:srgbClr val="26303A"/>
+                </a:solidFill>
+                <a:latin typeface="Calibri"/>
+              </a:rPr>
+              <a:t>Smart Tender Bid Evaluation</a:t>
+            </a:r>
+          </a:p>
+        </p:txBody>
+      </p:sp>
+      <p:sp>
+        <p:nvSpPr>
+          <p:cNvPr id="60" name="TextBox 59"/>
+          <p:cNvSpPr txBox="1"/>
+          <p:nvPr/>
+        </p:nvSpPr>
+        <p:spPr>
+          <a:xfrm>
+            <a:off x="2450592" y="4224528"/>
+            <a:ext cx="914400" cy="274320"/>
+          </a:xfrm>
+          <a:prstGeom prst="rect">
+            <a:avLst/>
+          </a:prstGeom>
+          <a:noFill/>
+        </p:spPr>
+        <p:txBody>
+          <a:bodyPr wrap="square" anchor="t"/>
+          <a:lstStyle/>
+          <a:p>
+            <a:pPr algn="l"/>
+            <a:r>
+              <a:rPr sz="1100" b="1">
+                <a:solidFill>
+                  <a:srgbClr val="0A5F59"/>
+                </a:solidFill>
+                <a:latin typeface="Calibri"/>
+              </a:rPr>
+              <a:t>LEADERS</a:t>
+            </a:r>
+          </a:p>
+        </p:txBody>
+      </p:sp>
+      <p:sp>
+        <p:nvSpPr>
+          <p:cNvPr id="61" name="TextBox 60"/>
+          <p:cNvSpPr txBox="1"/>
+          <p:nvPr/>
+        </p:nvSpPr>
+        <p:spPr>
+          <a:xfrm>
+            <a:off x="3383280" y="4224528"/>
+            <a:ext cx="3703320" cy="329184"/>
+          </a:xfrm>
+          <a:prstGeom prst="rect">
+            <a:avLst/>
+          </a:prstGeom>
+          <a:noFill/>
+        </p:spPr>
+        <p:txBody>
+          <a:bodyPr wrap="square" anchor="t"/>
+          <a:lstStyle/>
+          <a:p>
+            <a:pPr algn="l"/>
+            <a:r>
+              <a:rPr sz="1200" b="0">
+                <a:solidFill>
+                  <a:srgbClr val="3A454F"/>
+                </a:solidFill>
+                <a:latin typeface="Calibri"/>
+              </a:rPr>
+              <a:t>E-tender solutions are adopted, but with limited AI use in comparison</a:t>
+            </a:r>
+          </a:p>
+        </p:txBody>
+      </p:sp>
+      <p:sp>
+        <p:nvSpPr>
+          <p:cNvPr id="62" name="TextBox 61"/>
+          <p:cNvSpPr txBox="1"/>
+          <p:nvPr/>
+        </p:nvSpPr>
+        <p:spPr>
+          <a:xfrm>
+            <a:off x="7114032" y="4224528"/>
+            <a:ext cx="777240" cy="274320"/>
+          </a:xfrm>
+          <a:prstGeom prst="rect">
+            <a:avLst/>
+          </a:prstGeom>
+          <a:noFill/>
+        </p:spPr>
+        <p:txBody>
+          <a:bodyPr wrap="square" anchor="t"/>
+          <a:lstStyle/>
+          <a:p>
+            <a:pPr algn="r"/>
+            <a:r>
+              <a:rPr sz="1100" b="1">
+                <a:solidFill>
+                  <a:srgbClr val="5C6670"/>
+                </a:solidFill>
+                <a:latin typeface="Calibri"/>
+              </a:rPr>
+              <a:t>LOW</a:t>
+            </a:r>
+          </a:p>
+        </p:txBody>
+      </p:sp>
+      <p:sp>
+        <p:nvSpPr>
+          <p:cNvPr id="63" name="Rounded Rectangle 62"/>
           <p:cNvSpPr/>
           <p:nvPr/>
         </p:nvSpPr>
         <p:spPr>
           <a:xfrm>
-            <a:off x="457200" y="4407408"/>
-            <a:ext cx="292608" cy="292608"/>
-          </a:xfrm>
-          <a:prstGeom prst="ellipse">
-            <a:avLst/>
-          </a:prstGeom>
-          <a:solidFill>
-            <a:srgbClr val="0B7F77"/>
+            <a:off x="7973568" y="4297680"/>
+            <a:ext cx="914400" cy="128016"/>
+          </a:xfrm>
+          <a:prstGeom prst="roundRect">
+            <a:avLst>
+              <a:gd name="adj" fmla="val 50000"/>
+            </a:avLst>
+          </a:prstGeom>
+          <a:solidFill>
+            <a:srgbClr val="EDF0F2"/>
           </a:solidFill>
           <a:ln>
             <a:noFill/>
@@ -9178,131 +9409,23 @@
           </a:fontRef>
         </p:style>
         <p:txBody>
-          <a:bodyPr rtlCol="0" anchor="ctr" wrap="none"/>
+          <a:bodyPr rtlCol="0" anchor="ctr"/>
           <a:lstStyle/>
           <a:p>
             <a:pPr algn="ctr"/>
-            <a:r>
-              <a:rPr sz="1100" b="1">
-                <a:solidFill>
-                  <a:srgbClr val="FFFFFF"/>
-                </a:solidFill>
-                <a:latin typeface="Calibri"/>
-              </a:rPr>
-              <a:t>4</a:t>
-            </a:r>
-          </a:p>
-        </p:txBody>
-      </p:sp>
-      <p:sp>
-        <p:nvSpPr>
-          <p:cNvPr id="57" name="TextBox 56"/>
-          <p:cNvSpPr txBox="1"/>
-          <p:nvPr/>
-        </p:nvSpPr>
-        <p:spPr>
-          <a:xfrm>
-            <a:off x="822960" y="4334256"/>
-            <a:ext cx="1536192" cy="512064"/>
-          </a:xfrm>
-          <a:prstGeom prst="rect">
-            <a:avLst/>
-          </a:prstGeom>
-          <a:noFill/>
-        </p:spPr>
-        <p:txBody>
-          <a:bodyPr wrap="square" anchor="t"/>
-          <a:lstStyle/>
-          <a:p>
-            <a:pPr algn="l"/>
-            <a:r>
-              <a:rPr sz="1400" b="1">
-                <a:solidFill>
-                  <a:srgbClr val="26303A"/>
-                </a:solidFill>
-                <a:latin typeface="Calibri"/>
-              </a:rPr>
-              <a:t>Smart Tender Bid Evaluation</a:t>
-            </a:r>
-          </a:p>
-        </p:txBody>
-      </p:sp>
-      <p:sp>
-        <p:nvSpPr>
-          <p:cNvPr id="58" name="TextBox 57"/>
-          <p:cNvSpPr txBox="1"/>
-          <p:nvPr/>
-        </p:nvSpPr>
-        <p:spPr>
-          <a:xfrm>
-            <a:off x="2450592" y="4224528"/>
-            <a:ext cx="960120" cy="292608"/>
-          </a:xfrm>
-          <a:prstGeom prst="rect">
-            <a:avLst/>
-          </a:prstGeom>
-          <a:noFill/>
-        </p:spPr>
-        <p:txBody>
-          <a:bodyPr wrap="square" anchor="t"/>
-          <a:lstStyle/>
-          <a:p>
-            <a:pPr algn="l"/>
-            <a:r>
-              <a:rPr sz="1200" b="1">
-                <a:solidFill>
-                  <a:srgbClr val="0A5F59"/>
-                </a:solidFill>
-                <a:latin typeface="Calibri"/>
-              </a:rPr>
-              <a:t>LEADERS</a:t>
-            </a:r>
-          </a:p>
-        </p:txBody>
-      </p:sp>
-      <p:sp>
-        <p:nvSpPr>
-          <p:cNvPr id="59" name="TextBox 58"/>
-          <p:cNvSpPr txBox="1"/>
-          <p:nvPr/>
-        </p:nvSpPr>
-        <p:spPr>
-          <a:xfrm>
-            <a:off x="3383280" y="4224528"/>
-            <a:ext cx="2194560" cy="292608"/>
-          </a:xfrm>
-          <a:prstGeom prst="rect">
-            <a:avLst/>
-          </a:prstGeom>
-          <a:noFill/>
-        </p:spPr>
-        <p:txBody>
-          <a:bodyPr wrap="square" anchor="t"/>
-          <a:lstStyle/>
-          <a:p>
-            <a:pPr algn="l"/>
-            <a:r>
-              <a:rPr sz="1400" b="0">
-                <a:solidFill>
-                  <a:srgbClr val="3A454F"/>
-                </a:solidFill>
-                <a:latin typeface="Calibri"/>
-              </a:rPr>
-              <a:t>Leveling by hand in Excel.</a:t>
-            </a:r>
-          </a:p>
-        </p:txBody>
-      </p:sp>
-      <p:sp>
-        <p:nvSpPr>
-          <p:cNvPr id="60" name="Rounded Rectangle 59"/>
+          </a:p>
+        </p:txBody>
+      </p:sp>
+      <p:sp>
+        <p:nvSpPr>
+          <p:cNvPr id="64" name="Rounded Rectangle 63"/>
           <p:cNvSpPr/>
           <p:nvPr/>
         </p:nvSpPr>
         <p:spPr>
           <a:xfrm>
-            <a:off x="5632704" y="4279392"/>
-            <a:ext cx="868680" cy="128016"/>
+            <a:off x="7973568" y="4297680"/>
+            <a:ext cx="292608" cy="128016"/>
           </a:xfrm>
           <a:prstGeom prst="roundRect">
             <a:avLst>
@@ -9310,7 +9433,7 @@
             </a:avLst>
           </a:prstGeom>
           <a:solidFill>
-            <a:srgbClr val="EDF0F2"/>
+            <a:srgbClr val="98A2AB"/>
           </a:solidFill>
           <a:ln>
             <a:noFill/>
@@ -9340,14 +9463,113 @@
       </p:sp>
       <p:sp>
         <p:nvSpPr>
-          <p:cNvPr id="61" name="Rounded Rectangle 60"/>
+          <p:cNvPr id="65" name="TextBox 64"/>
+          <p:cNvSpPr txBox="1"/>
+          <p:nvPr/>
+        </p:nvSpPr>
+        <p:spPr>
+          <a:xfrm>
+            <a:off x="2450592" y="4590288"/>
+            <a:ext cx="914400" cy="274320"/>
+          </a:xfrm>
+          <a:prstGeom prst="rect">
+            <a:avLst/>
+          </a:prstGeom>
+          <a:noFill/>
+        </p:spPr>
+        <p:txBody>
+          <a:bodyPr wrap="square" anchor="t"/>
+          <a:lstStyle/>
+          <a:p>
+            <a:pPr algn="l"/>
+            <a:r>
+              <a:rPr sz="1100" b="1">
+                <a:solidFill>
+                  <a:srgbClr val="9AA3AC"/>
+                </a:solidFill>
+                <a:latin typeface="Calibri"/>
+              </a:rPr>
+              <a:t>DEVELOPING</a:t>
+            </a:r>
+          </a:p>
+        </p:txBody>
+      </p:sp>
+      <p:sp>
+        <p:nvSpPr>
+          <p:cNvPr id="66" name="TextBox 65"/>
+          <p:cNvSpPr txBox="1"/>
+          <p:nvPr/>
+        </p:nvSpPr>
+        <p:spPr>
+          <a:xfrm>
+            <a:off x="3383280" y="4590288"/>
+            <a:ext cx="3703320" cy="329184"/>
+          </a:xfrm>
+          <a:prstGeom prst="rect">
+            <a:avLst/>
+          </a:prstGeom>
+          <a:noFill/>
+        </p:spPr>
+        <p:txBody>
+          <a:bodyPr wrap="square" anchor="t"/>
+          <a:lstStyle/>
+          <a:p>
+            <a:pPr algn="l"/>
+            <a:r>
+              <a:rPr sz="1200" b="0">
+                <a:solidFill>
+                  <a:srgbClr val="3A454F"/>
+                </a:solidFill>
+                <a:latin typeface="Calibri"/>
+              </a:rPr>
+              <a:t>Manual consolidation and comparison in random Excels</a:t>
+            </a:r>
+          </a:p>
+        </p:txBody>
+      </p:sp>
+      <p:sp>
+        <p:nvSpPr>
+          <p:cNvPr id="67" name="TextBox 66"/>
+          <p:cNvSpPr txBox="1"/>
+          <p:nvPr/>
+        </p:nvSpPr>
+        <p:spPr>
+          <a:xfrm>
+            <a:off x="7114032" y="4590288"/>
+            <a:ext cx="777240" cy="274320"/>
+          </a:xfrm>
+          <a:prstGeom prst="rect">
+            <a:avLst/>
+          </a:prstGeom>
+          <a:noFill/>
+        </p:spPr>
+        <p:txBody>
+          <a:bodyPr wrap="square" anchor="t"/>
+          <a:lstStyle/>
+          <a:p>
+            <a:pPr algn="r"/>
+            <a:r>
+              <a:rPr sz="1100" b="1">
+                <a:solidFill>
+                  <a:srgbClr val="96641A"/>
+                </a:solidFill>
+                <a:latin typeface="Calibri"/>
+              </a:rPr>
+              <a:t>MEDIUM</a:t>
+            </a:r>
+          </a:p>
+        </p:txBody>
+      </p:sp>
+      <p:sp>
+        <p:nvSpPr>
+          <p:cNvPr id="68" name="Rounded Rectangle 67"/>
           <p:cNvSpPr/>
           <p:nvPr/>
         </p:nvSpPr>
         <p:spPr>
           <a:xfrm>
-            <a:off x="5632704" y="4279392"/>
-            <a:ext cx="608076" cy="128016"/>
+            <a:off x="7973568" y="4663440"/>
+            <a:ext cx="914400" cy="128016"/>
           </a:xfrm>
           <a:prstGeom prst="roundRect">
             <a:avLst>
@@ -9355,7 +9577,7 @@
             </a:avLst>
           </a:prstGeom>
           <a:solidFill>
-            <a:srgbClr val="D9982F"/>
+            <a:srgbClr val="EDF0F2"/>
           </a:solidFill>
           <a:ln>
             <a:noFill/>
@@ -9385,80 +9607,14 @@
       </p:sp>
       <p:sp>
         <p:nvSpPr>
-          <p:cNvPr id="62" name="TextBox 61"/>
-          <p:cNvSpPr txBox="1"/>
-          <p:nvPr/>
-        </p:nvSpPr>
-        <p:spPr>
-          <a:xfrm>
-            <a:off x="2450592" y="4590288"/>
-            <a:ext cx="960120" cy="292608"/>
-          </a:xfrm>
-          <a:prstGeom prst="rect">
-            <a:avLst/>
-          </a:prstGeom>
-          <a:noFill/>
-        </p:spPr>
-        <p:txBody>
-          <a:bodyPr wrap="square" anchor="t"/>
-          <a:lstStyle/>
-          <a:p>
-            <a:pPr algn="l"/>
-            <a:r>
-              <a:rPr sz="1200" b="1">
-                <a:solidFill>
-                  <a:srgbClr val="9AA3AC"/>
-                </a:solidFill>
-                <a:latin typeface="Calibri"/>
-              </a:rPr>
-              <a:t>DEVELOPING</a:t>
-            </a:r>
-          </a:p>
-        </p:txBody>
-      </p:sp>
-      <p:sp>
-        <p:nvSpPr>
-          <p:cNvPr id="63" name="TextBox 62"/>
-          <p:cNvSpPr txBox="1"/>
-          <p:nvPr/>
-        </p:nvSpPr>
-        <p:spPr>
-          <a:xfrm>
-            <a:off x="3383280" y="4590288"/>
-            <a:ext cx="2194560" cy="292608"/>
-          </a:xfrm>
-          <a:prstGeom prst="rect">
-            <a:avLst/>
-          </a:prstGeom>
-          <a:noFill/>
-        </p:spPr>
-        <p:txBody>
-          <a:bodyPr wrap="square" anchor="t"/>
-          <a:lstStyle/>
-          <a:p>
-            <a:pPr algn="l"/>
-            <a:r>
-              <a:rPr sz="1400" b="0">
-                <a:solidFill>
-                  <a:srgbClr val="3A454F"/>
-                </a:solidFill>
-                <a:latin typeface="Calibri"/>
-              </a:rPr>
-              <a:t>Each bidder's own format.</a:t>
-            </a:r>
-          </a:p>
-        </p:txBody>
-      </p:sp>
-      <p:sp>
-        <p:nvSpPr>
-          <p:cNvPr id="64" name="Rounded Rectangle 63"/>
+          <p:cNvPr id="69" name="Rounded Rectangle 68"/>
           <p:cNvSpPr/>
           <p:nvPr/>
         </p:nvSpPr>
         <p:spPr>
           <a:xfrm>
-            <a:off x="5632704" y="4645152"/>
-            <a:ext cx="868680" cy="128016"/>
+            <a:off x="7973568" y="4663440"/>
+            <a:ext cx="566928" cy="128016"/>
           </a:xfrm>
           <a:prstGeom prst="roundRect">
             <a:avLst>
@@ -9466,7 +9622,7 @@
             </a:avLst>
           </a:prstGeom>
           <a:solidFill>
-            <a:srgbClr val="EDF0F2"/>
+            <a:srgbClr val="D9982F"/>
           </a:solidFill>
           <a:ln>
             <a:noFill/>
@@ -9496,22 +9652,22 @@
       </p:sp>
       <p:sp>
         <p:nvSpPr>
-          <p:cNvPr id="65" name="Rounded Rectangle 64"/>
+          <p:cNvPr id="70" name="Rounded Rectangle 69"/>
           <p:cNvSpPr/>
           <p:nvPr/>
         </p:nvSpPr>
         <p:spPr>
           <a:xfrm>
-            <a:off x="5632704" y="4645152"/>
-            <a:ext cx="764438" cy="128016"/>
+            <a:off x="9098280" y="4224528"/>
+            <a:ext cx="2706624" cy="658368"/>
           </a:xfrm>
           <a:prstGeom prst="roundRect">
             <a:avLst>
-              <a:gd name="adj" fmla="val 50000"/>
+              <a:gd name="adj" fmla="val 4000"/>
             </a:avLst>
           </a:prstGeom>
           <a:solidFill>
-            <a:srgbClr val="C0453B"/>
+            <a:srgbClr val="E4F1EF"/>
           </a:solidFill>
           <a:ln>
             <a:noFill/>
@@ -9532,64 +9688,38 @@
           </a:fontRef>
         </p:style>
         <p:txBody>
-          <a:bodyPr rtlCol="0" anchor="ctr"/>
-          <a:lstStyle/>
-          <a:p>
-            <a:pPr algn="ctr"/>
-          </a:p>
-        </p:txBody>
-      </p:sp>
-      <p:sp>
-        <p:nvSpPr>
-          <p:cNvPr id="66" name="TextBox 65"/>
-          <p:cNvSpPr txBox="1"/>
-          <p:nvPr/>
-        </p:nvSpPr>
-        <p:spPr>
-          <a:xfrm>
-            <a:off x="6693408" y="4315968"/>
-            <a:ext cx="2267712" cy="530352"/>
-          </a:xfrm>
-          <a:prstGeom prst="rect">
-            <a:avLst/>
-          </a:prstGeom>
-          <a:noFill/>
-        </p:spPr>
-        <p:txBody>
-          <a:bodyPr wrap="square" anchor="t"/>
+          <a:bodyPr rtlCol="0" anchor="ctr" wrap="square" lIns="73152" rIns="73152" tIns="36576" bIns="36576"/>
           <a:lstStyle/>
           <a:p>
             <a:pPr algn="l"/>
             <a:r>
-              <a:rPr sz="1400" b="0">
-                <a:solidFill>
-                  <a:srgbClr val="26303A"/>
-                </a:solidFill>
-                <a:latin typeface="Calibri"/>
-              </a:rPr>
-              <a:t>Weeks per tender; scope gaps priced in.</a:t>
-            </a:r>
-          </a:p>
-        </p:txBody>
-      </p:sp>
-      <p:sp>
-        <p:nvSpPr>
-          <p:cNvPr id="67" name="Rounded Rectangle 66"/>
+              <a:rPr sz="1200" b="1">
+                <a:solidFill>
+                  <a:srgbClr val="0A5F59"/>
+                </a:solidFill>
+                <a:latin typeface="Calibri"/>
+              </a:rPr>
+              <a:t>Comparison in seconds, with an AI-based price recommendation</a:t>
+            </a:r>
+          </a:p>
+        </p:txBody>
+      </p:sp>
+      <p:sp>
+        <p:nvSpPr>
+          <p:cNvPr id="71" name="Rectangle 70"/>
           <p:cNvSpPr/>
           <p:nvPr/>
         </p:nvSpPr>
         <p:spPr>
           <a:xfrm>
-            <a:off x="9061704" y="4242816"/>
-            <a:ext cx="2743200" cy="640080"/>
-          </a:xfrm>
-          <a:prstGeom prst="roundRect">
-            <a:avLst>
-              <a:gd name="adj" fmla="val 4000"/>
-            </a:avLst>
-          </a:prstGeom>
-          <a:solidFill>
-            <a:srgbClr val="E4F1EF"/>
+            <a:off x="384048" y="5733288"/>
+            <a:ext cx="11420856" cy="9144"/>
+          </a:xfrm>
+          <a:prstGeom prst="rect">
+            <a:avLst/>
+          </a:prstGeom>
+          <a:solidFill>
+            <a:srgbClr val="E3E8E9"/>
           </a:solidFill>
           <a:ln>
             <a:noFill/>
@@ -9610,38 +9740,29 @@
           </a:fontRef>
         </p:style>
         <p:txBody>
-          <a:bodyPr rtlCol="0" anchor="ctr" wrap="square" lIns="73152" rIns="73152" tIns="36576" bIns="36576"/>
-          <a:lstStyle/>
-          <a:p>
-            <a:pPr algn="l"/>
-            <a:r>
-              <a:rPr sz="1400" b="1">
-                <a:solidFill>
-                  <a:srgbClr val="0A5F59"/>
-                </a:solidFill>
-                <a:latin typeface="Calibri"/>
-              </a:rPr>
-              <a:t>Bids mapped to one structure, then scored and ranked in minutes.</a:t>
-            </a:r>
-          </a:p>
-        </p:txBody>
-      </p:sp>
-      <p:sp>
-        <p:nvSpPr>
-          <p:cNvPr id="68" name="Rectangle 67"/>
+          <a:bodyPr rtlCol="0" anchor="ctr"/>
+          <a:lstStyle/>
+          <a:p>
+            <a:pPr algn="ctr"/>
+          </a:p>
+        </p:txBody>
+      </p:sp>
+      <p:sp>
+        <p:nvSpPr>
+          <p:cNvPr id="72" name="Oval 71"/>
           <p:cNvSpPr/>
           <p:nvPr/>
         </p:nvSpPr>
         <p:spPr>
           <a:xfrm>
-            <a:off x="384048" y="5733288"/>
-            <a:ext cx="11420856" cy="9144"/>
-          </a:xfrm>
-          <a:prstGeom prst="rect">
-            <a:avLst/>
-          </a:prstGeom>
-          <a:solidFill>
-            <a:srgbClr val="E3E8E9"/>
+            <a:off x="457200" y="5193792"/>
+            <a:ext cx="292608" cy="292608"/>
+          </a:xfrm>
+          <a:prstGeom prst="ellipse">
+            <a:avLst/>
+          </a:prstGeom>
+          <a:solidFill>
+            <a:srgbClr val="0B7F77"/>
           </a:solidFill>
           <a:ln>
             <a:noFill/>
@@ -9662,29 +9783,172 @@
           </a:fontRef>
         </p:style>
         <p:txBody>
-          <a:bodyPr rtlCol="0" anchor="ctr"/>
+          <a:bodyPr rtlCol="0" anchor="ctr" wrap="none"/>
           <a:lstStyle/>
           <a:p>
             <a:pPr algn="ctr"/>
-          </a:p>
-        </p:txBody>
-      </p:sp>
-      <p:sp>
-        <p:nvSpPr>
-          <p:cNvPr id="69" name="Oval 68"/>
+            <a:r>
+              <a:rPr sz="1100" b="1">
+                <a:solidFill>
+                  <a:srgbClr val="FFFFFF"/>
+                </a:solidFill>
+                <a:latin typeface="Calibri"/>
+              </a:rPr>
+              <a:t>5</a:t>
+            </a:r>
+          </a:p>
+        </p:txBody>
+      </p:sp>
+      <p:sp>
+        <p:nvSpPr>
+          <p:cNvPr id="73" name="TextBox 72"/>
+          <p:cNvSpPr txBox="1"/>
+          <p:nvPr/>
+        </p:nvSpPr>
+        <p:spPr>
+          <a:xfrm>
+            <a:off x="822960" y="5120640"/>
+            <a:ext cx="1536192" cy="512064"/>
+          </a:xfrm>
+          <a:prstGeom prst="rect">
+            <a:avLst/>
+          </a:prstGeom>
+          <a:noFill/>
+        </p:spPr>
+        <p:txBody>
+          <a:bodyPr wrap="square" anchor="t"/>
+          <a:lstStyle/>
+          <a:p>
+            <a:pPr algn="l"/>
+            <a:r>
+              <a:rPr sz="1300" b="1">
+                <a:solidFill>
+                  <a:srgbClr val="26303A"/>
+                </a:solidFill>
+                <a:latin typeface="Calibri"/>
+              </a:rPr>
+              <a:t>Agentic Cost Realization Tracking</a:t>
+            </a:r>
+          </a:p>
+        </p:txBody>
+      </p:sp>
+      <p:sp>
+        <p:nvSpPr>
+          <p:cNvPr id="74" name="TextBox 73"/>
+          <p:cNvSpPr txBox="1"/>
+          <p:nvPr/>
+        </p:nvSpPr>
+        <p:spPr>
+          <a:xfrm>
+            <a:off x="2450592" y="5010912"/>
+            <a:ext cx="914400" cy="274320"/>
+          </a:xfrm>
+          <a:prstGeom prst="rect">
+            <a:avLst/>
+          </a:prstGeom>
+          <a:noFill/>
+        </p:spPr>
+        <p:txBody>
+          <a:bodyPr wrap="square" anchor="t"/>
+          <a:lstStyle/>
+          <a:p>
+            <a:pPr algn="l"/>
+            <a:r>
+              <a:rPr sz="1100" b="1">
+                <a:solidFill>
+                  <a:srgbClr val="0A5F59"/>
+                </a:solidFill>
+                <a:latin typeface="Calibri"/>
+              </a:rPr>
+              <a:t>LEADERS</a:t>
+            </a:r>
+          </a:p>
+        </p:txBody>
+      </p:sp>
+      <p:sp>
+        <p:nvSpPr>
+          <p:cNvPr id="75" name="TextBox 74"/>
+          <p:cNvSpPr txBox="1"/>
+          <p:nvPr/>
+        </p:nvSpPr>
+        <p:spPr>
+          <a:xfrm>
+            <a:off x="3383280" y="5010912"/>
+            <a:ext cx="3703320" cy="329184"/>
+          </a:xfrm>
+          <a:prstGeom prst="rect">
+            <a:avLst/>
+          </a:prstGeom>
+          <a:noFill/>
+        </p:spPr>
+        <p:txBody>
+          <a:bodyPr wrap="square" anchor="t"/>
+          <a:lstStyle/>
+          <a:p>
+            <a:pPr algn="l"/>
+            <a:r>
+              <a:rPr sz="1200" b="0">
+                <a:solidFill>
+                  <a:srgbClr val="3A454F"/>
+                </a:solidFill>
+                <a:latin typeface="Calibri"/>
+              </a:rPr>
+              <a:t>PM and ERP solutions used, mostly not integrated</a:t>
+            </a:r>
+          </a:p>
+        </p:txBody>
+      </p:sp>
+      <p:sp>
+        <p:nvSpPr>
+          <p:cNvPr id="76" name="TextBox 75"/>
+          <p:cNvSpPr txBox="1"/>
+          <p:nvPr/>
+        </p:nvSpPr>
+        <p:spPr>
+          <a:xfrm>
+            <a:off x="7114032" y="5010912"/>
+            <a:ext cx="777240" cy="274320"/>
+          </a:xfrm>
+          <a:prstGeom prst="rect">
+            <a:avLst/>
+          </a:prstGeom>
+          <a:noFill/>
+        </p:spPr>
+        <p:txBody>
+          <a:bodyPr wrap="square" anchor="t"/>
+          <a:lstStyle/>
+          <a:p>
+            <a:pPr algn="r"/>
+            <a:r>
+              <a:rPr sz="1100" b="1">
+                <a:solidFill>
+                  <a:srgbClr val="96641A"/>
+                </a:solidFill>
+                <a:latin typeface="Calibri"/>
+              </a:rPr>
+              <a:t>MEDIUM</a:t>
+            </a:r>
+          </a:p>
+        </p:txBody>
+      </p:sp>
+      <p:sp>
+        <p:nvSpPr>
+          <p:cNvPr id="77" name="Rounded Rectangle 76"/>
           <p:cNvSpPr/>
           <p:nvPr/>
         </p:nvSpPr>
         <p:spPr>
           <a:xfrm>
-            <a:off x="457200" y="5193792"/>
-            <a:ext cx="292608" cy="292608"/>
-          </a:xfrm>
-          <a:prstGeom prst="ellipse">
-            <a:avLst/>
-          </a:prstGeom>
-          <a:solidFill>
-            <a:srgbClr val="0B7F77"/>
+            <a:off x="7973568" y="5084064"/>
+            <a:ext cx="914400" cy="128016"/>
+          </a:xfrm>
+          <a:prstGeom prst="roundRect">
+            <a:avLst>
+              <a:gd name="adj" fmla="val 50000"/>
+            </a:avLst>
+          </a:prstGeom>
+          <a:solidFill>
+            <a:srgbClr val="EDF0F2"/>
           </a:solidFill>
           <a:ln>
             <a:noFill/>
@@ -9705,131 +9969,23 @@
           </a:fontRef>
         </p:style>
         <p:txBody>
-          <a:bodyPr rtlCol="0" anchor="ctr" wrap="none"/>
+          <a:bodyPr rtlCol="0" anchor="ctr"/>
           <a:lstStyle/>
           <a:p>
             <a:pPr algn="ctr"/>
-            <a:r>
-              <a:rPr sz="1100" b="1">
-                <a:solidFill>
-                  <a:srgbClr val="FFFFFF"/>
-                </a:solidFill>
-                <a:latin typeface="Calibri"/>
-              </a:rPr>
-              <a:t>5</a:t>
-            </a:r>
-          </a:p>
-        </p:txBody>
-      </p:sp>
-      <p:sp>
-        <p:nvSpPr>
-          <p:cNvPr id="70" name="TextBox 69"/>
-          <p:cNvSpPr txBox="1"/>
-          <p:nvPr/>
-        </p:nvSpPr>
-        <p:spPr>
-          <a:xfrm>
-            <a:off x="822960" y="5120640"/>
-            <a:ext cx="1536192" cy="512064"/>
-          </a:xfrm>
-          <a:prstGeom prst="rect">
-            <a:avLst/>
-          </a:prstGeom>
-          <a:noFill/>
-        </p:spPr>
-        <p:txBody>
-          <a:bodyPr wrap="square" anchor="t"/>
-          <a:lstStyle/>
-          <a:p>
-            <a:pPr algn="l"/>
-            <a:r>
-              <a:rPr sz="1400" b="1">
-                <a:solidFill>
-                  <a:srgbClr val="26303A"/>
-                </a:solidFill>
-                <a:latin typeface="Calibri"/>
-              </a:rPr>
-              <a:t>Agentic Cost Realization Tracking</a:t>
-            </a:r>
-          </a:p>
-        </p:txBody>
-      </p:sp>
-      <p:sp>
-        <p:nvSpPr>
-          <p:cNvPr id="71" name="TextBox 70"/>
-          <p:cNvSpPr txBox="1"/>
-          <p:nvPr/>
-        </p:nvSpPr>
-        <p:spPr>
-          <a:xfrm>
-            <a:off x="2450592" y="5010912"/>
-            <a:ext cx="960120" cy="292608"/>
-          </a:xfrm>
-          <a:prstGeom prst="rect">
-            <a:avLst/>
-          </a:prstGeom>
-          <a:noFill/>
-        </p:spPr>
-        <p:txBody>
-          <a:bodyPr wrap="square" anchor="t"/>
-          <a:lstStyle/>
-          <a:p>
-            <a:pPr algn="l"/>
-            <a:r>
-              <a:rPr sz="1200" b="1">
-                <a:solidFill>
-                  <a:srgbClr val="0A5F59"/>
-                </a:solidFill>
-                <a:latin typeface="Calibri"/>
-              </a:rPr>
-              <a:t>LEADERS</a:t>
-            </a:r>
-          </a:p>
-        </p:txBody>
-      </p:sp>
-      <p:sp>
-        <p:nvSpPr>
-          <p:cNvPr id="72" name="TextBox 71"/>
-          <p:cNvSpPr txBox="1"/>
-          <p:nvPr/>
-        </p:nvSpPr>
-        <p:spPr>
-          <a:xfrm>
-            <a:off x="3383280" y="5010912"/>
-            <a:ext cx="2194560" cy="292608"/>
-          </a:xfrm>
-          <a:prstGeom prst="rect">
-            <a:avLst/>
-          </a:prstGeom>
-          <a:noFill/>
-        </p:spPr>
-        <p:txBody>
-          <a:bodyPr wrap="square" anchor="t"/>
-          <a:lstStyle/>
-          <a:p>
-            <a:pPr algn="l"/>
-            <a:r>
-              <a:rPr sz="1400" b="0">
-                <a:solidFill>
-                  <a:srgbClr val="3A454F"/>
-                </a:solidFill>
-                <a:latin typeface="Calibri"/>
-              </a:rPr>
-              <a:t>PM platforms, manual reports.</a:t>
-            </a:r>
-          </a:p>
-        </p:txBody>
-      </p:sp>
-      <p:sp>
-        <p:nvSpPr>
-          <p:cNvPr id="73" name="Rounded Rectangle 72"/>
+          </a:p>
+        </p:txBody>
+      </p:sp>
+      <p:sp>
+        <p:nvSpPr>
+          <p:cNvPr id="78" name="Rounded Rectangle 77"/>
           <p:cNvSpPr/>
           <p:nvPr/>
         </p:nvSpPr>
         <p:spPr>
           <a:xfrm>
-            <a:off x="5632704" y="5065776"/>
-            <a:ext cx="868680" cy="128016"/>
+            <a:off x="7973568" y="5084064"/>
+            <a:ext cx="566928" cy="128016"/>
           </a:xfrm>
           <a:prstGeom prst="roundRect">
             <a:avLst>
@@ -9837,7 +9993,7 @@
             </a:avLst>
           </a:prstGeom>
           <a:solidFill>
-            <a:srgbClr val="EDF0F2"/>
+            <a:srgbClr val="D9982F"/>
           </a:solidFill>
           <a:ln>
             <a:noFill/>
@@ -9867,14 +10023,113 @@
       </p:sp>
       <p:sp>
         <p:nvSpPr>
-          <p:cNvPr id="74" name="Rounded Rectangle 73"/>
+          <p:cNvPr id="79" name="TextBox 78"/>
+          <p:cNvSpPr txBox="1"/>
+          <p:nvPr/>
+        </p:nvSpPr>
+        <p:spPr>
+          <a:xfrm>
+            <a:off x="2450592" y="5376672"/>
+            <a:ext cx="914400" cy="274320"/>
+          </a:xfrm>
+          <a:prstGeom prst="rect">
+            <a:avLst/>
+          </a:prstGeom>
+          <a:noFill/>
+        </p:spPr>
+        <p:txBody>
+          <a:bodyPr wrap="square" anchor="t"/>
+          <a:lstStyle/>
+          <a:p>
+            <a:pPr algn="l"/>
+            <a:r>
+              <a:rPr sz="1100" b="1">
+                <a:solidFill>
+                  <a:srgbClr val="9AA3AC"/>
+                </a:solidFill>
+                <a:latin typeface="Calibri"/>
+              </a:rPr>
+              <a:t>DEVELOPING</a:t>
+            </a:r>
+          </a:p>
+        </p:txBody>
+      </p:sp>
+      <p:sp>
+        <p:nvSpPr>
+          <p:cNvPr id="80" name="TextBox 79"/>
+          <p:cNvSpPr txBox="1"/>
+          <p:nvPr/>
+        </p:nvSpPr>
+        <p:spPr>
+          <a:xfrm>
+            <a:off x="3383280" y="5376672"/>
+            <a:ext cx="3703320" cy="329184"/>
+          </a:xfrm>
+          <a:prstGeom prst="rect">
+            <a:avLst/>
+          </a:prstGeom>
+          <a:noFill/>
+        </p:spPr>
+        <p:txBody>
+          <a:bodyPr wrap="square" anchor="t"/>
+          <a:lstStyle/>
+          <a:p>
+            <a:pPr algn="l"/>
+            <a:r>
+              <a:rPr sz="1200" b="0">
+                <a:solidFill>
+                  <a:srgbClr val="3A454F"/>
+                </a:solidFill>
+                <a:latin typeface="Calibri"/>
+              </a:rPr>
+              <a:t>Manual tracking in Excels and e-mails</a:t>
+            </a:r>
+          </a:p>
+        </p:txBody>
+      </p:sp>
+      <p:sp>
+        <p:nvSpPr>
+          <p:cNvPr id="81" name="TextBox 80"/>
+          <p:cNvSpPr txBox="1"/>
+          <p:nvPr/>
+        </p:nvSpPr>
+        <p:spPr>
+          <a:xfrm>
+            <a:off x="7114032" y="5376672"/>
+            <a:ext cx="777240" cy="274320"/>
+          </a:xfrm>
+          <a:prstGeom prst="rect">
+            <a:avLst/>
+          </a:prstGeom>
+          <a:noFill/>
+        </p:spPr>
+        <p:txBody>
+          <a:bodyPr wrap="square" anchor="t"/>
+          <a:lstStyle/>
+          <a:p>
+            <a:pPr algn="r"/>
+            <a:r>
+              <a:rPr sz="1100" b="1">
+                <a:solidFill>
+                  <a:srgbClr val="96641A"/>
+                </a:solidFill>
+                <a:latin typeface="Calibri"/>
+              </a:rPr>
+              <a:t>MEDIUM</a:t>
+            </a:r>
+          </a:p>
+        </p:txBody>
+      </p:sp>
+      <p:sp>
+        <p:nvSpPr>
+          <p:cNvPr id="82" name="Rounded Rectangle 81"/>
           <p:cNvSpPr/>
           <p:nvPr/>
         </p:nvSpPr>
         <p:spPr>
           <a:xfrm>
-            <a:off x="5632704" y="5065776"/>
-            <a:ext cx="694944" cy="128016"/>
+            <a:off x="7973568" y="5449824"/>
+            <a:ext cx="914400" cy="128016"/>
           </a:xfrm>
           <a:prstGeom prst="roundRect">
             <a:avLst>
@@ -9882,7 +10137,7 @@
             </a:avLst>
           </a:prstGeom>
           <a:solidFill>
-            <a:srgbClr val="D9982F"/>
+            <a:srgbClr val="EDF0F2"/>
           </a:solidFill>
           <a:ln>
             <a:noFill/>
@@ -9912,80 +10167,14 @@
       </p:sp>
       <p:sp>
         <p:nvSpPr>
-          <p:cNvPr id="75" name="TextBox 74"/>
-          <p:cNvSpPr txBox="1"/>
-          <p:nvPr/>
-        </p:nvSpPr>
-        <p:spPr>
-          <a:xfrm>
-            <a:off x="2450592" y="5376672"/>
-            <a:ext cx="960120" cy="292608"/>
-          </a:xfrm>
-          <a:prstGeom prst="rect">
-            <a:avLst/>
-          </a:prstGeom>
-          <a:noFill/>
-        </p:spPr>
-        <p:txBody>
-          <a:bodyPr wrap="square" anchor="t"/>
-          <a:lstStyle/>
-          <a:p>
-            <a:pPr algn="l"/>
-            <a:r>
-              <a:rPr sz="1200" b="1">
-                <a:solidFill>
-                  <a:srgbClr val="9AA3AC"/>
-                </a:solidFill>
-                <a:latin typeface="Calibri"/>
-              </a:rPr>
-              <a:t>DEVELOPING</a:t>
-            </a:r>
-          </a:p>
-        </p:txBody>
-      </p:sp>
-      <p:sp>
-        <p:nvSpPr>
-          <p:cNvPr id="76" name="TextBox 75"/>
-          <p:cNvSpPr txBox="1"/>
-          <p:nvPr/>
-        </p:nvSpPr>
-        <p:spPr>
-          <a:xfrm>
-            <a:off x="3383280" y="5376672"/>
-            <a:ext cx="2194560" cy="292608"/>
-          </a:xfrm>
-          <a:prstGeom prst="rect">
-            <a:avLst/>
-          </a:prstGeom>
-          <a:noFill/>
-        </p:spPr>
-        <p:txBody>
-          <a:bodyPr wrap="square" anchor="t"/>
-          <a:lstStyle/>
-          <a:p>
-            <a:pPr algn="l"/>
-            <a:r>
-              <a:rPr sz="1400" b="0">
-                <a:solidFill>
-                  <a:srgbClr val="3A454F"/>
-                </a:solidFill>
-                <a:latin typeface="Calibri"/>
-              </a:rPr>
-              <a:t>Spreadsheets and site walks.</a:t>
-            </a:r>
-          </a:p>
-        </p:txBody>
-      </p:sp>
-      <p:sp>
-        <p:nvSpPr>
-          <p:cNvPr id="77" name="Rounded Rectangle 76"/>
+          <p:cNvPr id="83" name="Rounded Rectangle 82"/>
           <p:cNvSpPr/>
           <p:nvPr/>
         </p:nvSpPr>
         <p:spPr>
           <a:xfrm>
-            <a:off x="5632704" y="5431536"/>
-            <a:ext cx="868680" cy="128016"/>
+            <a:off x="7973568" y="5449824"/>
+            <a:ext cx="566928" cy="128016"/>
           </a:xfrm>
           <a:prstGeom prst="roundRect">
             <a:avLst>
@@ -9993,7 +10182,7 @@
             </a:avLst>
           </a:prstGeom>
           <a:solidFill>
-            <a:srgbClr val="EDF0F2"/>
+            <a:srgbClr val="D9982F"/>
           </a:solidFill>
           <a:ln>
             <a:noFill/>
@@ -10023,22 +10212,22 @@
       </p:sp>
       <p:sp>
         <p:nvSpPr>
-          <p:cNvPr id="78" name="Rounded Rectangle 77"/>
+          <p:cNvPr id="84" name="Rounded Rectangle 83"/>
           <p:cNvSpPr/>
           <p:nvPr/>
         </p:nvSpPr>
         <p:spPr>
           <a:xfrm>
-            <a:off x="5632704" y="5431536"/>
-            <a:ext cx="816559" cy="128016"/>
+            <a:off x="9098280" y="5010912"/>
+            <a:ext cx="2706624" cy="658368"/>
           </a:xfrm>
           <a:prstGeom prst="roundRect">
             <a:avLst>
-              <a:gd name="adj" fmla="val 50000"/>
+              <a:gd name="adj" fmla="val 4000"/>
             </a:avLst>
           </a:prstGeom>
           <a:solidFill>
-            <a:srgbClr val="C0453B"/>
+            <a:srgbClr val="E4F1EF"/>
           </a:solidFill>
           <a:ln>
             <a:noFill/>
@@ -10059,64 +10248,38 @@
           </a:fontRef>
         </p:style>
         <p:txBody>
-          <a:bodyPr rtlCol="0" anchor="ctr"/>
-          <a:lstStyle/>
-          <a:p>
-            <a:pPr algn="ctr"/>
-          </a:p>
-        </p:txBody>
-      </p:sp>
-      <p:sp>
-        <p:nvSpPr>
-          <p:cNvPr id="79" name="TextBox 78"/>
-          <p:cNvSpPr txBox="1"/>
-          <p:nvPr/>
-        </p:nvSpPr>
-        <p:spPr>
-          <a:xfrm>
-            <a:off x="6693408" y="5102352"/>
-            <a:ext cx="2267712" cy="530352"/>
-          </a:xfrm>
-          <a:prstGeom prst="rect">
-            <a:avLst/>
-          </a:prstGeom>
-          <a:noFill/>
-        </p:spPr>
-        <p:txBody>
-          <a:bodyPr wrap="square" anchor="t"/>
+          <a:bodyPr rtlCol="0" anchor="ctr" wrap="square" lIns="73152" rIns="73152" tIns="36576" bIns="36576"/>
           <a:lstStyle/>
           <a:p>
             <a:pPr algn="l"/>
             <a:r>
-              <a:rPr sz="1400" b="0">
-                <a:solidFill>
-                  <a:srgbClr val="26303A"/>
-                </a:solidFill>
-                <a:latin typeface="Calibri"/>
-              </a:rPr>
-              <a:t>Overruns surface once irreversible.</a:t>
-            </a:r>
-          </a:p>
-        </p:txBody>
-      </p:sp>
-      <p:sp>
-        <p:nvSpPr>
-          <p:cNvPr id="80" name="Rounded Rectangle 79"/>
+              <a:rPr sz="1200" b="1">
+                <a:solidFill>
+                  <a:srgbClr val="0A5F59"/>
+                </a:solidFill>
+                <a:latin typeface="Calibri"/>
+              </a:rPr>
+              <a:t>Predicts future delays from historical realizations</a:t>
+            </a:r>
+          </a:p>
+        </p:txBody>
+      </p:sp>
+      <p:sp>
+        <p:nvSpPr>
+          <p:cNvPr id="85" name="Rectangle 84"/>
           <p:cNvSpPr/>
           <p:nvPr/>
         </p:nvSpPr>
         <p:spPr>
           <a:xfrm>
-            <a:off x="9061704" y="5029200"/>
-            <a:ext cx="2743200" cy="640080"/>
-          </a:xfrm>
-          <a:prstGeom prst="roundRect">
-            <a:avLst>
-              <a:gd name="adj" fmla="val 4000"/>
-            </a:avLst>
-          </a:prstGeom>
-          <a:solidFill>
-            <a:srgbClr val="E4F1EF"/>
+            <a:off x="384048" y="6519672"/>
+            <a:ext cx="11420856" cy="9144"/>
+          </a:xfrm>
+          <a:prstGeom prst="rect">
+            <a:avLst/>
+          </a:prstGeom>
+          <a:solidFill>
+            <a:srgbClr val="E3E8E9"/>
           </a:solidFill>
           <a:ln>
             <a:noFill/>
@@ -10137,38 +10300,29 @@
           </a:fontRef>
         </p:style>
         <p:txBody>
-          <a:bodyPr rtlCol="0" anchor="ctr" wrap="square" lIns="73152" rIns="73152" tIns="36576" bIns="36576"/>
-          <a:lstStyle/>
-          <a:p>
-            <a:pPr algn="l"/>
-            <a:r>
-              <a:rPr sz="1400" b="1">
-                <a:solidFill>
-                  <a:srgbClr val="0A5F59"/>
-                </a:solidFill>
-                <a:latin typeface="Calibri"/>
-              </a:rPr>
-              <a:t>AI checks quantities and progress, and flags mismatches early.</a:t>
-            </a:r>
-          </a:p>
-        </p:txBody>
-      </p:sp>
-      <p:sp>
-        <p:nvSpPr>
-          <p:cNvPr id="81" name="Rectangle 80"/>
+          <a:bodyPr rtlCol="0" anchor="ctr"/>
+          <a:lstStyle/>
+          <a:p>
+            <a:pPr algn="ctr"/>
+          </a:p>
+        </p:txBody>
+      </p:sp>
+      <p:sp>
+        <p:nvSpPr>
+          <p:cNvPr id="86" name="Oval 85"/>
           <p:cNvSpPr/>
           <p:nvPr/>
         </p:nvSpPr>
         <p:spPr>
           <a:xfrm>
-            <a:off x="384048" y="6519672"/>
-            <a:ext cx="11420856" cy="9144"/>
-          </a:xfrm>
-          <a:prstGeom prst="rect">
-            <a:avLst/>
-          </a:prstGeom>
-          <a:solidFill>
-            <a:srgbClr val="E3E8E9"/>
+            <a:off x="457200" y="5980176"/>
+            <a:ext cx="292608" cy="292608"/>
+          </a:xfrm>
+          <a:prstGeom prst="ellipse">
+            <a:avLst/>
+          </a:prstGeom>
+          <a:solidFill>
+            <a:srgbClr val="B97D1E"/>
           </a:solidFill>
           <a:ln>
             <a:noFill/>
@@ -10189,29 +10343,172 @@
           </a:fontRef>
         </p:style>
         <p:txBody>
-          <a:bodyPr rtlCol="0" anchor="ctr"/>
+          <a:bodyPr rtlCol="0" anchor="ctr" wrap="none"/>
           <a:lstStyle/>
           <a:p>
             <a:pPr algn="ctr"/>
-          </a:p>
-        </p:txBody>
-      </p:sp>
-      <p:sp>
-        <p:nvSpPr>
-          <p:cNvPr id="82" name="Oval 81"/>
+            <a:r>
+              <a:rPr sz="1100" b="1">
+                <a:solidFill>
+                  <a:srgbClr val="FFFFFF"/>
+                </a:solidFill>
+                <a:latin typeface="Calibri"/>
+              </a:rPr>
+              <a:t>6</a:t>
+            </a:r>
+          </a:p>
+        </p:txBody>
+      </p:sp>
+      <p:sp>
+        <p:nvSpPr>
+          <p:cNvPr id="87" name="TextBox 86"/>
+          <p:cNvSpPr txBox="1"/>
+          <p:nvPr/>
+        </p:nvSpPr>
+        <p:spPr>
+          <a:xfrm>
+            <a:off x="822960" y="5907024"/>
+            <a:ext cx="1536192" cy="512064"/>
+          </a:xfrm>
+          <a:prstGeom prst="rect">
+            <a:avLst/>
+          </a:prstGeom>
+          <a:noFill/>
+        </p:spPr>
+        <p:txBody>
+          <a:bodyPr wrap="square" anchor="t"/>
+          <a:lstStyle/>
+          <a:p>
+            <a:pPr algn="l"/>
+            <a:r>
+              <a:rPr sz="1300" b="1">
+                <a:solidFill>
+                  <a:srgbClr val="26303A"/>
+                </a:solidFill>
+                <a:latin typeface="Calibri"/>
+              </a:rPr>
+              <a:t>AI-Based Value Optimizer</a:t>
+            </a:r>
+          </a:p>
+        </p:txBody>
+      </p:sp>
+      <p:sp>
+        <p:nvSpPr>
+          <p:cNvPr id="88" name="TextBox 87"/>
+          <p:cNvSpPr txBox="1"/>
+          <p:nvPr/>
+        </p:nvSpPr>
+        <p:spPr>
+          <a:xfrm>
+            <a:off x="2450592" y="5797296"/>
+            <a:ext cx="914400" cy="274320"/>
+          </a:xfrm>
+          <a:prstGeom prst="rect">
+            <a:avLst/>
+          </a:prstGeom>
+          <a:noFill/>
+        </p:spPr>
+        <p:txBody>
+          <a:bodyPr wrap="square" anchor="t"/>
+          <a:lstStyle/>
+          <a:p>
+            <a:pPr algn="l"/>
+            <a:r>
+              <a:rPr sz="1100" b="1">
+                <a:solidFill>
+                  <a:srgbClr val="0A5F59"/>
+                </a:solidFill>
+                <a:latin typeface="Calibri"/>
+              </a:rPr>
+              <a:t>LEADERS</a:t>
+            </a:r>
+          </a:p>
+        </p:txBody>
+      </p:sp>
+      <p:sp>
+        <p:nvSpPr>
+          <p:cNvPr id="89" name="TextBox 88"/>
+          <p:cNvSpPr txBox="1"/>
+          <p:nvPr/>
+        </p:nvSpPr>
+        <p:spPr>
+          <a:xfrm>
+            <a:off x="3383280" y="5797296"/>
+            <a:ext cx="3703320" cy="329184"/>
+          </a:xfrm>
+          <a:prstGeom prst="rect">
+            <a:avLst/>
+          </a:prstGeom>
+          <a:noFill/>
+        </p:spPr>
+        <p:txBody>
+          <a:bodyPr wrap="square" anchor="t"/>
+          <a:lstStyle/>
+          <a:p>
+            <a:pPr algn="l"/>
+            <a:r>
+              <a:rPr sz="1200" b="0">
+                <a:solidFill>
+                  <a:srgbClr val="3A454F"/>
+                </a:solidFill>
+                <a:latin typeface="Calibri"/>
+              </a:rPr>
+              <a:t>Expert-led value engineering with limited AI use</a:t>
+            </a:r>
+          </a:p>
+        </p:txBody>
+      </p:sp>
+      <p:sp>
+        <p:nvSpPr>
+          <p:cNvPr id="90" name="TextBox 89"/>
+          <p:cNvSpPr txBox="1"/>
+          <p:nvPr/>
+        </p:nvSpPr>
+        <p:spPr>
+          <a:xfrm>
+            <a:off x="7114032" y="5797296"/>
+            <a:ext cx="777240" cy="274320"/>
+          </a:xfrm>
+          <a:prstGeom prst="rect">
+            <a:avLst/>
+          </a:prstGeom>
+          <a:noFill/>
+        </p:spPr>
+        <p:txBody>
+          <a:bodyPr wrap="square" anchor="t"/>
+          <a:lstStyle/>
+          <a:p>
+            <a:pPr algn="r"/>
+            <a:r>
+              <a:rPr sz="1100" b="1">
+                <a:solidFill>
+                  <a:srgbClr val="A8392C"/>
+                </a:solidFill>
+                <a:latin typeface="Calibri"/>
+              </a:rPr>
+              <a:t>HIGH</a:t>
+            </a:r>
+          </a:p>
+        </p:txBody>
+      </p:sp>
+      <p:sp>
+        <p:nvSpPr>
+          <p:cNvPr id="91" name="Rounded Rectangle 90"/>
           <p:cNvSpPr/>
           <p:nvPr/>
         </p:nvSpPr>
         <p:spPr>
           <a:xfrm>
-            <a:off x="457200" y="5980176"/>
-            <a:ext cx="292608" cy="292608"/>
-          </a:xfrm>
-          <a:prstGeom prst="ellipse">
-            <a:avLst/>
-          </a:prstGeom>
-          <a:solidFill>
-            <a:srgbClr val="B97D1E"/>
+            <a:off x="7973568" y="5870448"/>
+            <a:ext cx="914400" cy="128016"/>
+          </a:xfrm>
+          <a:prstGeom prst="roundRect">
+            <a:avLst>
+              <a:gd name="adj" fmla="val 50000"/>
+            </a:avLst>
+          </a:prstGeom>
+          <a:solidFill>
+            <a:srgbClr val="EDF0F2"/>
           </a:solidFill>
           <a:ln>
             <a:noFill/>
@@ -10232,131 +10529,23 @@
           </a:fontRef>
         </p:style>
         <p:txBody>
-          <a:bodyPr rtlCol="0" anchor="ctr" wrap="none"/>
+          <a:bodyPr rtlCol="0" anchor="ctr"/>
           <a:lstStyle/>
           <a:p>
             <a:pPr algn="ctr"/>
-            <a:r>
-              <a:rPr sz="1100" b="1">
-                <a:solidFill>
-                  <a:srgbClr val="FFFFFF"/>
-                </a:solidFill>
-                <a:latin typeface="Calibri"/>
-              </a:rPr>
-              <a:t>6</a:t>
-            </a:r>
-          </a:p>
-        </p:txBody>
-      </p:sp>
-      <p:sp>
-        <p:nvSpPr>
-          <p:cNvPr id="83" name="TextBox 82"/>
-          <p:cNvSpPr txBox="1"/>
-          <p:nvPr/>
-        </p:nvSpPr>
-        <p:spPr>
-          <a:xfrm>
-            <a:off x="822960" y="5907024"/>
-            <a:ext cx="1536192" cy="512064"/>
-          </a:xfrm>
-          <a:prstGeom prst="rect">
-            <a:avLst/>
-          </a:prstGeom>
-          <a:noFill/>
-        </p:spPr>
-        <p:txBody>
-          <a:bodyPr wrap="square" anchor="t"/>
-          <a:lstStyle/>
-          <a:p>
-            <a:pPr algn="l"/>
-            <a:r>
-              <a:rPr sz="1400" b="1">
-                <a:solidFill>
-                  <a:srgbClr val="26303A"/>
-                </a:solidFill>
-                <a:latin typeface="Calibri"/>
-              </a:rPr>
-              <a:t>AI-Based Value Optimizer</a:t>
-            </a:r>
-          </a:p>
-        </p:txBody>
-      </p:sp>
-      <p:sp>
-        <p:nvSpPr>
-          <p:cNvPr id="84" name="TextBox 83"/>
-          <p:cNvSpPr txBox="1"/>
-          <p:nvPr/>
-        </p:nvSpPr>
-        <p:spPr>
-          <a:xfrm>
-            <a:off x="2450592" y="5797296"/>
-            <a:ext cx="960120" cy="292608"/>
-          </a:xfrm>
-          <a:prstGeom prst="rect">
-            <a:avLst/>
-          </a:prstGeom>
-          <a:noFill/>
-        </p:spPr>
-        <p:txBody>
-          <a:bodyPr wrap="square" anchor="t"/>
-          <a:lstStyle/>
-          <a:p>
-            <a:pPr algn="l"/>
-            <a:r>
-              <a:rPr sz="1200" b="1">
-                <a:solidFill>
-                  <a:srgbClr val="0A5F59"/>
-                </a:solidFill>
-                <a:latin typeface="Calibri"/>
-              </a:rPr>
-              <a:t>LEADERS</a:t>
-            </a:r>
-          </a:p>
-        </p:txBody>
-      </p:sp>
-      <p:sp>
-        <p:nvSpPr>
-          <p:cNvPr id="85" name="TextBox 84"/>
-          <p:cNvSpPr txBox="1"/>
-          <p:nvPr/>
-        </p:nvSpPr>
-        <p:spPr>
-          <a:xfrm>
-            <a:off x="3383280" y="5797296"/>
-            <a:ext cx="2194560" cy="292608"/>
-          </a:xfrm>
-          <a:prstGeom prst="rect">
-            <a:avLst/>
-          </a:prstGeom>
-          <a:noFill/>
-        </p:spPr>
-        <p:txBody>
-          <a:bodyPr wrap="square" anchor="t"/>
-          <a:lstStyle/>
-          <a:p>
-            <a:pPr algn="l"/>
-            <a:r>
-              <a:rPr sz="1400" b="0">
-                <a:solidFill>
-                  <a:srgbClr val="3A454F"/>
-                </a:solidFill>
-                <a:latin typeface="Calibri"/>
-              </a:rPr>
-              <a:t>Value engineering at gates.</a:t>
-            </a:r>
-          </a:p>
-        </p:txBody>
-      </p:sp>
-      <p:sp>
-        <p:nvSpPr>
-          <p:cNvPr id="86" name="Rounded Rectangle 85"/>
+          </a:p>
+        </p:txBody>
+      </p:sp>
+      <p:sp>
+        <p:nvSpPr>
+          <p:cNvPr id="92" name="Rounded Rectangle 91"/>
           <p:cNvSpPr/>
           <p:nvPr/>
         </p:nvSpPr>
         <p:spPr>
           <a:xfrm>
-            <a:off x="5632704" y="5852160"/>
-            <a:ext cx="868680" cy="128016"/>
+            <a:off x="7973568" y="5870448"/>
+            <a:ext cx="841248" cy="128016"/>
           </a:xfrm>
           <a:prstGeom prst="roundRect">
             <a:avLst>
@@ -10364,7 +10553,7 @@
             </a:avLst>
           </a:prstGeom>
           <a:solidFill>
-            <a:srgbClr val="EDF0F2"/>
+            <a:srgbClr val="C0453B"/>
           </a:solidFill>
           <a:ln>
             <a:noFill/>
@@ -10394,14 +10583,113 @@
       </p:sp>
       <p:sp>
         <p:nvSpPr>
-          <p:cNvPr id="87" name="Rounded Rectangle 86"/>
+          <p:cNvPr id="93" name="TextBox 92"/>
+          <p:cNvSpPr txBox="1"/>
+          <p:nvPr/>
+        </p:nvSpPr>
+        <p:spPr>
+          <a:xfrm>
+            <a:off x="2450592" y="6163056"/>
+            <a:ext cx="914400" cy="274320"/>
+          </a:xfrm>
+          <a:prstGeom prst="rect">
+            <a:avLst/>
+          </a:prstGeom>
+          <a:noFill/>
+        </p:spPr>
+        <p:txBody>
+          <a:bodyPr wrap="square" anchor="t"/>
+          <a:lstStyle/>
+          <a:p>
+            <a:pPr algn="l"/>
+            <a:r>
+              <a:rPr sz="1100" b="1">
+                <a:solidFill>
+                  <a:srgbClr val="9AA3AC"/>
+                </a:solidFill>
+                <a:latin typeface="Calibri"/>
+              </a:rPr>
+              <a:t>DEVELOPING</a:t>
+            </a:r>
+          </a:p>
+        </p:txBody>
+      </p:sp>
+      <p:sp>
+        <p:nvSpPr>
+          <p:cNvPr id="94" name="TextBox 93"/>
+          <p:cNvSpPr txBox="1"/>
+          <p:nvPr/>
+        </p:nvSpPr>
+        <p:spPr>
+          <a:xfrm>
+            <a:off x="3383280" y="6163056"/>
+            <a:ext cx="3703320" cy="329184"/>
+          </a:xfrm>
+          <a:prstGeom prst="rect">
+            <a:avLst/>
+          </a:prstGeom>
+          <a:noFill/>
+        </p:spPr>
+        <p:txBody>
+          <a:bodyPr wrap="square" anchor="t"/>
+          <a:lstStyle/>
+          <a:p>
+            <a:pPr algn="l"/>
+            <a:r>
+              <a:rPr sz="1200" b="0">
+                <a:solidFill>
+                  <a:srgbClr val="3A454F"/>
+                </a:solidFill>
+                <a:latin typeface="Calibri"/>
+              </a:rPr>
+              <a:t>Most value opportunities are not recognized</a:t>
+            </a:r>
+          </a:p>
+        </p:txBody>
+      </p:sp>
+      <p:sp>
+        <p:nvSpPr>
+          <p:cNvPr id="95" name="TextBox 94"/>
+          <p:cNvSpPr txBox="1"/>
+          <p:nvPr/>
+        </p:nvSpPr>
+        <p:spPr>
+          <a:xfrm>
+            <a:off x="7114032" y="6163056"/>
+            <a:ext cx="777240" cy="274320"/>
+          </a:xfrm>
+          <a:prstGeom prst="rect">
+            <a:avLst/>
+          </a:prstGeom>
+          <a:noFill/>
+        </p:spPr>
+        <p:txBody>
+          <a:bodyPr wrap="square" anchor="t"/>
+          <a:lstStyle/>
+          <a:p>
+            <a:pPr algn="r"/>
+            <a:r>
+              <a:rPr sz="1100" b="1">
+                <a:solidFill>
+                  <a:srgbClr val="A8392C"/>
+                </a:solidFill>
+                <a:latin typeface="Calibri"/>
+              </a:rPr>
+              <a:t>HIGH</a:t>
+            </a:r>
+          </a:p>
+        </p:txBody>
+      </p:sp>
+      <p:sp>
+        <p:nvSpPr>
+          <p:cNvPr id="96" name="Rounded Rectangle 95"/>
           <p:cNvSpPr/>
           <p:nvPr/>
         </p:nvSpPr>
         <p:spPr>
           <a:xfrm>
-            <a:off x="5632704" y="5852160"/>
-            <a:ext cx="416966" cy="128016"/>
+            <a:off x="7973568" y="6236208"/>
+            <a:ext cx="914400" cy="128016"/>
           </a:xfrm>
           <a:prstGeom prst="roundRect">
             <a:avLst>
@@ -10409,7 +10697,7 @@
             </a:avLst>
           </a:prstGeom>
           <a:solidFill>
-            <a:srgbClr val="98A2AB"/>
+            <a:srgbClr val="EDF0F2"/>
           </a:solidFill>
           <a:ln>
             <a:noFill/>
@@ -10439,80 +10727,14 @@
       </p:sp>
       <p:sp>
         <p:nvSpPr>
-          <p:cNvPr id="88" name="TextBox 87"/>
-          <p:cNvSpPr txBox="1"/>
-          <p:nvPr/>
-        </p:nvSpPr>
-        <p:spPr>
-          <a:xfrm>
-            <a:off x="2450592" y="6163056"/>
-            <a:ext cx="960120" cy="292608"/>
-          </a:xfrm>
-          <a:prstGeom prst="rect">
-            <a:avLst/>
-          </a:prstGeom>
-          <a:noFill/>
-        </p:spPr>
-        <p:txBody>
-          <a:bodyPr wrap="square" anchor="t"/>
-          <a:lstStyle/>
-          <a:p>
-            <a:pPr algn="l"/>
-            <a:r>
-              <a:rPr sz="1200" b="1">
-                <a:solidFill>
-                  <a:srgbClr val="9AA3AC"/>
-                </a:solidFill>
-                <a:latin typeface="Calibri"/>
-              </a:rPr>
-              <a:t>DEVELOPING</a:t>
-            </a:r>
-          </a:p>
-        </p:txBody>
-      </p:sp>
-      <p:sp>
-        <p:nvSpPr>
-          <p:cNvPr id="89" name="TextBox 88"/>
-          <p:cNvSpPr txBox="1"/>
-          <p:nvPr/>
-        </p:nvSpPr>
-        <p:spPr>
-          <a:xfrm>
-            <a:off x="3383280" y="6163056"/>
-            <a:ext cx="2194560" cy="292608"/>
-          </a:xfrm>
-          <a:prstGeom prst="rect">
-            <a:avLst/>
-          </a:prstGeom>
-          <a:noFill/>
-        </p:spPr>
-        <p:txBody>
-          <a:bodyPr wrap="square" anchor="t"/>
-          <a:lstStyle/>
-          <a:p>
-            <a:pPr algn="l"/>
-            <a:r>
-              <a:rPr sz="1400" b="0">
-                <a:solidFill>
-                  <a:srgbClr val="3A454F"/>
-                </a:solidFill>
-                <a:latin typeface="Calibri"/>
-              </a:rPr>
-              <a:t>Cost cuts after the breach.</a:t>
-            </a:r>
-          </a:p>
-        </p:txBody>
-      </p:sp>
-      <p:sp>
-        <p:nvSpPr>
-          <p:cNvPr id="90" name="Rounded Rectangle 89"/>
+          <p:cNvPr id="97" name="Rounded Rectangle 96"/>
           <p:cNvSpPr/>
           <p:nvPr/>
         </p:nvSpPr>
         <p:spPr>
           <a:xfrm>
-            <a:off x="5632704" y="6217920"/>
-            <a:ext cx="868680" cy="128016"/>
+            <a:off x="7973568" y="6236208"/>
+            <a:ext cx="841248" cy="128016"/>
           </a:xfrm>
           <a:prstGeom prst="roundRect">
             <a:avLst>
@@ -10520,7 +10742,7 @@
             </a:avLst>
           </a:prstGeom>
           <a:solidFill>
-            <a:srgbClr val="EDF0F2"/>
+            <a:srgbClr val="C0453B"/>
           </a:solidFill>
           <a:ln>
             <a:noFill/>
@@ -10550,22 +10772,22 @@
       </p:sp>
       <p:sp>
         <p:nvSpPr>
-          <p:cNvPr id="91" name="Rounded Rectangle 90"/>
+          <p:cNvPr id="98" name="Rounded Rectangle 97"/>
           <p:cNvSpPr/>
           <p:nvPr/>
         </p:nvSpPr>
         <p:spPr>
           <a:xfrm>
-            <a:off x="5632704" y="6217920"/>
-            <a:ext cx="642823" cy="128016"/>
+            <a:off x="9098280" y="5797296"/>
+            <a:ext cx="2706624" cy="658368"/>
           </a:xfrm>
           <a:prstGeom prst="roundRect">
             <a:avLst>
-              <a:gd name="adj" fmla="val 50000"/>
+              <a:gd name="adj" fmla="val 4000"/>
             </a:avLst>
           </a:prstGeom>
           <a:solidFill>
-            <a:srgbClr val="D9982F"/>
+            <a:srgbClr val="E4F1EF"/>
           </a:solidFill>
           <a:ln>
             <a:noFill/>
@@ -10586,96 +10808,18 @@
           </a:fontRef>
         </p:style>
         <p:txBody>
-          <a:bodyPr rtlCol="0" anchor="ctr"/>
-          <a:lstStyle/>
-          <a:p>
-            <a:pPr algn="ctr"/>
-          </a:p>
-        </p:txBody>
-      </p:sp>
-      <p:sp>
-        <p:nvSpPr>
-          <p:cNvPr id="92" name="TextBox 91"/>
-          <p:cNvSpPr txBox="1"/>
-          <p:nvPr/>
-        </p:nvSpPr>
-        <p:spPr>
-          <a:xfrm>
-            <a:off x="6693408" y="5888736"/>
-            <a:ext cx="2267712" cy="530352"/>
-          </a:xfrm>
-          <a:prstGeom prst="rect">
-            <a:avLst/>
-          </a:prstGeom>
-          <a:noFill/>
-        </p:spPr>
-        <p:txBody>
-          <a:bodyPr wrap="square" anchor="t"/>
+          <a:bodyPr rtlCol="0" anchor="ctr" wrap="square" lIns="73152" rIns="73152" tIns="36576" bIns="36576"/>
           <a:lstStyle/>
           <a:p>
             <a:pPr algn="l"/>
             <a:r>
-              <a:rPr sz="1400" b="0">
-                <a:solidFill>
-                  <a:srgbClr val="26303A"/>
-                </a:solidFill>
-                <a:latin typeface="Calibri"/>
-              </a:rPr>
-              <a:t>Savings found too late to design in.</a:t>
-            </a:r>
-          </a:p>
-        </p:txBody>
-      </p:sp>
-      <p:sp>
-        <p:nvSpPr>
-          <p:cNvPr id="93" name="Rounded Rectangle 92"/>
-          <p:cNvSpPr/>
-          <p:nvPr/>
-        </p:nvSpPr>
-        <p:spPr>
-          <a:xfrm>
-            <a:off x="9061704" y="5815584"/>
-            <a:ext cx="2743200" cy="640080"/>
-          </a:xfrm>
-          <a:prstGeom prst="roundRect">
-            <a:avLst>
-              <a:gd name="adj" fmla="val 4000"/>
-            </a:avLst>
-          </a:prstGeom>
-          <a:solidFill>
-            <a:srgbClr val="E4F1EF"/>
-          </a:solidFill>
-          <a:ln>
-            <a:noFill/>
-          </a:ln>
-        </p:spPr>
-        <p:style>
-          <a:lnRef idx="1">
-            <a:schemeClr val="accent1"/>
-          </a:lnRef>
-          <a:fillRef idx="3">
-            <a:schemeClr val="accent1"/>
-          </a:fillRef>
-          <a:effectRef idx="2">
-            <a:schemeClr val="accent1"/>
-          </a:effectRef>
-          <a:fontRef idx="minor">
-            <a:schemeClr val="lt1"/>
-          </a:fontRef>
-        </p:style>
-        <p:txBody>
-          <a:bodyPr rtlCol="0" anchor="ctr" wrap="square" lIns="73152" rIns="73152" tIns="36576" bIns="36576"/>
-          <a:lstStyle/>
-          <a:p>
-            <a:pPr algn="l"/>
-            <a:r>
-              <a:rPr sz="1400" b="1">
+              <a:rPr sz="1200" b="1">
                 <a:solidFill>
                   <a:srgbClr val="0A5F59"/>
                 </a:solidFill>
                 <a:latin typeface="Calibri"/>
               </a:rPr>
-              <a:t>An always-on loop that surfaces savings as work proceeds.</a:t>
+              <a:t>Not just savings — identifies opportunities and predicts future risks and issues</a:t>
             </a:r>
           </a:p>
         </p:txBody>

</xml_diff>

<commit_message>
Page 4: full-height coverage box with comment and players stacked beside it
Co-authored-by: ersoysarp <ersoysarp@users.noreply.github.com>
</commit_message>
<xml_diff>
--- a/BlueCurrency.pptx
+++ b/BlueCurrency.pptx
@@ -715,7 +715,7 @@
           <a:lstStyle/>
           <a:p>
             <a:r>
-              <a:t>Page 4. Competitive deep dive. Box colour is the group's coverage of that module, not each vendor.</a:t>
+              <a:t>Page 4. Competitive deep dive. Badge colour is the group's coverage of that module, not each vendor.</a:t>
             </a:r>
           </a:p>
           <a:p/>
@@ -12813,7 +12813,7 @@
         <p:spPr>
           <a:xfrm>
             <a:off x="384048" y="1170432"/>
-            <a:ext cx="2697480" cy="329184"/>
+            <a:ext cx="2962656" cy="329184"/>
           </a:xfrm>
           <a:prstGeom prst="roundRect">
             <a:avLst>
@@ -12866,8 +12866,8 @@
         </p:nvSpPr>
         <p:spPr>
           <a:xfrm>
-            <a:off x="3154680" y="1170432"/>
-            <a:ext cx="4297680" cy="329184"/>
+            <a:off x="3419856" y="1170432"/>
+            <a:ext cx="4151376" cy="329184"/>
           </a:xfrm>
           <a:prstGeom prst="roundRect">
             <a:avLst>
@@ -12920,8 +12920,8 @@
         </p:nvSpPr>
         <p:spPr>
           <a:xfrm>
-            <a:off x="7525512" y="1170432"/>
-            <a:ext cx="4279392" cy="329184"/>
+            <a:off x="7644383" y="1170432"/>
+            <a:ext cx="4142232" cy="329184"/>
           </a:xfrm>
           <a:prstGeom prst="roundRect">
             <a:avLst>
@@ -12975,7 +12975,7 @@
         <p:spPr>
           <a:xfrm>
             <a:off x="384048" y="2331720"/>
-            <a:ext cx="2697480" cy="9144"/>
+            <a:ext cx="2962656" cy="9144"/>
           </a:xfrm>
           <a:prstGeom prst="rect">
             <a:avLst/>
@@ -13070,7 +13070,7 @@
         <p:spPr>
           <a:xfrm>
             <a:off x="768096" y="1627632"/>
-            <a:ext cx="2240280" cy="329184"/>
+            <a:ext cx="2505456" cy="329184"/>
           </a:xfrm>
           <a:prstGeom prst="rect">
             <a:avLst/>
@@ -13103,7 +13103,7 @@
         <p:spPr>
           <a:xfrm>
             <a:off x="457200" y="1993392"/>
-            <a:ext cx="2523744" cy="274320"/>
+            <a:ext cx="2788920" cy="274320"/>
           </a:xfrm>
           <a:prstGeom prst="roundRect">
             <a:avLst>
@@ -13165,8 +13165,8 @@
         </p:nvSpPr>
         <p:spPr>
           <a:xfrm>
-            <a:off x="3154680" y="2331720"/>
-            <a:ext cx="4297680" cy="9144"/>
+            <a:off x="3419856" y="2331720"/>
+            <a:ext cx="4151376" cy="9144"/>
           </a:xfrm>
           <a:prstGeom prst="rect">
             <a:avLst/>
@@ -13208,12 +13208,12 @@
         </p:nvSpPr>
         <p:spPr>
           <a:xfrm>
-            <a:off x="3282696" y="1627632"/>
-            <a:ext cx="1078992" cy="219456"/>
+            <a:off x="3547872" y="1609344"/>
+            <a:ext cx="768096" cy="667512"/>
           </a:xfrm>
           <a:prstGeom prst="roundRect">
             <a:avLst>
-              <a:gd name="adj" fmla="val 4000"/>
+              <a:gd name="adj" fmla="val 5000"/>
             </a:avLst>
           </a:prstGeom>
           <a:solidFill>
@@ -13238,10 +13238,19 @@
           </a:fontRef>
         </p:style>
         <p:txBody>
-          <a:bodyPr rtlCol="0" anchor="ctr"/>
+          <a:bodyPr rtlCol="0" anchor="ctr" wrap="square" lIns="73152" rIns="73152" tIns="36576" bIns="36576"/>
           <a:lstStyle/>
           <a:p>
             <a:pPr algn="ctr"/>
+            <a:r>
+              <a:rPr sz="1000" b="1">
+                <a:solidFill>
+                  <a:srgbClr val="9B3328"/>
+                </a:solidFill>
+                <a:latin typeface="Calibri"/>
+              </a:rPr>
+              <a:t>BARELY</a:t>
+            </a:r>
           </a:p>
         </p:txBody>
       </p:sp>
@@ -13253,8 +13262,8 @@
         </p:nvSpPr>
         <p:spPr>
           <a:xfrm>
-            <a:off x="3282696" y="1627632"/>
-            <a:ext cx="1078992" cy="219456"/>
+            <a:off x="4407408" y="1600200"/>
+            <a:ext cx="3035808" cy="384048"/>
           </a:xfrm>
           <a:prstGeom prst="rect">
             <a:avLst/>
@@ -13265,15 +13274,15 @@
           <a:bodyPr wrap="square" anchor="t"/>
           <a:lstStyle/>
           <a:p>
-            <a:pPr algn="ctr"/>
-            <a:r>
-              <a:rPr sz="1000" b="1">
-                <a:solidFill>
-                  <a:srgbClr val="9B3328"/>
-                </a:solidFill>
-                <a:latin typeface="Calibri"/>
-              </a:rPr>
-              <a:t>BARELY</a:t>
+            <a:pPr algn="l"/>
+            <a:r>
+              <a:rPr sz="1300" b="1">
+                <a:solidFill>
+                  <a:srgbClr val="26303A"/>
+                </a:solidFill>
+                <a:latin typeface="Calibri"/>
+              </a:rPr>
+              <a:t>Not agentic either: no automation and no learning across stages.</a:t>
             </a:r>
           </a:p>
         </p:txBody>
@@ -13286,8 +13295,8 @@
         </p:nvSpPr>
         <p:spPr>
           <a:xfrm>
-            <a:off x="4416552" y="1609344"/>
-            <a:ext cx="2926080" cy="420624"/>
+            <a:off x="4407408" y="2011680"/>
+            <a:ext cx="3035808" cy="237744"/>
           </a:xfrm>
           <a:prstGeom prst="rect">
             <a:avLst/>
@@ -13302,39 +13311,6 @@
             <a:r>
               <a:rPr sz="1300" b="1">
                 <a:solidFill>
-                  <a:srgbClr val="26303A"/>
-                </a:solidFill>
-                <a:latin typeface="Calibri"/>
-              </a:rPr>
-              <a:t>Not agentic either: no automation and no learning across stages.</a:t>
-            </a:r>
-          </a:p>
-        </p:txBody>
-      </p:sp>
-      <p:sp>
-        <p:nvSpPr>
-          <p:cNvPr id="23" name="TextBox 22"/>
-          <p:cNvSpPr txBox="1"/>
-          <p:nvPr/>
-        </p:nvSpPr>
-        <p:spPr>
-          <a:xfrm>
-            <a:off x="3282696" y="2048256"/>
-            <a:ext cx="4041648" cy="237744"/>
-          </a:xfrm>
-          <a:prstGeom prst="rect">
-            <a:avLst/>
-          </a:prstGeom>
-          <a:noFill/>
-        </p:spPr>
-        <p:txBody>
-          <a:bodyPr wrap="square" anchor="t"/>
-          <a:lstStyle/>
-          <a:p>
-            <a:pPr algn="l"/>
-            <a:r>
-              <a:rPr sz="1300" b="1">
-                <a:solidFill>
                   <a:srgbClr val="3A454F"/>
                 </a:solidFill>
                 <a:latin typeface="Calibri"/>
@@ -13346,14 +13322,14 @@
       </p:sp>
       <p:sp>
         <p:nvSpPr>
-          <p:cNvPr id="24" name="Rectangle 23"/>
+          <p:cNvPr id="23" name="Rectangle 22"/>
           <p:cNvSpPr/>
           <p:nvPr/>
         </p:nvSpPr>
         <p:spPr>
           <a:xfrm>
-            <a:off x="7525512" y="2331720"/>
-            <a:ext cx="4279392" cy="9144"/>
+            <a:off x="7644383" y="2331720"/>
+            <a:ext cx="4142232" cy="9144"/>
           </a:xfrm>
           <a:prstGeom prst="rect">
             <a:avLst/>
@@ -13389,18 +13365,18 @@
       </p:sp>
       <p:sp>
         <p:nvSpPr>
-          <p:cNvPr id="25" name="Rounded Rectangle 24"/>
+          <p:cNvPr id="24" name="Rounded Rectangle 23"/>
           <p:cNvSpPr/>
           <p:nvPr/>
         </p:nvSpPr>
         <p:spPr>
           <a:xfrm>
-            <a:off x="7653528" y="1627632"/>
-            <a:ext cx="1078992" cy="219456"/>
+            <a:off x="7772399" y="1609344"/>
+            <a:ext cx="768096" cy="667512"/>
           </a:xfrm>
           <a:prstGeom prst="roundRect">
             <a:avLst>
-              <a:gd name="adj" fmla="val 4000"/>
+              <a:gd name="adj" fmla="val 5000"/>
             </a:avLst>
           </a:prstGeom>
           <a:solidFill>
@@ -13425,10 +13401,52 @@
           </a:fontRef>
         </p:style>
         <p:txBody>
-          <a:bodyPr rtlCol="0" anchor="ctr"/>
+          <a:bodyPr rtlCol="0" anchor="ctr" wrap="square" lIns="73152" rIns="73152" tIns="36576" bIns="36576"/>
           <a:lstStyle/>
           <a:p>
             <a:pPr algn="ctr"/>
+            <a:r>
+              <a:rPr sz="1000" b="1">
+                <a:solidFill>
+                  <a:srgbClr val="9B3328"/>
+                </a:solidFill>
+                <a:latin typeface="Calibri"/>
+              </a:rPr>
+              <a:t>BARELY</a:t>
+            </a:r>
+          </a:p>
+        </p:txBody>
+      </p:sp>
+      <p:sp>
+        <p:nvSpPr>
+          <p:cNvPr id="25" name="TextBox 24"/>
+          <p:cNvSpPr txBox="1"/>
+          <p:nvPr/>
+        </p:nvSpPr>
+        <p:spPr>
+          <a:xfrm>
+            <a:off x="8631935" y="1600200"/>
+            <a:ext cx="3026664" cy="384048"/>
+          </a:xfrm>
+          <a:prstGeom prst="rect">
+            <a:avLst/>
+          </a:prstGeom>
+          <a:noFill/>
+        </p:spPr>
+        <p:txBody>
+          <a:bodyPr wrap="square" anchor="t"/>
+          <a:lstStyle/>
+          <a:p>
+            <a:pPr algn="l"/>
+            <a:r>
+              <a:rPr sz="1300" b="1">
+                <a:solidFill>
+                  <a:srgbClr val="26303A"/>
+                </a:solidFill>
+                <a:latin typeface="Calibri"/>
+              </a:rPr>
+              <a:t>Each tool owns a single stage; nobody governs the whole lifecycle.</a:t>
+            </a:r>
           </a:p>
         </p:txBody>
       </p:sp>
@@ -13440,8 +13458,8 @@
         </p:nvSpPr>
         <p:spPr>
           <a:xfrm>
-            <a:off x="7653528" y="1627632"/>
-            <a:ext cx="1078992" cy="219456"/>
+            <a:off x="8631935" y="2011680"/>
+            <a:ext cx="3026664" cy="237744"/>
           </a:xfrm>
           <a:prstGeom prst="rect">
             <a:avLst/>
@@ -13452,76 +13470,10 @@
           <a:bodyPr wrap="square" anchor="t"/>
           <a:lstStyle/>
           <a:p>
-            <a:pPr algn="ctr"/>
-            <a:r>
-              <a:rPr sz="1000" b="1">
-                <a:solidFill>
-                  <a:srgbClr val="9B3328"/>
-                </a:solidFill>
-                <a:latin typeface="Calibri"/>
-              </a:rPr>
-              <a:t>BARELY</a:t>
-            </a:r>
-          </a:p>
-        </p:txBody>
-      </p:sp>
-      <p:sp>
-        <p:nvSpPr>
-          <p:cNvPr id="27" name="TextBox 26"/>
-          <p:cNvSpPr txBox="1"/>
-          <p:nvPr/>
-        </p:nvSpPr>
-        <p:spPr>
-          <a:xfrm>
-            <a:off x="8787384" y="1609344"/>
-            <a:ext cx="2907792" cy="420624"/>
-          </a:xfrm>
-          <a:prstGeom prst="rect">
-            <a:avLst/>
-          </a:prstGeom>
-          <a:noFill/>
-        </p:spPr>
-        <p:txBody>
-          <a:bodyPr wrap="square" anchor="t"/>
-          <a:lstStyle/>
-          <a:p>
             <a:pPr algn="l"/>
             <a:r>
               <a:rPr sz="1300" b="1">
                 <a:solidFill>
-                  <a:srgbClr val="26303A"/>
-                </a:solidFill>
-                <a:latin typeface="Calibri"/>
-              </a:rPr>
-              <a:t>Each tool owns a single stage; nobody governs the whole lifecycle.</a:t>
-            </a:r>
-          </a:p>
-        </p:txBody>
-      </p:sp>
-      <p:sp>
-        <p:nvSpPr>
-          <p:cNvPr id="28" name="TextBox 27"/>
-          <p:cNvSpPr txBox="1"/>
-          <p:nvPr/>
-        </p:nvSpPr>
-        <p:spPr>
-          <a:xfrm>
-            <a:off x="7653528" y="2048256"/>
-            <a:ext cx="4023360" cy="237744"/>
-          </a:xfrm>
-          <a:prstGeom prst="rect">
-            <a:avLst/>
-          </a:prstGeom>
-          <a:noFill/>
-        </p:spPr>
-        <p:txBody>
-          <a:bodyPr wrap="square" anchor="t"/>
-          <a:lstStyle/>
-          <a:p>
-            <a:pPr algn="l"/>
-            <a:r>
-              <a:rPr sz="1300" b="1">
-                <a:solidFill>
                   <a:srgbClr val="3A454F"/>
                 </a:solidFill>
                 <a:latin typeface="Calibri"/>
@@ -13533,14 +13485,14 @@
       </p:sp>
       <p:sp>
         <p:nvSpPr>
-          <p:cNvPr id="29" name="Rectangle 28"/>
+          <p:cNvPr id="27" name="Rectangle 26"/>
           <p:cNvSpPr/>
           <p:nvPr/>
         </p:nvSpPr>
         <p:spPr>
           <a:xfrm>
             <a:off x="384048" y="3172968"/>
-            <a:ext cx="2697480" cy="9144"/>
+            <a:ext cx="2962656" cy="9144"/>
           </a:xfrm>
           <a:prstGeom prst="rect">
             <a:avLst/>
@@ -13576,7 +13528,7 @@
       </p:sp>
       <p:sp>
         <p:nvSpPr>
-          <p:cNvPr id="30" name="Oval 29"/>
+          <p:cNvPr id="28" name="Oval 27"/>
           <p:cNvSpPr/>
           <p:nvPr/>
         </p:nvSpPr>
@@ -13628,14 +13580,14 @@
       </p:sp>
       <p:sp>
         <p:nvSpPr>
-          <p:cNvPr id="31" name="TextBox 30"/>
+          <p:cNvPr id="29" name="TextBox 28"/>
           <p:cNvSpPr txBox="1"/>
           <p:nvPr/>
         </p:nvSpPr>
         <p:spPr>
           <a:xfrm>
             <a:off x="768096" y="2468880"/>
-            <a:ext cx="2240280" cy="329184"/>
+            <a:ext cx="2505456" cy="329184"/>
           </a:xfrm>
           <a:prstGeom prst="rect">
             <a:avLst/>
@@ -13661,14 +13613,14 @@
       </p:sp>
       <p:sp>
         <p:nvSpPr>
-          <p:cNvPr id="32" name="Rounded Rectangle 31"/>
+          <p:cNvPr id="30" name="Rounded Rectangle 29"/>
           <p:cNvSpPr/>
           <p:nvPr/>
         </p:nvSpPr>
         <p:spPr>
           <a:xfrm>
             <a:off x="457200" y="2834640"/>
-            <a:ext cx="2523744" cy="274320"/>
+            <a:ext cx="2788920" cy="274320"/>
           </a:xfrm>
           <a:prstGeom prst="roundRect">
             <a:avLst>
@@ -13724,14 +13676,14 @@
       </p:sp>
       <p:sp>
         <p:nvSpPr>
-          <p:cNvPr id="33" name="Rectangle 32"/>
+          <p:cNvPr id="31" name="Rectangle 30"/>
           <p:cNvSpPr/>
           <p:nvPr/>
         </p:nvSpPr>
         <p:spPr>
           <a:xfrm>
-            <a:off x="3154680" y="3172968"/>
-            <a:ext cx="4297680" cy="9144"/>
+            <a:off x="3419856" y="3172968"/>
+            <a:ext cx="4151376" cy="9144"/>
           </a:xfrm>
           <a:prstGeom prst="rect">
             <a:avLst/>
@@ -13767,18 +13719,18 @@
       </p:sp>
       <p:sp>
         <p:nvSpPr>
-          <p:cNvPr id="34" name="Rounded Rectangle 33"/>
+          <p:cNvPr id="32" name="Rounded Rectangle 31"/>
           <p:cNvSpPr/>
           <p:nvPr/>
         </p:nvSpPr>
         <p:spPr>
           <a:xfrm>
-            <a:off x="3282696" y="2468880"/>
-            <a:ext cx="1078992" cy="219456"/>
+            <a:off x="3547872" y="2450592"/>
+            <a:ext cx="768096" cy="667512"/>
           </a:xfrm>
           <a:prstGeom prst="roundRect">
             <a:avLst>
-              <a:gd name="adj" fmla="val 4000"/>
+              <a:gd name="adj" fmla="val 5000"/>
             </a:avLst>
           </a:prstGeom>
           <a:solidFill>
@@ -13803,23 +13755,32 @@
           </a:fontRef>
         </p:style>
         <p:txBody>
-          <a:bodyPr rtlCol="0" anchor="ctr"/>
+          <a:bodyPr rtlCol="0" anchor="ctr" wrap="square" lIns="73152" rIns="73152" tIns="36576" bIns="36576"/>
           <a:lstStyle/>
           <a:p>
             <a:pPr algn="ctr"/>
-          </a:p>
-        </p:txBody>
-      </p:sp>
-      <p:sp>
-        <p:nvSpPr>
-          <p:cNvPr id="35" name="TextBox 34"/>
+            <a:r>
+              <a:rPr sz="1000" b="1">
+                <a:solidFill>
+                  <a:srgbClr val="8A5B14"/>
+                </a:solidFill>
+                <a:latin typeface="Calibri"/>
+              </a:rPr>
+              <a:t>PARTIAL</a:t>
+            </a:r>
+          </a:p>
+        </p:txBody>
+      </p:sp>
+      <p:sp>
+        <p:nvSpPr>
+          <p:cNvPr id="33" name="TextBox 32"/>
           <p:cNvSpPr txBox="1"/>
           <p:nvPr/>
         </p:nvSpPr>
         <p:spPr>
           <a:xfrm>
-            <a:off x="3282696" y="2468880"/>
-            <a:ext cx="1078992" cy="219456"/>
+            <a:off x="4407408" y="2441448"/>
+            <a:ext cx="3035808" cy="384048"/>
           </a:xfrm>
           <a:prstGeom prst="rect">
             <a:avLst/>
@@ -13830,29 +13791,29 @@
           <a:bodyPr wrap="square" anchor="t"/>
           <a:lstStyle/>
           <a:p>
-            <a:pPr algn="ctr"/>
-            <a:r>
-              <a:rPr sz="1000" b="1">
-                <a:solidFill>
-                  <a:srgbClr val="8A5B14"/>
-                </a:solidFill>
-                <a:latin typeface="Calibri"/>
-              </a:rPr>
-              <a:t>PARTIAL</a:t>
-            </a:r>
-          </a:p>
-        </p:txBody>
-      </p:sp>
-      <p:sp>
-        <p:nvSpPr>
-          <p:cNvPr id="36" name="TextBox 35"/>
+            <a:pPr algn="l"/>
+            <a:r>
+              <a:rPr sz="1300" b="1">
+                <a:solidFill>
+                  <a:srgbClr val="26303A"/>
+                </a:solidFill>
+                <a:latin typeface="Calibri"/>
+              </a:rPr>
+              <a:t>Provides structure, but no BoQ catalog creation from scratch out of historical data.</a:t>
+            </a:r>
+          </a:p>
+        </p:txBody>
+      </p:sp>
+      <p:sp>
+        <p:nvSpPr>
+          <p:cNvPr id="34" name="TextBox 33"/>
           <p:cNvSpPr txBox="1"/>
           <p:nvPr/>
         </p:nvSpPr>
         <p:spPr>
           <a:xfrm>
-            <a:off x="4416552" y="2450592"/>
-            <a:ext cx="2926080" cy="420624"/>
+            <a:off x="4407408" y="2852928"/>
+            <a:ext cx="3035808" cy="237744"/>
           </a:xfrm>
           <a:prstGeom prst="rect">
             <a:avLst/>
@@ -13867,39 +13828,6 @@
             <a:r>
               <a:rPr sz="1300" b="1">
                 <a:solidFill>
-                  <a:srgbClr val="26303A"/>
-                </a:solidFill>
-                <a:latin typeface="Calibri"/>
-              </a:rPr>
-              <a:t>Provides structure, but no BoQ catalog creation from scratch out of historical data.</a:t>
-            </a:r>
-          </a:p>
-        </p:txBody>
-      </p:sp>
-      <p:sp>
-        <p:nvSpPr>
-          <p:cNvPr id="37" name="TextBox 36"/>
-          <p:cNvSpPr txBox="1"/>
-          <p:nvPr/>
-        </p:nvSpPr>
-        <p:spPr>
-          <a:xfrm>
-            <a:off x="3282696" y="2889504"/>
-            <a:ext cx="4041648" cy="237744"/>
-          </a:xfrm>
-          <a:prstGeom prst="rect">
-            <a:avLst/>
-          </a:prstGeom>
-          <a:noFill/>
-        </p:spPr>
-        <p:txBody>
-          <a:bodyPr wrap="square" anchor="t"/>
-          <a:lstStyle/>
-          <a:p>
-            <a:pPr algn="l"/>
-            <a:r>
-              <a:rPr sz="1300" b="1">
-                <a:solidFill>
                   <a:srgbClr val="3A454F"/>
                 </a:solidFill>
                 <a:latin typeface="Calibri"/>
@@ -13911,14 +13839,14 @@
       </p:sp>
       <p:sp>
         <p:nvSpPr>
-          <p:cNvPr id="38" name="Rectangle 37"/>
+          <p:cNvPr id="35" name="Rectangle 34"/>
           <p:cNvSpPr/>
           <p:nvPr/>
         </p:nvSpPr>
         <p:spPr>
           <a:xfrm>
-            <a:off x="7525512" y="3172968"/>
-            <a:ext cx="4279392" cy="9144"/>
+            <a:off x="7644383" y="3172968"/>
+            <a:ext cx="4142232" cy="9144"/>
           </a:xfrm>
           <a:prstGeom prst="rect">
             <a:avLst/>
@@ -13954,18 +13882,18 @@
       </p:sp>
       <p:sp>
         <p:nvSpPr>
-          <p:cNvPr id="39" name="Rounded Rectangle 38"/>
+          <p:cNvPr id="36" name="Rounded Rectangle 35"/>
           <p:cNvSpPr/>
           <p:nvPr/>
         </p:nvSpPr>
         <p:spPr>
           <a:xfrm>
-            <a:off x="7653528" y="2468880"/>
-            <a:ext cx="1078992" cy="219456"/>
+            <a:off x="7772399" y="2450592"/>
+            <a:ext cx="768096" cy="667512"/>
           </a:xfrm>
           <a:prstGeom prst="roundRect">
             <a:avLst>
-              <a:gd name="adj" fmla="val 4000"/>
+              <a:gd name="adj" fmla="val 5000"/>
             </a:avLst>
           </a:prstGeom>
           <a:solidFill>
@@ -13990,23 +13918,32 @@
           </a:fontRef>
         </p:style>
         <p:txBody>
-          <a:bodyPr rtlCol="0" anchor="ctr"/>
+          <a:bodyPr rtlCol="0" anchor="ctr" wrap="square" lIns="73152" rIns="73152" tIns="36576" bIns="36576"/>
           <a:lstStyle/>
           <a:p>
             <a:pPr algn="ctr"/>
-          </a:p>
-        </p:txBody>
-      </p:sp>
-      <p:sp>
-        <p:nvSpPr>
-          <p:cNvPr id="40" name="TextBox 39"/>
+            <a:r>
+              <a:rPr sz="1000" b="1">
+                <a:solidFill>
+                  <a:srgbClr val="8A5B14"/>
+                </a:solidFill>
+                <a:latin typeface="Calibri"/>
+              </a:rPr>
+              <a:t>PARTIAL</a:t>
+            </a:r>
+          </a:p>
+        </p:txBody>
+      </p:sp>
+      <p:sp>
+        <p:nvSpPr>
+          <p:cNvPr id="37" name="TextBox 36"/>
           <p:cNvSpPr txBox="1"/>
           <p:nvPr/>
         </p:nvSpPr>
         <p:spPr>
           <a:xfrm>
-            <a:off x="7653528" y="2468880"/>
-            <a:ext cx="1078992" cy="219456"/>
+            <a:off x="8631935" y="2441448"/>
+            <a:ext cx="3026664" cy="384048"/>
           </a:xfrm>
           <a:prstGeom prst="rect">
             <a:avLst/>
@@ -14017,29 +13954,29 @@
           <a:bodyPr wrap="square" anchor="t"/>
           <a:lstStyle/>
           <a:p>
-            <a:pPr algn="ctr"/>
-            <a:r>
-              <a:rPr sz="1000" b="1">
-                <a:solidFill>
-                  <a:srgbClr val="8A5B14"/>
-                </a:solidFill>
-                <a:latin typeface="Calibri"/>
-              </a:rPr>
-              <a:t>PARTIAL</a:t>
-            </a:r>
-          </a:p>
-        </p:txBody>
-      </p:sp>
-      <p:sp>
-        <p:nvSpPr>
-          <p:cNvPr id="41" name="TextBox 40"/>
+            <a:pPr algn="l"/>
+            <a:r>
+              <a:rPr sz="1300" b="1">
+                <a:solidFill>
+                  <a:srgbClr val="26303A"/>
+                </a:solidFill>
+                <a:latin typeface="Calibri"/>
+              </a:rPr>
+              <a:t>Document to data translation, but limited BoQ hierarchy focus.</a:t>
+            </a:r>
+          </a:p>
+        </p:txBody>
+      </p:sp>
+      <p:sp>
+        <p:nvSpPr>
+          <p:cNvPr id="38" name="TextBox 37"/>
           <p:cNvSpPr txBox="1"/>
           <p:nvPr/>
         </p:nvSpPr>
         <p:spPr>
           <a:xfrm>
-            <a:off x="8787384" y="2450592"/>
-            <a:ext cx="2907792" cy="420624"/>
+            <a:off x="8631935" y="2852928"/>
+            <a:ext cx="3026664" cy="237744"/>
           </a:xfrm>
           <a:prstGeom prst="rect">
             <a:avLst/>
@@ -14054,39 +13991,6 @@
             <a:r>
               <a:rPr sz="1300" b="1">
                 <a:solidFill>
-                  <a:srgbClr val="26303A"/>
-                </a:solidFill>
-                <a:latin typeface="Calibri"/>
-              </a:rPr>
-              <a:t>Document to data translation, but limited BoQ hierarchy focus.</a:t>
-            </a:r>
-          </a:p>
-        </p:txBody>
-      </p:sp>
-      <p:sp>
-        <p:nvSpPr>
-          <p:cNvPr id="42" name="TextBox 41"/>
-          <p:cNvSpPr txBox="1"/>
-          <p:nvPr/>
-        </p:nvSpPr>
-        <p:spPr>
-          <a:xfrm>
-            <a:off x="7653528" y="2889504"/>
-            <a:ext cx="4023360" cy="237744"/>
-          </a:xfrm>
-          <a:prstGeom prst="rect">
-            <a:avLst/>
-          </a:prstGeom>
-          <a:noFill/>
-        </p:spPr>
-        <p:txBody>
-          <a:bodyPr wrap="square" anchor="t"/>
-          <a:lstStyle/>
-          <a:p>
-            <a:pPr algn="l"/>
-            <a:r>
-              <a:rPr sz="1300" b="1">
-                <a:solidFill>
                   <a:srgbClr val="3A454F"/>
                 </a:solidFill>
                 <a:latin typeface="Calibri"/>
@@ -14098,14 +14002,14 @@
       </p:sp>
       <p:sp>
         <p:nvSpPr>
-          <p:cNvPr id="43" name="Rectangle 42"/>
+          <p:cNvPr id="39" name="Rectangle 38"/>
           <p:cNvSpPr/>
           <p:nvPr/>
         </p:nvSpPr>
         <p:spPr>
           <a:xfrm>
             <a:off x="384048" y="4014216"/>
-            <a:ext cx="2697480" cy="9144"/>
+            <a:ext cx="2962656" cy="9144"/>
           </a:xfrm>
           <a:prstGeom prst="rect">
             <a:avLst/>
@@ -14141,7 +14045,7 @@
       </p:sp>
       <p:sp>
         <p:nvSpPr>
-          <p:cNvPr id="44" name="Oval 43"/>
+          <p:cNvPr id="40" name="Oval 39"/>
           <p:cNvSpPr/>
           <p:nvPr/>
         </p:nvSpPr>
@@ -14193,14 +14097,14 @@
       </p:sp>
       <p:sp>
         <p:nvSpPr>
-          <p:cNvPr id="45" name="TextBox 44"/>
+          <p:cNvPr id="41" name="TextBox 40"/>
           <p:cNvSpPr txBox="1"/>
           <p:nvPr/>
         </p:nvSpPr>
         <p:spPr>
           <a:xfrm>
             <a:off x="768096" y="3310128"/>
-            <a:ext cx="2240280" cy="329184"/>
+            <a:ext cx="2505456" cy="329184"/>
           </a:xfrm>
           <a:prstGeom prst="rect">
             <a:avLst/>
@@ -14226,14 +14130,14 @@
       </p:sp>
       <p:sp>
         <p:nvSpPr>
-          <p:cNvPr id="46" name="Rounded Rectangle 45"/>
+          <p:cNvPr id="42" name="Rounded Rectangle 41"/>
           <p:cNvSpPr/>
           <p:nvPr/>
         </p:nvSpPr>
         <p:spPr>
           <a:xfrm>
             <a:off x="457200" y="3675888"/>
-            <a:ext cx="2523744" cy="274320"/>
+            <a:ext cx="2788920" cy="274320"/>
           </a:xfrm>
           <a:prstGeom prst="roundRect">
             <a:avLst>
@@ -14289,14 +14193,14 @@
       </p:sp>
       <p:sp>
         <p:nvSpPr>
-          <p:cNvPr id="47" name="Rectangle 46"/>
+          <p:cNvPr id="43" name="Rectangle 42"/>
           <p:cNvSpPr/>
           <p:nvPr/>
         </p:nvSpPr>
         <p:spPr>
           <a:xfrm>
-            <a:off x="3154680" y="4014216"/>
-            <a:ext cx="4297680" cy="9144"/>
+            <a:off x="3419856" y="4014216"/>
+            <a:ext cx="4151376" cy="9144"/>
           </a:xfrm>
           <a:prstGeom prst="rect">
             <a:avLst/>
@@ -14332,18 +14236,18 @@
       </p:sp>
       <p:sp>
         <p:nvSpPr>
-          <p:cNvPr id="48" name="Rounded Rectangle 47"/>
+          <p:cNvPr id="44" name="Rounded Rectangle 43"/>
           <p:cNvSpPr/>
           <p:nvPr/>
         </p:nvSpPr>
         <p:spPr>
           <a:xfrm>
-            <a:off x="3282696" y="3310128"/>
-            <a:ext cx="1078992" cy="219456"/>
+            <a:off x="3547872" y="3291840"/>
+            <a:ext cx="768096" cy="667512"/>
           </a:xfrm>
           <a:prstGeom prst="roundRect">
             <a:avLst>
-              <a:gd name="adj" fmla="val 4000"/>
+              <a:gd name="adj" fmla="val 5000"/>
             </a:avLst>
           </a:prstGeom>
           <a:solidFill>
@@ -14368,23 +14272,32 @@
           </a:fontRef>
         </p:style>
         <p:txBody>
-          <a:bodyPr rtlCol="0" anchor="ctr"/>
+          <a:bodyPr rtlCol="0" anchor="ctr" wrap="square" lIns="73152" rIns="73152" tIns="36576" bIns="36576"/>
           <a:lstStyle/>
           <a:p>
             <a:pPr algn="ctr"/>
-          </a:p>
-        </p:txBody>
-      </p:sp>
-      <p:sp>
-        <p:nvSpPr>
-          <p:cNvPr id="49" name="TextBox 48"/>
+            <a:r>
+              <a:rPr sz="1000" b="1">
+                <a:solidFill>
+                  <a:srgbClr val="1E6B3D"/>
+                </a:solidFill>
+                <a:latin typeface="Calibri"/>
+              </a:rPr>
+              <a:t>COVERS MOST</a:t>
+            </a:r>
+          </a:p>
+        </p:txBody>
+      </p:sp>
+      <p:sp>
+        <p:nvSpPr>
+          <p:cNvPr id="45" name="TextBox 44"/>
           <p:cNvSpPr txBox="1"/>
           <p:nvPr/>
         </p:nvSpPr>
         <p:spPr>
           <a:xfrm>
-            <a:off x="3282696" y="3310128"/>
-            <a:ext cx="1078992" cy="219456"/>
+            <a:off x="4407408" y="3282696"/>
+            <a:ext cx="3035808" cy="384048"/>
           </a:xfrm>
           <a:prstGeom prst="rect">
             <a:avLst/>
@@ -14395,29 +14308,29 @@
           <a:bodyPr wrap="square" anchor="t"/>
           <a:lstStyle/>
           <a:p>
-            <a:pPr algn="ctr"/>
-            <a:r>
-              <a:rPr sz="1000" b="1">
-                <a:solidFill>
-                  <a:srgbClr val="1E6B3D"/>
-                </a:solidFill>
-                <a:latin typeface="Calibri"/>
-              </a:rPr>
-              <a:t>COVERS MOST</a:t>
-            </a:r>
-          </a:p>
-        </p:txBody>
-      </p:sp>
-      <p:sp>
-        <p:nvSpPr>
-          <p:cNvPr id="50" name="TextBox 49"/>
+            <a:pPr algn="l"/>
+            <a:r>
+              <a:rPr sz="1300" b="1">
+                <a:solidFill>
+                  <a:srgbClr val="26303A"/>
+                </a:solidFill>
+                <a:latin typeface="Calibri"/>
+              </a:rPr>
+              <a:t>Mature estimating engines; this step is already well served.</a:t>
+            </a:r>
+          </a:p>
+        </p:txBody>
+      </p:sp>
+      <p:sp>
+        <p:nvSpPr>
+          <p:cNvPr id="46" name="TextBox 45"/>
           <p:cNvSpPr txBox="1"/>
           <p:nvPr/>
         </p:nvSpPr>
         <p:spPr>
           <a:xfrm>
-            <a:off x="4416552" y="3291840"/>
-            <a:ext cx="2926080" cy="420624"/>
+            <a:off x="4407408" y="3694176"/>
+            <a:ext cx="3035808" cy="237744"/>
           </a:xfrm>
           <a:prstGeom prst="rect">
             <a:avLst/>
@@ -14432,39 +14345,6 @@
             <a:r>
               <a:rPr sz="1300" b="1">
                 <a:solidFill>
-                  <a:srgbClr val="26303A"/>
-                </a:solidFill>
-                <a:latin typeface="Calibri"/>
-              </a:rPr>
-              <a:t>Mature estimating engines; this step is already well served.</a:t>
-            </a:r>
-          </a:p>
-        </p:txBody>
-      </p:sp>
-      <p:sp>
-        <p:nvSpPr>
-          <p:cNvPr id="51" name="TextBox 50"/>
-          <p:cNvSpPr txBox="1"/>
-          <p:nvPr/>
-        </p:nvSpPr>
-        <p:spPr>
-          <a:xfrm>
-            <a:off x="3282696" y="3730752"/>
-            <a:ext cx="4041648" cy="237744"/>
-          </a:xfrm>
-          <a:prstGeom prst="rect">
-            <a:avLst/>
-          </a:prstGeom>
-          <a:noFill/>
-        </p:spPr>
-        <p:txBody>
-          <a:bodyPr wrap="square" anchor="t"/>
-          <a:lstStyle/>
-          <a:p>
-            <a:pPr algn="l"/>
-            <a:r>
-              <a:rPr sz="1300" b="1">
-                <a:solidFill>
                   <a:srgbClr val="3A454F"/>
                 </a:solidFill>
                 <a:latin typeface="Calibri"/>
@@ -14476,14 +14356,14 @@
       </p:sp>
       <p:sp>
         <p:nvSpPr>
-          <p:cNvPr id="52" name="Rectangle 51"/>
+          <p:cNvPr id="47" name="Rectangle 46"/>
           <p:cNvSpPr/>
           <p:nvPr/>
         </p:nvSpPr>
         <p:spPr>
           <a:xfrm>
-            <a:off x="7525512" y="4014216"/>
-            <a:ext cx="4279392" cy="9144"/>
+            <a:off x="7644383" y="4014216"/>
+            <a:ext cx="4142232" cy="9144"/>
           </a:xfrm>
           <a:prstGeom prst="rect">
             <a:avLst/>
@@ -14519,18 +14399,18 @@
       </p:sp>
       <p:sp>
         <p:nvSpPr>
-          <p:cNvPr id="53" name="Rounded Rectangle 52"/>
+          <p:cNvPr id="48" name="Rounded Rectangle 47"/>
           <p:cNvSpPr/>
           <p:nvPr/>
         </p:nvSpPr>
         <p:spPr>
           <a:xfrm>
-            <a:off x="7653528" y="3310128"/>
-            <a:ext cx="1078992" cy="219456"/>
+            <a:off x="7772399" y="3291840"/>
+            <a:ext cx="768096" cy="667512"/>
           </a:xfrm>
           <a:prstGeom prst="roundRect">
             <a:avLst>
-              <a:gd name="adj" fmla="val 4000"/>
+              <a:gd name="adj" fmla="val 5000"/>
             </a:avLst>
           </a:prstGeom>
           <a:solidFill>
@@ -14555,23 +14435,32 @@
           </a:fontRef>
         </p:style>
         <p:txBody>
-          <a:bodyPr rtlCol="0" anchor="ctr"/>
+          <a:bodyPr rtlCol="0" anchor="ctr" wrap="square" lIns="73152" rIns="73152" tIns="36576" bIns="36576"/>
           <a:lstStyle/>
           <a:p>
             <a:pPr algn="ctr"/>
-          </a:p>
-        </p:txBody>
-      </p:sp>
-      <p:sp>
-        <p:nvSpPr>
-          <p:cNvPr id="54" name="TextBox 53"/>
+            <a:r>
+              <a:rPr sz="1000" b="1">
+                <a:solidFill>
+                  <a:srgbClr val="1E6B3D"/>
+                </a:solidFill>
+                <a:latin typeface="Calibri"/>
+              </a:rPr>
+              <a:t>COVERS MOST</a:t>
+            </a:r>
+          </a:p>
+        </p:txBody>
+      </p:sp>
+      <p:sp>
+        <p:nvSpPr>
+          <p:cNvPr id="49" name="TextBox 48"/>
           <p:cNvSpPr txBox="1"/>
           <p:nvPr/>
         </p:nvSpPr>
         <p:spPr>
           <a:xfrm>
-            <a:off x="7653528" y="3310128"/>
-            <a:ext cx="1078992" cy="219456"/>
+            <a:off x="8631935" y="3282696"/>
+            <a:ext cx="3026664" cy="384048"/>
           </a:xfrm>
           <a:prstGeom prst="rect">
             <a:avLst/>
@@ -14582,29 +14471,29 @@
           <a:bodyPr wrap="square" anchor="t"/>
           <a:lstStyle/>
           <a:p>
-            <a:pPr algn="ctr"/>
-            <a:r>
-              <a:rPr sz="1000" b="1">
-                <a:solidFill>
-                  <a:srgbClr val="1E6B3D"/>
-                </a:solidFill>
-                <a:latin typeface="Calibri"/>
-              </a:rPr>
-              <a:t>COVERS MOST</a:t>
-            </a:r>
-          </a:p>
-        </p:txBody>
-      </p:sp>
-      <p:sp>
-        <p:nvSpPr>
-          <p:cNvPr id="55" name="TextBox 54"/>
+            <a:pPr algn="l"/>
+            <a:r>
+              <a:rPr sz="1300" b="1">
+                <a:solidFill>
+                  <a:srgbClr val="26303A"/>
+                </a:solidFill>
+                <a:latin typeface="Calibri"/>
+              </a:rPr>
+              <a:t>Genuinely strong AI estimating; also well served.</a:t>
+            </a:r>
+          </a:p>
+        </p:txBody>
+      </p:sp>
+      <p:sp>
+        <p:nvSpPr>
+          <p:cNvPr id="50" name="TextBox 49"/>
           <p:cNvSpPr txBox="1"/>
           <p:nvPr/>
         </p:nvSpPr>
         <p:spPr>
           <a:xfrm>
-            <a:off x="8787384" y="3291840"/>
-            <a:ext cx="2907792" cy="420624"/>
+            <a:off x="8631935" y="3694176"/>
+            <a:ext cx="3026664" cy="237744"/>
           </a:xfrm>
           <a:prstGeom prst="rect">
             <a:avLst/>
@@ -14619,39 +14508,6 @@
             <a:r>
               <a:rPr sz="1300" b="1">
                 <a:solidFill>
-                  <a:srgbClr val="26303A"/>
-                </a:solidFill>
-                <a:latin typeface="Calibri"/>
-              </a:rPr>
-              <a:t>Genuinely strong AI estimating; also well served.</a:t>
-            </a:r>
-          </a:p>
-        </p:txBody>
-      </p:sp>
-      <p:sp>
-        <p:nvSpPr>
-          <p:cNvPr id="56" name="TextBox 55"/>
-          <p:cNvSpPr txBox="1"/>
-          <p:nvPr/>
-        </p:nvSpPr>
-        <p:spPr>
-          <a:xfrm>
-            <a:off x="7653528" y="3730752"/>
-            <a:ext cx="4023360" cy="237744"/>
-          </a:xfrm>
-          <a:prstGeom prst="rect">
-            <a:avLst/>
-          </a:prstGeom>
-          <a:noFill/>
-        </p:spPr>
-        <p:txBody>
-          <a:bodyPr wrap="square" anchor="t"/>
-          <a:lstStyle/>
-          <a:p>
-            <a:pPr algn="l"/>
-            <a:r>
-              <a:rPr sz="1300" b="1">
-                <a:solidFill>
                   <a:srgbClr val="3A454F"/>
                 </a:solidFill>
                 <a:latin typeface="Calibri"/>
@@ -14663,14 +14519,14 @@
       </p:sp>
       <p:sp>
         <p:nvSpPr>
-          <p:cNvPr id="57" name="Rectangle 56"/>
+          <p:cNvPr id="51" name="Rectangle 50"/>
           <p:cNvSpPr/>
           <p:nvPr/>
         </p:nvSpPr>
         <p:spPr>
           <a:xfrm>
             <a:off x="384048" y="4855464"/>
-            <a:ext cx="2697480" cy="9144"/>
+            <a:ext cx="2962656" cy="9144"/>
           </a:xfrm>
           <a:prstGeom prst="rect">
             <a:avLst/>
@@ -14706,7 +14562,7 @@
       </p:sp>
       <p:sp>
         <p:nvSpPr>
-          <p:cNvPr id="58" name="Oval 57"/>
+          <p:cNvPr id="52" name="Oval 51"/>
           <p:cNvSpPr/>
           <p:nvPr/>
         </p:nvSpPr>
@@ -14758,14 +14614,14 @@
       </p:sp>
       <p:sp>
         <p:nvSpPr>
-          <p:cNvPr id="59" name="TextBox 58"/>
+          <p:cNvPr id="53" name="TextBox 52"/>
           <p:cNvSpPr txBox="1"/>
           <p:nvPr/>
         </p:nvSpPr>
         <p:spPr>
           <a:xfrm>
             <a:off x="768096" y="4151376"/>
-            <a:ext cx="2240280" cy="329184"/>
+            <a:ext cx="2505456" cy="329184"/>
           </a:xfrm>
           <a:prstGeom prst="rect">
             <a:avLst/>
@@ -14791,14 +14647,14 @@
       </p:sp>
       <p:sp>
         <p:nvSpPr>
-          <p:cNvPr id="60" name="Rounded Rectangle 59"/>
+          <p:cNvPr id="54" name="Rounded Rectangle 53"/>
           <p:cNvSpPr/>
           <p:nvPr/>
         </p:nvSpPr>
         <p:spPr>
           <a:xfrm>
             <a:off x="457200" y="4517136"/>
-            <a:ext cx="2523744" cy="274320"/>
+            <a:ext cx="2788920" cy="274320"/>
           </a:xfrm>
           <a:prstGeom prst="roundRect">
             <a:avLst>
@@ -14854,14 +14710,14 @@
       </p:sp>
       <p:sp>
         <p:nvSpPr>
-          <p:cNvPr id="61" name="Rectangle 60"/>
+          <p:cNvPr id="55" name="Rectangle 54"/>
           <p:cNvSpPr/>
           <p:nvPr/>
         </p:nvSpPr>
         <p:spPr>
           <a:xfrm>
-            <a:off x="3154680" y="4855464"/>
-            <a:ext cx="4297680" cy="9144"/>
+            <a:off x="3419856" y="4855464"/>
+            <a:ext cx="4151376" cy="9144"/>
           </a:xfrm>
           <a:prstGeom prst="rect">
             <a:avLst/>
@@ -14897,18 +14753,18 @@
       </p:sp>
       <p:sp>
         <p:nvSpPr>
-          <p:cNvPr id="62" name="Rounded Rectangle 61"/>
+          <p:cNvPr id="56" name="Rounded Rectangle 55"/>
           <p:cNvSpPr/>
           <p:nvPr/>
         </p:nvSpPr>
         <p:spPr>
           <a:xfrm>
-            <a:off x="3282696" y="4151376"/>
-            <a:ext cx="1078992" cy="219456"/>
+            <a:off x="3547872" y="4133088"/>
+            <a:ext cx="768096" cy="667512"/>
           </a:xfrm>
           <a:prstGeom prst="roundRect">
             <a:avLst>
-              <a:gd name="adj" fmla="val 4000"/>
+              <a:gd name="adj" fmla="val 5000"/>
             </a:avLst>
           </a:prstGeom>
           <a:solidFill>
@@ -14933,23 +14789,32 @@
           </a:fontRef>
         </p:style>
         <p:txBody>
-          <a:bodyPr rtlCol="0" anchor="ctr"/>
+          <a:bodyPr rtlCol="0" anchor="ctr" wrap="square" lIns="73152" rIns="73152" tIns="36576" bIns="36576"/>
           <a:lstStyle/>
           <a:p>
             <a:pPr algn="ctr"/>
-          </a:p>
-        </p:txBody>
-      </p:sp>
-      <p:sp>
-        <p:nvSpPr>
-          <p:cNvPr id="63" name="TextBox 62"/>
+            <a:r>
+              <a:rPr sz="1000" b="1">
+                <a:solidFill>
+                  <a:srgbClr val="8A5B14"/>
+                </a:solidFill>
+                <a:latin typeface="Calibri"/>
+              </a:rPr>
+              <a:t>PARTIAL</a:t>
+            </a:r>
+          </a:p>
+        </p:txBody>
+      </p:sp>
+      <p:sp>
+        <p:nvSpPr>
+          <p:cNvPr id="57" name="TextBox 56"/>
           <p:cNvSpPr txBox="1"/>
           <p:nvPr/>
         </p:nvSpPr>
         <p:spPr>
           <a:xfrm>
-            <a:off x="3282696" y="4151376"/>
-            <a:ext cx="1078992" cy="219456"/>
+            <a:off x="4407408" y="4123944"/>
+            <a:ext cx="3035808" cy="384048"/>
           </a:xfrm>
           <a:prstGeom prst="rect">
             <a:avLst/>
@@ -14960,29 +14825,29 @@
           <a:bodyPr wrap="square" anchor="t"/>
           <a:lstStyle/>
           <a:p>
-            <a:pPr algn="ctr"/>
-            <a:r>
-              <a:rPr sz="1000" b="1">
-                <a:solidFill>
-                  <a:srgbClr val="8A5B14"/>
-                </a:solidFill>
-                <a:latin typeface="Calibri"/>
-              </a:rPr>
-              <a:t>PARTIAL</a:t>
-            </a:r>
-          </a:p>
-        </p:txBody>
-      </p:sp>
-      <p:sp>
-        <p:nvSpPr>
-          <p:cNvPr id="64" name="TextBox 63"/>
+            <a:pPr algn="l"/>
+            <a:r>
+              <a:rPr sz="1300" b="1">
+                <a:solidFill>
+                  <a:srgbClr val="26303A"/>
+                </a:solidFill>
+                <a:latin typeface="Calibri"/>
+              </a:rPr>
+              <a:t>Standard templates make it workable; the gap is AI recommendation and spec analysis.</a:t>
+            </a:r>
+          </a:p>
+        </p:txBody>
+      </p:sp>
+      <p:sp>
+        <p:nvSpPr>
+          <p:cNvPr id="58" name="TextBox 57"/>
           <p:cNvSpPr txBox="1"/>
           <p:nvPr/>
         </p:nvSpPr>
         <p:spPr>
           <a:xfrm>
-            <a:off x="4416552" y="4133088"/>
-            <a:ext cx="2926080" cy="420624"/>
+            <a:off x="4407408" y="4535424"/>
+            <a:ext cx="3035808" cy="237744"/>
           </a:xfrm>
           <a:prstGeom prst="rect">
             <a:avLst/>
@@ -14997,39 +14862,6 @@
             <a:r>
               <a:rPr sz="1300" b="1">
                 <a:solidFill>
-                  <a:srgbClr val="26303A"/>
-                </a:solidFill>
-                <a:latin typeface="Calibri"/>
-              </a:rPr>
-              <a:t>Standard templates make comparison workable; the gap is AI recommendation and spec analysis.</a:t>
-            </a:r>
-          </a:p>
-        </p:txBody>
-      </p:sp>
-      <p:sp>
-        <p:nvSpPr>
-          <p:cNvPr id="65" name="TextBox 64"/>
-          <p:cNvSpPr txBox="1"/>
-          <p:nvPr/>
-        </p:nvSpPr>
-        <p:spPr>
-          <a:xfrm>
-            <a:off x="3282696" y="4572000"/>
-            <a:ext cx="4041648" cy="237744"/>
-          </a:xfrm>
-          <a:prstGeom prst="rect">
-            <a:avLst/>
-          </a:prstGeom>
-          <a:noFill/>
-        </p:spPr>
-        <p:txBody>
-          <a:bodyPr wrap="square" anchor="t"/>
-          <a:lstStyle/>
-          <a:p>
-            <a:pPr algn="l"/>
-            <a:r>
-              <a:rPr sz="1300" b="1">
-                <a:solidFill>
                   <a:srgbClr val="3A454F"/>
                 </a:solidFill>
                 <a:latin typeface="Calibri"/>
@@ -15041,14 +14873,14 @@
       </p:sp>
       <p:sp>
         <p:nvSpPr>
-          <p:cNvPr id="66" name="Rectangle 65"/>
+          <p:cNvPr id="59" name="Rectangle 58"/>
           <p:cNvSpPr/>
           <p:nvPr/>
         </p:nvSpPr>
         <p:spPr>
           <a:xfrm>
-            <a:off x="7525512" y="4855464"/>
-            <a:ext cx="4279392" cy="9144"/>
+            <a:off x="7644383" y="4855464"/>
+            <a:ext cx="4142232" cy="9144"/>
           </a:xfrm>
           <a:prstGeom prst="rect">
             <a:avLst/>
@@ -15084,18 +14916,18 @@
       </p:sp>
       <p:sp>
         <p:nvSpPr>
-          <p:cNvPr id="67" name="Rounded Rectangle 66"/>
+          <p:cNvPr id="60" name="Rounded Rectangle 59"/>
           <p:cNvSpPr/>
           <p:nvPr/>
         </p:nvSpPr>
         <p:spPr>
           <a:xfrm>
-            <a:off x="7653528" y="4151376"/>
-            <a:ext cx="1078992" cy="219456"/>
+            <a:off x="7772399" y="4133088"/>
+            <a:ext cx="768096" cy="667512"/>
           </a:xfrm>
           <a:prstGeom prst="roundRect">
             <a:avLst>
-              <a:gd name="adj" fmla="val 4000"/>
+              <a:gd name="adj" fmla="val 5000"/>
             </a:avLst>
           </a:prstGeom>
           <a:solidFill>
@@ -15120,23 +14952,32 @@
           </a:fontRef>
         </p:style>
         <p:txBody>
-          <a:bodyPr rtlCol="0" anchor="ctr"/>
+          <a:bodyPr rtlCol="0" anchor="ctr" wrap="square" lIns="73152" rIns="73152" tIns="36576" bIns="36576"/>
           <a:lstStyle/>
           <a:p>
             <a:pPr algn="ctr"/>
-          </a:p>
-        </p:txBody>
-      </p:sp>
-      <p:sp>
-        <p:nvSpPr>
-          <p:cNvPr id="68" name="TextBox 67"/>
+            <a:r>
+              <a:rPr sz="1000" b="1">
+                <a:solidFill>
+                  <a:srgbClr val="1E6B3D"/>
+                </a:solidFill>
+                <a:latin typeface="Calibri"/>
+              </a:rPr>
+              <a:t>COVERS MOST</a:t>
+            </a:r>
+          </a:p>
+        </p:txBody>
+      </p:sp>
+      <p:sp>
+        <p:nvSpPr>
+          <p:cNvPr id="61" name="TextBox 60"/>
           <p:cNvSpPr txBox="1"/>
           <p:nvPr/>
         </p:nvSpPr>
         <p:spPr>
           <a:xfrm>
-            <a:off x="7653528" y="4151376"/>
-            <a:ext cx="1078992" cy="219456"/>
+            <a:off x="8631935" y="4123944"/>
+            <a:ext cx="3026664" cy="384048"/>
           </a:xfrm>
           <a:prstGeom prst="rect">
             <a:avLst/>
@@ -15147,29 +14988,29 @@
           <a:bodyPr wrap="square" anchor="t"/>
           <a:lstStyle/>
           <a:p>
-            <a:pPr algn="ctr"/>
-            <a:r>
-              <a:rPr sz="1000" b="1">
-                <a:solidFill>
-                  <a:srgbClr val="1E6B3D"/>
-                </a:solidFill>
-                <a:latin typeface="Calibri"/>
-              </a:rPr>
-              <a:t>COVERS MOST</a:t>
-            </a:r>
-          </a:p>
-        </p:txBody>
-      </p:sp>
-      <p:sp>
-        <p:nvSpPr>
-          <p:cNvPr id="69" name="TextBox 68"/>
+            <a:pPr algn="l"/>
+            <a:r>
+              <a:rPr sz="1300" b="1">
+                <a:solidFill>
+                  <a:srgbClr val="26303A"/>
+                </a:solidFill>
+                <a:latin typeface="Calibri"/>
+              </a:rPr>
+              <a:t>They cover bid comparison well, so no real gap here.</a:t>
+            </a:r>
+          </a:p>
+        </p:txBody>
+      </p:sp>
+      <p:sp>
+        <p:nvSpPr>
+          <p:cNvPr id="62" name="TextBox 61"/>
           <p:cNvSpPr txBox="1"/>
           <p:nvPr/>
         </p:nvSpPr>
         <p:spPr>
           <a:xfrm>
-            <a:off x="8787384" y="4133088"/>
-            <a:ext cx="2907792" cy="420624"/>
+            <a:off x="8631935" y="4535424"/>
+            <a:ext cx="3026664" cy="237744"/>
           </a:xfrm>
           <a:prstGeom prst="rect">
             <a:avLst/>
@@ -15184,39 +15025,6 @@
             <a:r>
               <a:rPr sz="1300" b="1">
                 <a:solidFill>
-                  <a:srgbClr val="26303A"/>
-                </a:solidFill>
-                <a:latin typeface="Calibri"/>
-              </a:rPr>
-              <a:t>They cover bid comparison well, so no real gap here.</a:t>
-            </a:r>
-          </a:p>
-        </p:txBody>
-      </p:sp>
-      <p:sp>
-        <p:nvSpPr>
-          <p:cNvPr id="70" name="TextBox 69"/>
-          <p:cNvSpPr txBox="1"/>
-          <p:nvPr/>
-        </p:nvSpPr>
-        <p:spPr>
-          <a:xfrm>
-            <a:off x="7653528" y="4572000"/>
-            <a:ext cx="4023360" cy="237744"/>
-          </a:xfrm>
-          <a:prstGeom prst="rect">
-            <a:avLst/>
-          </a:prstGeom>
-          <a:noFill/>
-        </p:spPr>
-        <p:txBody>
-          <a:bodyPr wrap="square" anchor="t"/>
-          <a:lstStyle/>
-          <a:p>
-            <a:pPr algn="l"/>
-            <a:r>
-              <a:rPr sz="1300" b="1">
-                <a:solidFill>
                   <a:srgbClr val="3A454F"/>
                 </a:solidFill>
                 <a:latin typeface="Calibri"/>
@@ -15228,14 +15036,14 @@
       </p:sp>
       <p:sp>
         <p:nvSpPr>
-          <p:cNvPr id="71" name="Rectangle 70"/>
+          <p:cNvPr id="63" name="Rectangle 62"/>
           <p:cNvSpPr/>
           <p:nvPr/>
         </p:nvSpPr>
         <p:spPr>
           <a:xfrm>
             <a:off x="384048" y="5696712"/>
-            <a:ext cx="2697480" cy="9144"/>
+            <a:ext cx="2962656" cy="9144"/>
           </a:xfrm>
           <a:prstGeom prst="rect">
             <a:avLst/>
@@ -15271,7 +15079,7 @@
       </p:sp>
       <p:sp>
         <p:nvSpPr>
-          <p:cNvPr id="72" name="Oval 71"/>
+          <p:cNvPr id="64" name="Oval 63"/>
           <p:cNvSpPr/>
           <p:nvPr/>
         </p:nvSpPr>
@@ -15323,14 +15131,14 @@
       </p:sp>
       <p:sp>
         <p:nvSpPr>
-          <p:cNvPr id="73" name="TextBox 72"/>
+          <p:cNvPr id="65" name="TextBox 64"/>
           <p:cNvSpPr txBox="1"/>
           <p:nvPr/>
         </p:nvSpPr>
         <p:spPr>
           <a:xfrm>
             <a:off x="768096" y="4992624"/>
-            <a:ext cx="2240280" cy="329184"/>
+            <a:ext cx="2505456" cy="329184"/>
           </a:xfrm>
           <a:prstGeom prst="rect">
             <a:avLst/>
@@ -15356,14 +15164,14 @@
       </p:sp>
       <p:sp>
         <p:nvSpPr>
-          <p:cNvPr id="74" name="Rounded Rectangle 73"/>
+          <p:cNvPr id="66" name="Rounded Rectangle 65"/>
           <p:cNvSpPr/>
           <p:nvPr/>
         </p:nvSpPr>
         <p:spPr>
           <a:xfrm>
             <a:off x="457200" y="5358384"/>
-            <a:ext cx="2523744" cy="274320"/>
+            <a:ext cx="2788920" cy="274320"/>
           </a:xfrm>
           <a:prstGeom prst="roundRect">
             <a:avLst>
@@ -15419,14 +15227,14 @@
       </p:sp>
       <p:sp>
         <p:nvSpPr>
-          <p:cNvPr id="75" name="Rectangle 74"/>
+          <p:cNvPr id="67" name="Rectangle 66"/>
           <p:cNvSpPr/>
           <p:nvPr/>
         </p:nvSpPr>
         <p:spPr>
           <a:xfrm>
-            <a:off x="3154680" y="5696712"/>
-            <a:ext cx="4297680" cy="9144"/>
+            <a:off x="3419856" y="5696712"/>
+            <a:ext cx="4151376" cy="9144"/>
           </a:xfrm>
           <a:prstGeom prst="rect">
             <a:avLst/>
@@ -15462,18 +15270,18 @@
       </p:sp>
       <p:sp>
         <p:nvSpPr>
-          <p:cNvPr id="76" name="Rounded Rectangle 75"/>
+          <p:cNvPr id="68" name="Rounded Rectangle 67"/>
           <p:cNvSpPr/>
           <p:nvPr/>
         </p:nvSpPr>
         <p:spPr>
           <a:xfrm>
-            <a:off x="3282696" y="4992624"/>
-            <a:ext cx="1078992" cy="219456"/>
+            <a:off x="3547872" y="4974336"/>
+            <a:ext cx="768096" cy="667512"/>
           </a:xfrm>
           <a:prstGeom prst="roundRect">
             <a:avLst>
-              <a:gd name="adj" fmla="val 4000"/>
+              <a:gd name="adj" fmla="val 5000"/>
             </a:avLst>
           </a:prstGeom>
           <a:solidFill>
@@ -15498,23 +15306,32 @@
           </a:fontRef>
         </p:style>
         <p:txBody>
-          <a:bodyPr rtlCol="0" anchor="ctr"/>
+          <a:bodyPr rtlCol="0" anchor="ctr" wrap="square" lIns="73152" rIns="73152" tIns="36576" bIns="36576"/>
           <a:lstStyle/>
           <a:p>
             <a:pPr algn="ctr"/>
-          </a:p>
-        </p:txBody>
-      </p:sp>
-      <p:sp>
-        <p:nvSpPr>
-          <p:cNvPr id="77" name="TextBox 76"/>
+            <a:r>
+              <a:rPr sz="1000" b="1">
+                <a:solidFill>
+                  <a:srgbClr val="8A5B14"/>
+                </a:solidFill>
+                <a:latin typeface="Calibri"/>
+              </a:rPr>
+              <a:t>PARTIAL</a:t>
+            </a:r>
+          </a:p>
+        </p:txBody>
+      </p:sp>
+      <p:sp>
+        <p:nvSpPr>
+          <p:cNvPr id="69" name="TextBox 68"/>
           <p:cNvSpPr txBox="1"/>
           <p:nvPr/>
         </p:nvSpPr>
         <p:spPr>
           <a:xfrm>
-            <a:off x="3282696" y="4992624"/>
-            <a:ext cx="1078992" cy="219456"/>
+            <a:off x="4407408" y="4965192"/>
+            <a:ext cx="3035808" cy="384048"/>
           </a:xfrm>
           <a:prstGeom prst="rect">
             <a:avLst/>
@@ -15525,29 +15342,29 @@
           <a:bodyPr wrap="square" anchor="t"/>
           <a:lstStyle/>
           <a:p>
-            <a:pPr algn="ctr"/>
-            <a:r>
-              <a:rPr sz="1000" b="1">
-                <a:solidFill>
-                  <a:srgbClr val="8A5B14"/>
-                </a:solidFill>
-                <a:latin typeface="Calibri"/>
-              </a:rPr>
-              <a:t>PARTIAL</a:t>
-            </a:r>
-          </a:p>
-        </p:txBody>
-      </p:sp>
-      <p:sp>
-        <p:nvSpPr>
-          <p:cNvPr id="78" name="TextBox 77"/>
+            <a:pPr algn="l"/>
+            <a:r>
+              <a:rPr sz="1300" b="1">
+                <a:solidFill>
+                  <a:srgbClr val="26303A"/>
+                </a:solidFill>
+                <a:latin typeface="Calibri"/>
+              </a:rPr>
+              <a:t>Systems of record are entrenched, but recording is fully manual.</a:t>
+            </a:r>
+          </a:p>
+        </p:txBody>
+      </p:sp>
+      <p:sp>
+        <p:nvSpPr>
+          <p:cNvPr id="70" name="TextBox 69"/>
           <p:cNvSpPr txBox="1"/>
           <p:nvPr/>
         </p:nvSpPr>
         <p:spPr>
           <a:xfrm>
-            <a:off x="4416552" y="4974336"/>
-            <a:ext cx="2926080" cy="420624"/>
+            <a:off x="4407408" y="5376672"/>
+            <a:ext cx="3035808" cy="237744"/>
           </a:xfrm>
           <a:prstGeom prst="rect">
             <a:avLst/>
@@ -15562,58 +15379,25 @@
             <a:r>
               <a:rPr sz="1300" b="1">
                 <a:solidFill>
-                  <a:srgbClr val="26303A"/>
-                </a:solidFill>
-                <a:latin typeface="Calibri"/>
-              </a:rPr>
-              <a:t>Systems of record are entrenched, but recording is fully manual.</a:t>
-            </a:r>
-          </a:p>
-        </p:txBody>
-      </p:sp>
-      <p:sp>
-        <p:nvSpPr>
-          <p:cNvPr id="79" name="TextBox 78"/>
-          <p:cNvSpPr txBox="1"/>
-          <p:nvPr/>
-        </p:nvSpPr>
-        <p:spPr>
-          <a:xfrm>
-            <a:off x="3282696" y="5413248"/>
-            <a:ext cx="4041648" cy="237744"/>
-          </a:xfrm>
-          <a:prstGeom prst="rect">
-            <a:avLst/>
-          </a:prstGeom>
-          <a:noFill/>
-        </p:spPr>
-        <p:txBody>
-          <a:bodyPr wrap="square" anchor="t"/>
-          <a:lstStyle/>
-          <a:p>
-            <a:pPr algn="l"/>
-            <a:r>
-              <a:rPr sz="1300" b="1">
-                <a:solidFill>
                   <a:srgbClr val="3A454F"/>
                 </a:solidFill>
                 <a:latin typeface="Calibri"/>
               </a:rPr>
-              <a:t>Procore   ·   Oracle Primavera   ·   Autodesk ACC</a:t>
-            </a:r>
-          </a:p>
-        </p:txBody>
-      </p:sp>
-      <p:sp>
-        <p:nvSpPr>
-          <p:cNvPr id="80" name="Rectangle 79"/>
+              <a:t>Procore   ·   Primavera   ·   Autodesk ACC</a:t>
+            </a:r>
+          </a:p>
+        </p:txBody>
+      </p:sp>
+      <p:sp>
+        <p:nvSpPr>
+          <p:cNvPr id="71" name="Rectangle 70"/>
           <p:cNvSpPr/>
           <p:nvPr/>
         </p:nvSpPr>
         <p:spPr>
           <a:xfrm>
-            <a:off x="7525512" y="5696712"/>
-            <a:ext cx="4279392" cy="9144"/>
+            <a:off x="7644383" y="5696712"/>
+            <a:ext cx="4142232" cy="9144"/>
           </a:xfrm>
           <a:prstGeom prst="rect">
             <a:avLst/>
@@ -15649,18 +15433,18 @@
       </p:sp>
       <p:sp>
         <p:nvSpPr>
-          <p:cNvPr id="81" name="Rounded Rectangle 80"/>
+          <p:cNvPr id="72" name="Rounded Rectangle 71"/>
           <p:cNvSpPr/>
           <p:nvPr/>
         </p:nvSpPr>
         <p:spPr>
           <a:xfrm>
-            <a:off x="7653528" y="4992624"/>
-            <a:ext cx="1078992" cy="219456"/>
+            <a:off x="7772399" y="4974336"/>
+            <a:ext cx="768096" cy="667512"/>
           </a:xfrm>
           <a:prstGeom prst="roundRect">
             <a:avLst>
-              <a:gd name="adj" fmla="val 4000"/>
+              <a:gd name="adj" fmla="val 5000"/>
             </a:avLst>
           </a:prstGeom>
           <a:solidFill>
@@ -15685,23 +15469,32 @@
           </a:fontRef>
         </p:style>
         <p:txBody>
-          <a:bodyPr rtlCol="0" anchor="ctr"/>
+          <a:bodyPr rtlCol="0" anchor="ctr" wrap="square" lIns="73152" rIns="73152" tIns="36576" bIns="36576"/>
           <a:lstStyle/>
           <a:p>
             <a:pPr algn="ctr"/>
-          </a:p>
-        </p:txBody>
-      </p:sp>
-      <p:sp>
-        <p:nvSpPr>
-          <p:cNvPr id="82" name="TextBox 81"/>
+            <a:r>
+              <a:rPr sz="1000" b="1">
+                <a:solidFill>
+                  <a:srgbClr val="8A5B14"/>
+                </a:solidFill>
+                <a:latin typeface="Calibri"/>
+              </a:rPr>
+              <a:t>PARTIAL</a:t>
+            </a:r>
+          </a:p>
+        </p:txBody>
+      </p:sp>
+      <p:sp>
+        <p:nvSpPr>
+          <p:cNvPr id="73" name="TextBox 72"/>
           <p:cNvSpPr txBox="1"/>
           <p:nvPr/>
         </p:nvSpPr>
         <p:spPr>
           <a:xfrm>
-            <a:off x="7653528" y="4992624"/>
-            <a:ext cx="1078992" cy="219456"/>
+            <a:off x="8631935" y="4965192"/>
+            <a:ext cx="3026664" cy="384048"/>
           </a:xfrm>
           <a:prstGeom prst="rect">
             <a:avLst/>
@@ -15712,29 +15505,29 @@
           <a:bodyPr wrap="square" anchor="t"/>
           <a:lstStyle/>
           <a:p>
-            <a:pPr algn="ctr"/>
-            <a:r>
-              <a:rPr sz="1000" b="1">
-                <a:solidFill>
-                  <a:srgbClr val="8A5B14"/>
-                </a:solidFill>
-                <a:latin typeface="Calibri"/>
-              </a:rPr>
-              <a:t>PARTIAL</a:t>
-            </a:r>
-          </a:p>
-        </p:txBody>
-      </p:sp>
-      <p:sp>
-        <p:nvSpPr>
-          <p:cNvPr id="83" name="TextBox 82"/>
+            <a:pPr algn="l"/>
+            <a:r>
+              <a:rPr sz="1300" b="1">
+                <a:solidFill>
+                  <a:srgbClr val="26303A"/>
+                </a:solidFill>
+                <a:latin typeface="Calibri"/>
+              </a:rPr>
+              <a:t>Physical progress capture only, with no contract or IPC cost tracking.</a:t>
+            </a:r>
+          </a:p>
+        </p:txBody>
+      </p:sp>
+      <p:sp>
+        <p:nvSpPr>
+          <p:cNvPr id="74" name="TextBox 73"/>
           <p:cNvSpPr txBox="1"/>
           <p:nvPr/>
         </p:nvSpPr>
         <p:spPr>
           <a:xfrm>
-            <a:off x="8787384" y="4974336"/>
-            <a:ext cx="2907792" cy="420624"/>
+            <a:off x="8631935" y="5376672"/>
+            <a:ext cx="3026664" cy="237744"/>
           </a:xfrm>
           <a:prstGeom prst="rect">
             <a:avLst/>
@@ -15749,39 +15542,6 @@
             <a:r>
               <a:rPr sz="1300" b="1">
                 <a:solidFill>
-                  <a:srgbClr val="26303A"/>
-                </a:solidFill>
-                <a:latin typeface="Calibri"/>
-              </a:rPr>
-              <a:t>Physical progress capture only, with no contract or IPC cost tracking.</a:t>
-            </a:r>
-          </a:p>
-        </p:txBody>
-      </p:sp>
-      <p:sp>
-        <p:nvSpPr>
-          <p:cNvPr id="84" name="TextBox 83"/>
-          <p:cNvSpPr txBox="1"/>
-          <p:nvPr/>
-        </p:nvSpPr>
-        <p:spPr>
-          <a:xfrm>
-            <a:off x="7653528" y="5413248"/>
-            <a:ext cx="4023360" cy="237744"/>
-          </a:xfrm>
-          <a:prstGeom prst="rect">
-            <a:avLst/>
-          </a:prstGeom>
-          <a:noFill/>
-        </p:spPr>
-        <p:txBody>
-          <a:bodyPr wrap="square" anchor="t"/>
-          <a:lstStyle/>
-          <a:p>
-            <a:pPr algn="l"/>
-            <a:r>
-              <a:rPr sz="1300" b="1">
-                <a:solidFill>
                   <a:srgbClr val="3A454F"/>
                 </a:solidFill>
                 <a:latin typeface="Calibri"/>
@@ -15793,14 +15553,14 @@
       </p:sp>
       <p:sp>
         <p:nvSpPr>
-          <p:cNvPr id="85" name="Rectangle 84"/>
+          <p:cNvPr id="75" name="Rectangle 74"/>
           <p:cNvSpPr/>
           <p:nvPr/>
         </p:nvSpPr>
         <p:spPr>
           <a:xfrm>
             <a:off x="384048" y="6537960"/>
-            <a:ext cx="2697480" cy="9144"/>
+            <a:ext cx="2962656" cy="9144"/>
           </a:xfrm>
           <a:prstGeom prst="rect">
             <a:avLst/>
@@ -15836,7 +15596,7 @@
       </p:sp>
       <p:sp>
         <p:nvSpPr>
-          <p:cNvPr id="86" name="Oval 85"/>
+          <p:cNvPr id="76" name="Oval 75"/>
           <p:cNvSpPr/>
           <p:nvPr/>
         </p:nvSpPr>
@@ -15888,14 +15648,14 @@
       </p:sp>
       <p:sp>
         <p:nvSpPr>
-          <p:cNvPr id="87" name="TextBox 86"/>
+          <p:cNvPr id="77" name="TextBox 76"/>
           <p:cNvSpPr txBox="1"/>
           <p:nvPr/>
         </p:nvSpPr>
         <p:spPr>
           <a:xfrm>
             <a:off x="768096" y="5833872"/>
-            <a:ext cx="2240280" cy="329184"/>
+            <a:ext cx="2505456" cy="329184"/>
           </a:xfrm>
           <a:prstGeom prst="rect">
             <a:avLst/>
@@ -15921,14 +15681,14 @@
       </p:sp>
       <p:sp>
         <p:nvSpPr>
-          <p:cNvPr id="88" name="Rounded Rectangle 87"/>
+          <p:cNvPr id="78" name="Rounded Rectangle 77"/>
           <p:cNvSpPr/>
           <p:nvPr/>
         </p:nvSpPr>
         <p:spPr>
           <a:xfrm>
             <a:off x="457200" y="6199632"/>
-            <a:ext cx="2523744" cy="274320"/>
+            <a:ext cx="2788920" cy="274320"/>
           </a:xfrm>
           <a:prstGeom prst="roundRect">
             <a:avLst>
@@ -15984,14 +15744,14 @@
       </p:sp>
       <p:sp>
         <p:nvSpPr>
-          <p:cNvPr id="89" name="Rectangle 88"/>
+          <p:cNvPr id="79" name="Rectangle 78"/>
           <p:cNvSpPr/>
           <p:nvPr/>
         </p:nvSpPr>
         <p:spPr>
           <a:xfrm>
-            <a:off x="3154680" y="6537960"/>
-            <a:ext cx="4297680" cy="9144"/>
+            <a:off x="3419856" y="6537960"/>
+            <a:ext cx="4151376" cy="9144"/>
           </a:xfrm>
           <a:prstGeom prst="rect">
             <a:avLst/>
@@ -16027,18 +15787,18 @@
       </p:sp>
       <p:sp>
         <p:nvSpPr>
-          <p:cNvPr id="90" name="Rounded Rectangle 89"/>
+          <p:cNvPr id="80" name="Rounded Rectangle 79"/>
           <p:cNvSpPr/>
           <p:nvPr/>
         </p:nvSpPr>
         <p:spPr>
           <a:xfrm>
-            <a:off x="3282696" y="5833872"/>
-            <a:ext cx="1078992" cy="219456"/>
+            <a:off x="3547872" y="5815584"/>
+            <a:ext cx="768096" cy="667512"/>
           </a:xfrm>
           <a:prstGeom prst="roundRect">
             <a:avLst>
-              <a:gd name="adj" fmla="val 4000"/>
+              <a:gd name="adj" fmla="val 5000"/>
             </a:avLst>
           </a:prstGeom>
           <a:solidFill>
@@ -16063,23 +15823,32 @@
           </a:fontRef>
         </p:style>
         <p:txBody>
-          <a:bodyPr rtlCol="0" anchor="ctr"/>
+          <a:bodyPr rtlCol="0" anchor="ctr" wrap="square" lIns="73152" rIns="73152" tIns="36576" bIns="36576"/>
           <a:lstStyle/>
           <a:p>
             <a:pPr algn="ctr"/>
-          </a:p>
-        </p:txBody>
-      </p:sp>
-      <p:sp>
-        <p:nvSpPr>
-          <p:cNvPr id="91" name="TextBox 90"/>
+            <a:r>
+              <a:rPr sz="1000" b="1">
+                <a:solidFill>
+                  <a:srgbClr val="9B3328"/>
+                </a:solidFill>
+                <a:latin typeface="Calibri"/>
+              </a:rPr>
+              <a:t>BARELY</a:t>
+            </a:r>
+          </a:p>
+        </p:txBody>
+      </p:sp>
+      <p:sp>
+        <p:nvSpPr>
+          <p:cNvPr id="81" name="TextBox 80"/>
           <p:cNvSpPr txBox="1"/>
           <p:nvPr/>
         </p:nvSpPr>
         <p:spPr>
           <a:xfrm>
-            <a:off x="3282696" y="5833872"/>
-            <a:ext cx="1078992" cy="219456"/>
+            <a:off x="4407408" y="5806440"/>
+            <a:ext cx="3035808" cy="384048"/>
           </a:xfrm>
           <a:prstGeom prst="rect">
             <a:avLst/>
@@ -16090,29 +15859,29 @@
           <a:bodyPr wrap="square" anchor="t"/>
           <a:lstStyle/>
           <a:p>
-            <a:pPr algn="ctr"/>
-            <a:r>
-              <a:rPr sz="1000" b="1">
-                <a:solidFill>
-                  <a:srgbClr val="9B3328"/>
-                </a:solidFill>
-                <a:latin typeface="Calibri"/>
-              </a:rPr>
-              <a:t>BARELY</a:t>
-            </a:r>
-          </a:p>
-        </p:txBody>
-      </p:sp>
-      <p:sp>
-        <p:nvSpPr>
-          <p:cNvPr id="92" name="TextBox 91"/>
+            <a:pPr algn="l"/>
+            <a:r>
+              <a:rPr sz="1300" b="1">
+                <a:solidFill>
+                  <a:srgbClr val="26303A"/>
+                </a:solidFill>
+                <a:latin typeface="Calibri"/>
+              </a:rPr>
+              <a:t>Static what-if analysis at gates; no continuous savings loop anywhere.</a:t>
+            </a:r>
+          </a:p>
+        </p:txBody>
+      </p:sp>
+      <p:sp>
+        <p:nvSpPr>
+          <p:cNvPr id="82" name="TextBox 81"/>
           <p:cNvSpPr txBox="1"/>
           <p:nvPr/>
         </p:nvSpPr>
         <p:spPr>
           <a:xfrm>
-            <a:off x="4416552" y="5815584"/>
-            <a:ext cx="2926080" cy="420624"/>
+            <a:off x="4407408" y="6217920"/>
+            <a:ext cx="3035808" cy="237744"/>
           </a:xfrm>
           <a:prstGeom prst="rect">
             <a:avLst/>
@@ -16127,39 +15896,6 @@
             <a:r>
               <a:rPr sz="1300" b="1">
                 <a:solidFill>
-                  <a:srgbClr val="26303A"/>
-                </a:solidFill>
-                <a:latin typeface="Calibri"/>
-              </a:rPr>
-              <a:t>Static what-if analysis at gates; no continuous savings loop anywhere.</a:t>
-            </a:r>
-          </a:p>
-        </p:txBody>
-      </p:sp>
-      <p:sp>
-        <p:nvSpPr>
-          <p:cNvPr id="93" name="TextBox 92"/>
-          <p:cNvSpPr txBox="1"/>
-          <p:nvPr/>
-        </p:nvSpPr>
-        <p:spPr>
-          <a:xfrm>
-            <a:off x="3282696" y="6254496"/>
-            <a:ext cx="4041648" cy="237744"/>
-          </a:xfrm>
-          <a:prstGeom prst="rect">
-            <a:avLst/>
-          </a:prstGeom>
-          <a:noFill/>
-        </p:spPr>
-        <p:txBody>
-          <a:bodyPr wrap="square" anchor="t"/>
-          <a:lstStyle/>
-          <a:p>
-            <a:pPr algn="l"/>
-            <a:r>
-              <a:rPr sz="1300" b="1">
-                <a:solidFill>
                   <a:srgbClr val="3A454F"/>
                 </a:solidFill>
                 <a:latin typeface="Calibri"/>
@@ -16171,14 +15907,14 @@
       </p:sp>
       <p:sp>
         <p:nvSpPr>
-          <p:cNvPr id="94" name="Rectangle 93"/>
+          <p:cNvPr id="83" name="Rectangle 82"/>
           <p:cNvSpPr/>
           <p:nvPr/>
         </p:nvSpPr>
         <p:spPr>
           <a:xfrm>
-            <a:off x="7525512" y="6537960"/>
-            <a:ext cx="4279392" cy="9144"/>
+            <a:off x="7644383" y="6537960"/>
+            <a:ext cx="4142232" cy="9144"/>
           </a:xfrm>
           <a:prstGeom prst="rect">
             <a:avLst/>
@@ -16214,18 +15950,18 @@
       </p:sp>
       <p:sp>
         <p:nvSpPr>
-          <p:cNvPr id="95" name="Rounded Rectangle 94"/>
+          <p:cNvPr id="84" name="Rounded Rectangle 83"/>
           <p:cNvSpPr/>
           <p:nvPr/>
         </p:nvSpPr>
         <p:spPr>
           <a:xfrm>
-            <a:off x="7653528" y="5833872"/>
-            <a:ext cx="1078992" cy="219456"/>
+            <a:off x="7772399" y="5815584"/>
+            <a:ext cx="768096" cy="667512"/>
           </a:xfrm>
           <a:prstGeom prst="roundRect">
             <a:avLst>
-              <a:gd name="adj" fmla="val 4000"/>
+              <a:gd name="adj" fmla="val 5000"/>
             </a:avLst>
           </a:prstGeom>
           <a:solidFill>
@@ -16250,23 +15986,32 @@
           </a:fontRef>
         </p:style>
         <p:txBody>
-          <a:bodyPr rtlCol="0" anchor="ctr"/>
+          <a:bodyPr rtlCol="0" anchor="ctr" wrap="square" lIns="73152" rIns="73152" tIns="36576" bIns="36576"/>
           <a:lstStyle/>
           <a:p>
             <a:pPr algn="ctr"/>
-          </a:p>
-        </p:txBody>
-      </p:sp>
-      <p:sp>
-        <p:nvSpPr>
-          <p:cNvPr id="96" name="TextBox 95"/>
+            <a:r>
+              <a:rPr sz="1000" b="1">
+                <a:solidFill>
+                  <a:srgbClr val="8A5B14"/>
+                </a:solidFill>
+                <a:latin typeface="Calibri"/>
+              </a:rPr>
+              <a:t>PARTIAL</a:t>
+            </a:r>
+          </a:p>
+        </p:txBody>
+      </p:sp>
+      <p:sp>
+        <p:nvSpPr>
+          <p:cNvPr id="85" name="TextBox 84"/>
           <p:cNvSpPr txBox="1"/>
           <p:nvPr/>
         </p:nvSpPr>
         <p:spPr>
           <a:xfrm>
-            <a:off x="7653528" y="5833872"/>
-            <a:ext cx="1078992" cy="219456"/>
+            <a:off x="8631935" y="5806440"/>
+            <a:ext cx="3026664" cy="384048"/>
           </a:xfrm>
           <a:prstGeom prst="rect">
             <a:avLst/>
@@ -16277,62 +16022,29 @@
           <a:bodyPr wrap="square" anchor="t"/>
           <a:lstStyle/>
           <a:p>
-            <a:pPr algn="ctr"/>
-            <a:r>
-              <a:rPr sz="1000" b="1">
-                <a:solidFill>
-                  <a:srgbClr val="8A5B14"/>
-                </a:solidFill>
-                <a:latin typeface="Calibri"/>
-              </a:rPr>
-              <a:t>PARTIAL</a:t>
-            </a:r>
-          </a:p>
-        </p:txBody>
-      </p:sp>
-      <p:sp>
-        <p:nvSpPr>
-          <p:cNvPr id="97" name="TextBox 96"/>
+            <a:pPr algn="l"/>
+            <a:r>
+              <a:rPr sz="1300" b="1">
+                <a:solidFill>
+                  <a:srgbClr val="26303A"/>
+                </a:solidFill>
+                <a:latin typeface="Calibri"/>
+              </a:rPr>
+              <a:t>Optimization exists for schedule; cost value is left untouched.</a:t>
+            </a:r>
+          </a:p>
+        </p:txBody>
+      </p:sp>
+      <p:sp>
+        <p:nvSpPr>
+          <p:cNvPr id="86" name="TextBox 85"/>
           <p:cNvSpPr txBox="1"/>
           <p:nvPr/>
         </p:nvSpPr>
         <p:spPr>
           <a:xfrm>
-            <a:off x="8787384" y="5815584"/>
-            <a:ext cx="2907792" cy="420624"/>
-          </a:xfrm>
-          <a:prstGeom prst="rect">
-            <a:avLst/>
-          </a:prstGeom>
-          <a:noFill/>
-        </p:spPr>
-        <p:txBody>
-          <a:bodyPr wrap="square" anchor="t"/>
-          <a:lstStyle/>
-          <a:p>
-            <a:pPr algn="l"/>
-            <a:r>
-              <a:rPr sz="1300" b="1">
-                <a:solidFill>
-                  <a:srgbClr val="26303A"/>
-                </a:solidFill>
-                <a:latin typeface="Calibri"/>
-              </a:rPr>
-              <a:t>Optimization exists for schedule; cost value is left untouched.</a:t>
-            </a:r>
-          </a:p>
-        </p:txBody>
-      </p:sp>
-      <p:sp>
-        <p:nvSpPr>
-          <p:cNvPr id="98" name="TextBox 97"/>
-          <p:cNvSpPr txBox="1"/>
-          <p:nvPr/>
-        </p:nvSpPr>
-        <p:spPr>
-          <a:xfrm>
-            <a:off x="7653528" y="6254496"/>
-            <a:ext cx="4023360" cy="237744"/>
+            <a:off x="8631935" y="6217920"/>
+            <a:ext cx="3026664" cy="237744"/>
           </a:xfrm>
           <a:prstGeom prst="rect">
             <a:avLst/>

</xml_diff>

<commit_message>
Page 3: simplify each archetype to a header, its players and one takeaway
Co-authored-by: ersoysarp <ersoysarp@users.noreply.github.com>
</commit_message>
<xml_diff>
--- a/BlueCurrency.pptx
+++ b/BlueCurrency.pptx
@@ -9870,7 +9870,7 @@
                 </a:solidFill>
                 <a:latin typeface="Calibri"/>
               </a:rPr>
-              <a:t>, and we sit deliberately between them, not at the far corner</a:t>
+              <a:t>, and we sit deliberately between them</a:t>
             </a:r>
           </a:p>
         </p:txBody>
@@ -9923,11 +9923,11 @@
           </a:xfrm>
           <a:prstGeom prst="roundRect">
             <a:avLst>
-              <a:gd name="adj" fmla="val 8000"/>
+              <a:gd name="adj" fmla="val 4000"/>
             </a:avLst>
           </a:prstGeom>
           <a:solidFill>
-            <a:srgbClr val="F7F9F9"/>
+            <a:srgbClr val="FFFFFF"/>
           </a:solidFill>
           <a:ln w="9525">
             <a:solidFill>
@@ -9965,7 +9965,7 @@
         </p:nvSpPr>
         <p:spPr>
           <a:xfrm>
-            <a:off x="603504" y="1078992"/>
+            <a:off x="621792" y="1097280"/>
             <a:ext cx="5120640" cy="274320"/>
           </a:xfrm>
           <a:prstGeom prst="rect">
@@ -10003,47 +10003,14 @@
       </p:sp>
       <p:sp>
         <p:nvSpPr>
-          <p:cNvPr id="8" name="TextBox 7"/>
-          <p:cNvSpPr txBox="1"/>
-          <p:nvPr/>
-        </p:nvSpPr>
-        <p:spPr>
-          <a:xfrm>
-            <a:off x="603504" y="1335024"/>
-            <a:ext cx="5120640" cy="256032"/>
-          </a:xfrm>
-          <a:prstGeom prst="rect">
-            <a:avLst/>
-          </a:prstGeom>
-          <a:noFill/>
-        </p:spPr>
-        <p:txBody>
-          <a:bodyPr wrap="square" anchor="t"/>
-          <a:lstStyle/>
-          <a:p>
-            <a:pPr algn="l"/>
-            <a:r>
-              <a:rPr sz="1400" b="0">
-                <a:solidFill>
-                  <a:srgbClr val="3A454F"/>
-                </a:solidFill>
-                <a:latin typeface="Calibri"/>
-              </a:rPr>
-              <a:t>Built on models from day one, excellent at the one step they own.</a:t>
-            </a:r>
-          </a:p>
-        </p:txBody>
-      </p:sp>
-      <p:sp>
-        <p:nvSpPr>
-          <p:cNvPr id="9" name="Rounded Rectangle 8"/>
+          <p:cNvPr id="8" name="Rounded Rectangle 7"/>
           <p:cNvSpPr/>
           <p:nvPr/>
         </p:nvSpPr>
         <p:spPr>
           <a:xfrm>
-            <a:off x="603504" y="1645920"/>
-            <a:ext cx="1005840" cy="274320"/>
+            <a:off x="621792" y="1517904"/>
+            <a:ext cx="987552" cy="274320"/>
           </a:xfrm>
           <a:prstGeom prst="roundRect">
             <a:avLst>
@@ -10051,11 +10018,11 @@
             </a:avLst>
           </a:prstGeom>
           <a:solidFill>
-            <a:srgbClr val="FFFFFF"/>
+            <a:srgbClr val="E4F1EF"/>
           </a:solidFill>
           <a:ln w="9525">
             <a:solidFill>
-              <a:srgbClr val="BBD9D5"/>
+              <a:srgbClr val="CFE4E0"/>
             </a:solidFill>
           </a:ln>
         </p:spPr>
@@ -10092,14 +10059,14 @@
       </p:sp>
       <p:sp>
         <p:nvSpPr>
-          <p:cNvPr id="10" name="Rounded Rectangle 9"/>
+          <p:cNvPr id="9" name="Rounded Rectangle 8"/>
           <p:cNvSpPr/>
           <p:nvPr/>
         </p:nvSpPr>
         <p:spPr>
           <a:xfrm>
-            <a:off x="1664208" y="1645920"/>
-            <a:ext cx="1005840" cy="274320"/>
+            <a:off x="1664208" y="1517904"/>
+            <a:ext cx="987552" cy="274320"/>
           </a:xfrm>
           <a:prstGeom prst="roundRect">
             <a:avLst>
@@ -10107,11 +10074,11 @@
             </a:avLst>
           </a:prstGeom>
           <a:solidFill>
-            <a:srgbClr val="FFFFFF"/>
+            <a:srgbClr val="E4F1EF"/>
           </a:solidFill>
           <a:ln w="9525">
             <a:solidFill>
-              <a:srgbClr val="BBD9D5"/>
+              <a:srgbClr val="CFE4E0"/>
             </a:solidFill>
           </a:ln>
         </p:spPr>
@@ -10148,14 +10115,14 @@
       </p:sp>
       <p:sp>
         <p:nvSpPr>
-          <p:cNvPr id="11" name="Rounded Rectangle 10"/>
+          <p:cNvPr id="10" name="Rounded Rectangle 9"/>
           <p:cNvSpPr/>
           <p:nvPr/>
         </p:nvSpPr>
         <p:spPr>
           <a:xfrm>
-            <a:off x="2724912" y="1645920"/>
-            <a:ext cx="1005840" cy="274320"/>
+            <a:off x="2706624" y="1517904"/>
+            <a:ext cx="987552" cy="274320"/>
           </a:xfrm>
           <a:prstGeom prst="roundRect">
             <a:avLst>
@@ -10163,11 +10130,11 @@
             </a:avLst>
           </a:prstGeom>
           <a:solidFill>
-            <a:srgbClr val="FFFFFF"/>
+            <a:srgbClr val="E4F1EF"/>
           </a:solidFill>
           <a:ln w="9525">
             <a:solidFill>
-              <a:srgbClr val="BBD9D5"/>
+              <a:srgbClr val="CFE4E0"/>
             </a:solidFill>
           </a:ln>
         </p:spPr>
@@ -10204,14 +10171,14 @@
       </p:sp>
       <p:sp>
         <p:nvSpPr>
-          <p:cNvPr id="12" name="Rounded Rectangle 11"/>
+          <p:cNvPr id="11" name="Rounded Rectangle 10"/>
           <p:cNvSpPr/>
           <p:nvPr/>
         </p:nvSpPr>
         <p:spPr>
           <a:xfrm>
-            <a:off x="3785616" y="1645920"/>
-            <a:ext cx="1005840" cy="274320"/>
+            <a:off x="3749040" y="1517904"/>
+            <a:ext cx="987552" cy="274320"/>
           </a:xfrm>
           <a:prstGeom prst="roundRect">
             <a:avLst>
@@ -10219,11 +10186,11 @@
             </a:avLst>
           </a:prstGeom>
           <a:solidFill>
-            <a:srgbClr val="FFFFFF"/>
+            <a:srgbClr val="E4F1EF"/>
           </a:solidFill>
           <a:ln w="9525">
             <a:solidFill>
-              <a:srgbClr val="BBD9D5"/>
+              <a:srgbClr val="CFE4E0"/>
             </a:solidFill>
           </a:ln>
         </p:spPr>
@@ -10260,14 +10227,14 @@
       </p:sp>
       <p:sp>
         <p:nvSpPr>
-          <p:cNvPr id="13" name="Rounded Rectangle 12"/>
+          <p:cNvPr id="12" name="Rounded Rectangle 11"/>
           <p:cNvSpPr/>
           <p:nvPr/>
         </p:nvSpPr>
         <p:spPr>
           <a:xfrm>
-            <a:off x="4846320" y="1645920"/>
-            <a:ext cx="1005840" cy="274320"/>
+            <a:off x="4791456" y="1517904"/>
+            <a:ext cx="987552" cy="274320"/>
           </a:xfrm>
           <a:prstGeom prst="roundRect">
             <a:avLst>
@@ -10275,11 +10242,11 @@
             </a:avLst>
           </a:prstGeom>
           <a:solidFill>
-            <a:srgbClr val="FFFFFF"/>
+            <a:srgbClr val="E4F1EF"/>
           </a:solidFill>
           <a:ln w="9525">
             <a:solidFill>
-              <a:srgbClr val="BBD9D5"/>
+              <a:srgbClr val="CFE4E0"/>
             </a:solidFill>
           </a:ln>
         </p:spPr>
@@ -10316,14 +10283,14 @@
       </p:sp>
       <p:sp>
         <p:nvSpPr>
-          <p:cNvPr id="14" name="Rounded Rectangle 13"/>
+          <p:cNvPr id="13" name="Rounded Rectangle 12"/>
           <p:cNvSpPr/>
           <p:nvPr/>
         </p:nvSpPr>
         <p:spPr>
           <a:xfrm>
-            <a:off x="603504" y="1975104"/>
-            <a:ext cx="1005840" cy="274320"/>
+            <a:off x="621792" y="1847088"/>
+            <a:ext cx="987552" cy="274320"/>
           </a:xfrm>
           <a:prstGeom prst="roundRect">
             <a:avLst>
@@ -10331,11 +10298,11 @@
             </a:avLst>
           </a:prstGeom>
           <a:solidFill>
-            <a:srgbClr val="FFFFFF"/>
+            <a:srgbClr val="E4F1EF"/>
           </a:solidFill>
           <a:ln w="9525">
             <a:solidFill>
-              <a:srgbClr val="BBD9D5"/>
+              <a:srgbClr val="CFE4E0"/>
             </a:solidFill>
           </a:ln>
         </p:spPr>
@@ -10372,14 +10339,14 @@
       </p:sp>
       <p:sp>
         <p:nvSpPr>
-          <p:cNvPr id="15" name="Rounded Rectangle 14"/>
+          <p:cNvPr id="14" name="Rounded Rectangle 13"/>
           <p:cNvSpPr/>
           <p:nvPr/>
         </p:nvSpPr>
         <p:spPr>
           <a:xfrm>
-            <a:off x="1664208" y="1975104"/>
-            <a:ext cx="1005840" cy="274320"/>
+            <a:off x="1664208" y="1847088"/>
+            <a:ext cx="987552" cy="274320"/>
           </a:xfrm>
           <a:prstGeom prst="roundRect">
             <a:avLst>
@@ -10387,11 +10354,11 @@
             </a:avLst>
           </a:prstGeom>
           <a:solidFill>
-            <a:srgbClr val="FFFFFF"/>
+            <a:srgbClr val="E4F1EF"/>
           </a:solidFill>
           <a:ln w="9525">
             <a:solidFill>
-              <a:srgbClr val="BBD9D5"/>
+              <a:srgbClr val="CFE4E0"/>
             </a:solidFill>
           </a:ln>
         </p:spPr>
@@ -10428,14 +10395,14 @@
       </p:sp>
       <p:sp>
         <p:nvSpPr>
-          <p:cNvPr id="16" name="Rounded Rectangle 15"/>
+          <p:cNvPr id="15" name="Rounded Rectangle 14"/>
           <p:cNvSpPr/>
           <p:nvPr/>
         </p:nvSpPr>
         <p:spPr>
           <a:xfrm>
-            <a:off x="2724912" y="1975104"/>
-            <a:ext cx="1005840" cy="274320"/>
+            <a:off x="2706624" y="1847088"/>
+            <a:ext cx="987552" cy="274320"/>
           </a:xfrm>
           <a:prstGeom prst="roundRect">
             <a:avLst>
@@ -10443,11 +10410,11 @@
             </a:avLst>
           </a:prstGeom>
           <a:solidFill>
-            <a:srgbClr val="FFFFFF"/>
+            <a:srgbClr val="E4F1EF"/>
           </a:solidFill>
           <a:ln w="9525">
             <a:solidFill>
-              <a:srgbClr val="BBD9D5"/>
+              <a:srgbClr val="CFE4E0"/>
             </a:solidFill>
           </a:ln>
         </p:spPr>
@@ -10484,14 +10451,14 @@
       </p:sp>
       <p:sp>
         <p:nvSpPr>
-          <p:cNvPr id="17" name="Rounded Rectangle 16"/>
+          <p:cNvPr id="16" name="Rounded Rectangle 15"/>
           <p:cNvSpPr/>
           <p:nvPr/>
         </p:nvSpPr>
         <p:spPr>
           <a:xfrm>
-            <a:off x="3785616" y="1975104"/>
-            <a:ext cx="1005840" cy="274320"/>
+            <a:off x="3749040" y="1847088"/>
+            <a:ext cx="987552" cy="274320"/>
           </a:xfrm>
           <a:prstGeom prst="roundRect">
             <a:avLst>
@@ -10499,11 +10466,11 @@
             </a:avLst>
           </a:prstGeom>
           <a:solidFill>
-            <a:srgbClr val="FFFFFF"/>
+            <a:srgbClr val="E4F1EF"/>
           </a:solidFill>
           <a:ln w="9525">
             <a:solidFill>
-              <a:srgbClr val="BBD9D5"/>
+              <a:srgbClr val="CFE4E0"/>
             </a:solidFill>
           </a:ln>
         </p:spPr>
@@ -10540,14 +10507,14 @@
       </p:sp>
       <p:sp>
         <p:nvSpPr>
-          <p:cNvPr id="18" name="Rounded Rectangle 17"/>
+          <p:cNvPr id="17" name="Rounded Rectangle 16"/>
           <p:cNvSpPr/>
           <p:nvPr/>
         </p:nvSpPr>
         <p:spPr>
           <a:xfrm>
-            <a:off x="4846320" y="1975104"/>
-            <a:ext cx="1005840" cy="274320"/>
+            <a:off x="4791456" y="1847088"/>
+            <a:ext cx="987552" cy="274320"/>
           </a:xfrm>
           <a:prstGeom prst="roundRect">
             <a:avLst>
@@ -10555,11 +10522,11 @@
             </a:avLst>
           </a:prstGeom>
           <a:solidFill>
-            <a:srgbClr val="FFFFFF"/>
+            <a:srgbClr val="E4F1EF"/>
           </a:solidFill>
           <a:ln w="9525">
             <a:solidFill>
-              <a:srgbClr val="BBD9D5"/>
+              <a:srgbClr val="CFE4E0"/>
             </a:solidFill>
           </a:ln>
         </p:spPr>
@@ -10596,104 +10563,23 @@
       </p:sp>
       <p:sp>
         <p:nvSpPr>
-          <p:cNvPr id="19" name="TextBox 18"/>
-          <p:cNvSpPr txBox="1"/>
-          <p:nvPr/>
-        </p:nvSpPr>
-        <p:spPr>
-          <a:xfrm>
-            <a:off x="603504" y="2377440"/>
-            <a:ext cx="5120640" cy="219456"/>
+          <p:cNvPr id="18" name="Rectangle 17"/>
+          <p:cNvSpPr/>
+          <p:nvPr/>
+        </p:nvSpPr>
+        <p:spPr>
+          <a:xfrm>
+            <a:off x="621792" y="2615183"/>
+            <a:ext cx="5148072" cy="9144"/>
           </a:xfrm>
           <a:prstGeom prst="rect">
             <a:avLst/>
           </a:prstGeom>
-          <a:noFill/>
-        </p:spPr>
-        <p:txBody>
-          <a:bodyPr wrap="square" anchor="t"/>
-          <a:lstStyle/>
-          <a:p>
-            <a:pPr algn="l"/>
-            <a:r>
-              <a:rPr sz="1400" b="0">
-                <a:solidFill>
-                  <a:srgbClr val="6B7580"/>
-                </a:solidFill>
-                <a:latin typeface="Calibri"/>
-              </a:rPr>
-              <a:t>Strong in  takeoff, cost classification, tendering, site progress</a:t>
-            </a:r>
-          </a:p>
-        </p:txBody>
-      </p:sp>
-      <p:sp>
-        <p:nvSpPr>
-          <p:cNvPr id="20" name="TextBox 19"/>
-          <p:cNvSpPr txBox="1"/>
-          <p:nvPr/>
-        </p:nvSpPr>
-        <p:spPr>
-          <a:xfrm>
-            <a:off x="603504" y="2615184"/>
-            <a:ext cx="5120640" cy="365760"/>
-          </a:xfrm>
-          <a:prstGeom prst="rect">
-            <a:avLst/>
-          </a:prstGeom>
-          <a:noFill/>
-        </p:spPr>
-        <p:txBody>
-          <a:bodyPr wrap="square" anchor="t">
-            <a:spAutoFit/>
-          </a:bodyPr>
-          <a:lstStyle/>
-          <a:p>
-            <a:pPr algn="l"/>
-            <a:r>
-              <a:rPr sz="1400" b="1">
-                <a:solidFill>
-                  <a:srgbClr val="26303A"/>
-                </a:solidFill>
-                <a:latin typeface="Calibri"/>
-              </a:rPr>
-              <a:t>Each solves a slice, and </a:t>
-            </a:r>
-            <a:r>
-              <a:rPr sz="1400" b="1">
-                <a:solidFill>
-                  <a:srgbClr val="C0453B"/>
-                </a:solidFill>
-                <a:latin typeface="Calibri"/>
-              </a:rPr>
-              <a:t>nothing carries across a handover.</a:t>
-            </a:r>
-          </a:p>
-        </p:txBody>
-      </p:sp>
-      <p:sp>
-        <p:nvSpPr>
-          <p:cNvPr id="21" name="Rounded Rectangle 20"/>
-          <p:cNvSpPr/>
-          <p:nvPr/>
-        </p:nvSpPr>
-        <p:spPr>
-          <a:xfrm>
-            <a:off x="6071616" y="1005840"/>
-            <a:ext cx="5440680" cy="2084831"/>
-          </a:xfrm>
-          <a:prstGeom prst="roundRect">
-            <a:avLst>
-              <a:gd name="adj" fmla="val 8000"/>
-            </a:avLst>
-          </a:prstGeom>
-          <a:solidFill>
-            <a:srgbClr val="EEF8F6"/>
-          </a:solidFill>
-          <a:ln w="19050">
-            <a:solidFill>
-              <a:srgbClr val="9CCBC5"/>
-            </a:solidFill>
+          <a:solidFill>
+            <a:srgbClr val="E3E8E9"/>
+          </a:solidFill>
+          <a:ln>
+            <a:noFill/>
           </a:ln>
         </p:spPr>
         <p:style>
@@ -10720,14 +10606,14 @@
       </p:sp>
       <p:sp>
         <p:nvSpPr>
-          <p:cNvPr id="22" name="TextBox 21"/>
+          <p:cNvPr id="19" name="TextBox 18"/>
           <p:cNvSpPr txBox="1"/>
           <p:nvPr/>
         </p:nvSpPr>
         <p:spPr>
           <a:xfrm>
-            <a:off x="6199632" y="1078992"/>
-            <a:ext cx="5120640" cy="274320"/>
+            <a:off x="621792" y="2670047"/>
+            <a:ext cx="5120640" cy="310896"/>
           </a:xfrm>
           <a:prstGeom prst="rect">
             <a:avLst/>
@@ -10744,78 +10630,47 @@
             <a:r>
               <a:rPr sz="1400" b="1">
                 <a:solidFill>
-                  <a:srgbClr val="0A5F59"/>
-                </a:solidFill>
-                <a:latin typeface="Calibri"/>
-              </a:rPr>
-              <a:t>Agentic platforms  </a:t>
+                  <a:srgbClr val="26303A"/>
+                </a:solidFill>
+                <a:latin typeface="Calibri"/>
+              </a:rPr>
+              <a:t>Sharp on the one step they own, </a:t>
             </a:r>
             <a:r>
               <a:rPr sz="1400" b="1">
                 <a:solidFill>
-                  <a:srgbClr val="6B7580"/>
-                </a:solidFill>
-                <a:latin typeface="Calibri"/>
-              </a:rPr>
-              <a:t>AI-native, across the lifecycle</a:t>
-            </a:r>
-          </a:p>
-        </p:txBody>
-      </p:sp>
-      <p:sp>
-        <p:nvSpPr>
-          <p:cNvPr id="23" name="TextBox 22"/>
-          <p:cNvSpPr txBox="1"/>
-          <p:nvPr/>
-        </p:nvSpPr>
-        <p:spPr>
-          <a:xfrm>
-            <a:off x="6199632" y="1371600"/>
-            <a:ext cx="5120640" cy="329184"/>
-          </a:xfrm>
-          <a:prstGeom prst="rect">
-            <a:avLst/>
-          </a:prstGeom>
-          <a:noFill/>
-        </p:spPr>
-        <p:txBody>
-          <a:bodyPr wrap="square" anchor="t"/>
-          <a:lstStyle/>
-          <a:p>
-            <a:pPr algn="l"/>
-            <a:r>
-              <a:rPr sz="1400" b="0">
-                <a:solidFill>
-                  <a:srgbClr val="3A454F"/>
-                </a:solidFill>
-                <a:latin typeface="Calibri"/>
-              </a:rPr>
-              <a:t>One platform that reasons across every stage, from BoQ through to site.</a:t>
-            </a:r>
-          </a:p>
-        </p:txBody>
-      </p:sp>
-      <p:sp>
-        <p:nvSpPr>
-          <p:cNvPr id="24" name="Rounded Rectangle 23"/>
+                  <a:srgbClr val="C0453B"/>
+                </a:solidFill>
+                <a:latin typeface="Calibri"/>
+              </a:rPr>
+              <a:t>nothing carries across a handover.</a:t>
+            </a:r>
+          </a:p>
+        </p:txBody>
+      </p:sp>
+      <p:sp>
+        <p:nvSpPr>
+          <p:cNvPr id="20" name="Rounded Rectangle 19"/>
           <p:cNvSpPr/>
           <p:nvPr/>
         </p:nvSpPr>
         <p:spPr>
           <a:xfrm>
-            <a:off x="7306056" y="1828800"/>
-            <a:ext cx="2971800" cy="420624"/>
+            <a:off x="6071616" y="1005840"/>
+            <a:ext cx="5440680" cy="2084831"/>
           </a:xfrm>
           <a:prstGeom prst="roundRect">
             <a:avLst>
-              <a:gd name="adj" fmla="val 8000"/>
+              <a:gd name="adj" fmla="val 4000"/>
             </a:avLst>
           </a:prstGeom>
           <a:solidFill>
-            <a:srgbClr val="DCEEEA"/>
-          </a:solidFill>
-          <a:ln>
-            <a:noFill/>
+            <a:srgbClr val="F4FAF9"/>
+          </a:solidFill>
+          <a:ln w="15875">
+            <a:solidFill>
+              <a:srgbClr val="9CCBC5"/>
+            </a:solidFill>
           </a:ln>
         </p:spPr>
         <p:style>
@@ -10833,32 +10688,23 @@
           </a:fontRef>
         </p:style>
         <p:txBody>
-          <a:bodyPr rtlCol="0" anchor="ctr" wrap="square" lIns="73152" rIns="73152" tIns="36576" bIns="36576"/>
+          <a:bodyPr rtlCol="0" anchor="ctr"/>
           <a:lstStyle/>
           <a:p>
             <a:pPr algn="ctr"/>
-            <a:r>
-              <a:rPr sz="1400" b="1">
-                <a:solidFill>
-                  <a:srgbClr val="0A5F59"/>
-                </a:solidFill>
-                <a:latin typeface="Calibri"/>
-              </a:rPr>
-              <a:t>NO ONE IS HERE YET</a:t>
-            </a:r>
-          </a:p>
-        </p:txBody>
-      </p:sp>
-      <p:sp>
-        <p:nvSpPr>
-          <p:cNvPr id="25" name="TextBox 24"/>
+          </a:p>
+        </p:txBody>
+      </p:sp>
+      <p:sp>
+        <p:nvSpPr>
+          <p:cNvPr id="21" name="TextBox 20"/>
           <p:cNvSpPr txBox="1"/>
           <p:nvPr/>
         </p:nvSpPr>
         <p:spPr>
           <a:xfrm>
-            <a:off x="6199632" y="2468880"/>
-            <a:ext cx="5120640" cy="457200"/>
+            <a:off x="6217920" y="1097280"/>
+            <a:ext cx="5120640" cy="274320"/>
           </a:xfrm>
           <a:prstGeom prst="rect">
             <a:avLst/>
@@ -10879,6 +10725,147 @@
                 </a:solidFill>
                 <a:latin typeface="Calibri"/>
               </a:rPr>
+              <a:t>Agentic platforms  </a:t>
+            </a:r>
+            <a:r>
+              <a:rPr sz="1400" b="1">
+                <a:solidFill>
+                  <a:srgbClr val="6B7580"/>
+                </a:solidFill>
+                <a:latin typeface="Calibri"/>
+              </a:rPr>
+              <a:t>AI-native, across the lifecycle</a:t>
+            </a:r>
+          </a:p>
+        </p:txBody>
+      </p:sp>
+      <p:sp>
+        <p:nvSpPr>
+          <p:cNvPr id="22" name="Rounded Rectangle 21"/>
+          <p:cNvSpPr/>
+          <p:nvPr/>
+        </p:nvSpPr>
+        <p:spPr>
+          <a:xfrm>
+            <a:off x="6217920" y="1499616"/>
+            <a:ext cx="5148072" cy="1005840"/>
+          </a:xfrm>
+          <a:prstGeom prst="roundRect">
+            <a:avLst>
+              <a:gd name="adj" fmla="val 4000"/>
+            </a:avLst>
+          </a:prstGeom>
+          <a:solidFill>
+            <a:srgbClr val="DCEEEA"/>
+          </a:solidFill>
+          <a:ln>
+            <a:noFill/>
+          </a:ln>
+        </p:spPr>
+        <p:style>
+          <a:lnRef idx="1">
+            <a:schemeClr val="accent1"/>
+          </a:lnRef>
+          <a:fillRef idx="3">
+            <a:schemeClr val="accent1"/>
+          </a:fillRef>
+          <a:effectRef idx="2">
+            <a:schemeClr val="accent1"/>
+          </a:effectRef>
+          <a:fontRef idx="minor">
+            <a:schemeClr val="lt1"/>
+          </a:fontRef>
+        </p:style>
+        <p:txBody>
+          <a:bodyPr rtlCol="0" anchor="ctr" wrap="square" lIns="73152" rIns="73152" tIns="36576" bIns="36576"/>
+          <a:lstStyle/>
+          <a:p>
+            <a:pPr algn="ctr"/>
+            <a:r>
+              <a:rPr sz="1400" b="1">
+                <a:solidFill>
+                  <a:srgbClr val="0A5F59"/>
+                </a:solidFill>
+                <a:latin typeface="Calibri"/>
+              </a:rPr>
+              <a:t>NO ONE IS HERE YET</a:t>
+            </a:r>
+          </a:p>
+        </p:txBody>
+      </p:sp>
+      <p:sp>
+        <p:nvSpPr>
+          <p:cNvPr id="23" name="Rectangle 22"/>
+          <p:cNvSpPr/>
+          <p:nvPr/>
+        </p:nvSpPr>
+        <p:spPr>
+          <a:xfrm>
+            <a:off x="6217920" y="2615183"/>
+            <a:ext cx="5148072" cy="9144"/>
+          </a:xfrm>
+          <a:prstGeom prst="rect">
+            <a:avLst/>
+          </a:prstGeom>
+          <a:solidFill>
+            <a:srgbClr val="9CCBC5"/>
+          </a:solidFill>
+          <a:ln>
+            <a:noFill/>
+          </a:ln>
+        </p:spPr>
+        <p:style>
+          <a:lnRef idx="1">
+            <a:schemeClr val="accent1"/>
+          </a:lnRef>
+          <a:fillRef idx="3">
+            <a:schemeClr val="accent1"/>
+          </a:fillRef>
+          <a:effectRef idx="2">
+            <a:schemeClr val="accent1"/>
+          </a:effectRef>
+          <a:fontRef idx="minor">
+            <a:schemeClr val="lt1"/>
+          </a:fontRef>
+        </p:style>
+        <p:txBody>
+          <a:bodyPr rtlCol="0" anchor="ctr"/>
+          <a:lstStyle/>
+          <a:p>
+            <a:pPr algn="ctr"/>
+          </a:p>
+        </p:txBody>
+      </p:sp>
+      <p:sp>
+        <p:nvSpPr>
+          <p:cNvPr id="24" name="TextBox 23"/>
+          <p:cNvSpPr txBox="1"/>
+          <p:nvPr/>
+        </p:nvSpPr>
+        <p:spPr>
+          <a:xfrm>
+            <a:off x="6217920" y="2670047"/>
+            <a:ext cx="5120640" cy="310896"/>
+          </a:xfrm>
+          <a:prstGeom prst="rect">
+            <a:avLst/>
+          </a:prstGeom>
+          <a:noFill/>
+        </p:spPr>
+        <p:txBody>
+          <a:bodyPr wrap="square" anchor="t">
+            <a:spAutoFit/>
+          </a:bodyPr>
+          <a:lstStyle/>
+          <a:p>
+            <a:pPr algn="l"/>
+            <a:r>
+              <a:rPr sz="1400" b="1">
+                <a:solidFill>
+                  <a:srgbClr val="0A5F59"/>
+                </a:solidFill>
+                <a:latin typeface="Calibri"/>
+              </a:rPr>
               <a:t>Where the market is heading, </a:t>
             </a:r>
             <a:r>
@@ -10895,7 +10882,7 @@
       </p:sp>
       <p:sp>
         <p:nvSpPr>
-          <p:cNvPr id="26" name="Rounded Rectangle 25"/>
+          <p:cNvPr id="25" name="Rounded Rectangle 24"/>
           <p:cNvSpPr/>
           <p:nvPr/>
         </p:nvSpPr>
@@ -10906,11 +10893,11 @@
           </a:xfrm>
           <a:prstGeom prst="roundRect">
             <a:avLst>
-              <a:gd name="adj" fmla="val 8000"/>
+              <a:gd name="adj" fmla="val 4000"/>
             </a:avLst>
           </a:prstGeom>
           <a:solidFill>
-            <a:srgbClr val="F7F9F9"/>
+            <a:srgbClr val="FFFFFF"/>
           </a:solidFill>
           <a:ln w="9525">
             <a:solidFill>
@@ -10942,13 +10929,13 @@
       </p:sp>
       <p:sp>
         <p:nvSpPr>
-          <p:cNvPr id="27" name="TextBox 26"/>
+          <p:cNvPr id="26" name="TextBox 25"/>
           <p:cNvSpPr txBox="1"/>
           <p:nvPr/>
         </p:nvSpPr>
         <p:spPr>
           <a:xfrm>
-            <a:off x="603504" y="3986784"/>
+            <a:off x="621792" y="4005072"/>
             <a:ext cx="5120640" cy="274320"/>
           </a:xfrm>
           <a:prstGeom prst="rect">
@@ -10986,47 +10973,14 @@
       </p:sp>
       <p:sp>
         <p:nvSpPr>
-          <p:cNvPr id="28" name="TextBox 27"/>
-          <p:cNvSpPr txBox="1"/>
-          <p:nvPr/>
-        </p:nvSpPr>
-        <p:spPr>
-          <a:xfrm>
-            <a:off x="603504" y="4242816"/>
-            <a:ext cx="5120640" cy="256032"/>
-          </a:xfrm>
-          <a:prstGeom prst="rect">
-            <a:avLst/>
-          </a:prstGeom>
-          <a:noFill/>
-        </p:spPr>
-        <p:txBody>
-          <a:bodyPr wrap="square" anchor="t"/>
-          <a:lstStyle/>
-          <a:p>
-            <a:pPr algn="l"/>
-            <a:r>
-              <a:rPr sz="1400" b="0">
-                <a:solidFill>
-                  <a:srgbClr val="3A454F"/>
-                </a:solidFill>
-                <a:latin typeface="Calibri"/>
-              </a:rPr>
-              <a:t>Built around a single task and driven entirely by the operator.</a:t>
-            </a:r>
-          </a:p>
-        </p:txBody>
-      </p:sp>
-      <p:sp>
-        <p:nvSpPr>
-          <p:cNvPr id="29" name="Rounded Rectangle 28"/>
+          <p:cNvPr id="27" name="Rounded Rectangle 26"/>
           <p:cNvSpPr/>
           <p:nvPr/>
         </p:nvSpPr>
         <p:spPr>
           <a:xfrm>
-            <a:off x="603504" y="4553712"/>
-            <a:ext cx="1417320" cy="274320"/>
+            <a:off x="621792" y="4425696"/>
+            <a:ext cx="1243584" cy="274320"/>
           </a:xfrm>
           <a:prstGeom prst="roundRect">
             <a:avLst>
@@ -11075,14 +11029,14 @@
       </p:sp>
       <p:sp>
         <p:nvSpPr>
-          <p:cNvPr id="30" name="Rounded Rectangle 29"/>
+          <p:cNvPr id="28" name="Rounded Rectangle 27"/>
           <p:cNvSpPr/>
           <p:nvPr/>
         </p:nvSpPr>
         <p:spPr>
           <a:xfrm>
-            <a:off x="2075688" y="4553712"/>
-            <a:ext cx="1417320" cy="274320"/>
+            <a:off x="1920240" y="4425696"/>
+            <a:ext cx="1243584" cy="274320"/>
           </a:xfrm>
           <a:prstGeom prst="roundRect">
             <a:avLst>
@@ -11131,14 +11085,14 @@
       </p:sp>
       <p:sp>
         <p:nvSpPr>
-          <p:cNvPr id="31" name="Rounded Rectangle 30"/>
+          <p:cNvPr id="29" name="Rounded Rectangle 28"/>
           <p:cNvSpPr/>
           <p:nvPr/>
         </p:nvSpPr>
         <p:spPr>
           <a:xfrm>
-            <a:off x="3547872" y="4553712"/>
-            <a:ext cx="1417320" cy="274320"/>
+            <a:off x="3218688" y="4425696"/>
+            <a:ext cx="1243584" cy="274320"/>
           </a:xfrm>
           <a:prstGeom prst="roundRect">
             <a:avLst>
@@ -11187,14 +11141,14 @@
       </p:sp>
       <p:sp>
         <p:nvSpPr>
-          <p:cNvPr id="32" name="Rounded Rectangle 31"/>
+          <p:cNvPr id="30" name="Rounded Rectangle 29"/>
           <p:cNvSpPr/>
           <p:nvPr/>
         </p:nvSpPr>
         <p:spPr>
           <a:xfrm>
-            <a:off x="5020056" y="4553712"/>
-            <a:ext cx="1417320" cy="274320"/>
+            <a:off x="4517136" y="4425696"/>
+            <a:ext cx="1243584" cy="274320"/>
           </a:xfrm>
           <a:prstGeom prst="roundRect">
             <a:avLst>
@@ -11243,14 +11197,14 @@
       </p:sp>
       <p:sp>
         <p:nvSpPr>
-          <p:cNvPr id="33" name="Rounded Rectangle 32"/>
+          <p:cNvPr id="31" name="Rounded Rectangle 30"/>
           <p:cNvSpPr/>
           <p:nvPr/>
         </p:nvSpPr>
         <p:spPr>
           <a:xfrm>
-            <a:off x="603504" y="4882896"/>
-            <a:ext cx="1417320" cy="274320"/>
+            <a:off x="621792" y="4754880"/>
+            <a:ext cx="1243584" cy="274320"/>
           </a:xfrm>
           <a:prstGeom prst="roundRect">
             <a:avLst>
@@ -11299,14 +11253,14 @@
       </p:sp>
       <p:sp>
         <p:nvSpPr>
-          <p:cNvPr id="34" name="Rounded Rectangle 33"/>
+          <p:cNvPr id="32" name="Rounded Rectangle 31"/>
           <p:cNvSpPr/>
           <p:nvPr/>
         </p:nvSpPr>
         <p:spPr>
           <a:xfrm>
-            <a:off x="2075688" y="4882896"/>
-            <a:ext cx="1417320" cy="274320"/>
+            <a:off x="1920240" y="4754880"/>
+            <a:ext cx="1243584" cy="274320"/>
           </a:xfrm>
           <a:prstGeom prst="roundRect">
             <a:avLst>
@@ -11355,14 +11309,14 @@
       </p:sp>
       <p:sp>
         <p:nvSpPr>
-          <p:cNvPr id="35" name="Rounded Rectangle 34"/>
+          <p:cNvPr id="33" name="Rounded Rectangle 32"/>
           <p:cNvSpPr/>
           <p:nvPr/>
         </p:nvSpPr>
         <p:spPr>
           <a:xfrm>
-            <a:off x="3547872" y="4882896"/>
-            <a:ext cx="1417320" cy="274320"/>
+            <a:off x="3218688" y="4754880"/>
+            <a:ext cx="1243584" cy="274320"/>
           </a:xfrm>
           <a:prstGeom prst="roundRect">
             <a:avLst>
@@ -11411,47 +11365,57 @@
       </p:sp>
       <p:sp>
         <p:nvSpPr>
-          <p:cNvPr id="36" name="TextBox 35"/>
+          <p:cNvPr id="34" name="Rectangle 33"/>
+          <p:cNvSpPr/>
+          <p:nvPr/>
+        </p:nvSpPr>
+        <p:spPr>
+          <a:xfrm>
+            <a:off x="621792" y="5522975"/>
+            <a:ext cx="5148072" cy="9144"/>
+          </a:xfrm>
+          <a:prstGeom prst="rect">
+            <a:avLst/>
+          </a:prstGeom>
+          <a:solidFill>
+            <a:srgbClr val="E3E8E9"/>
+          </a:solidFill>
+          <a:ln>
+            <a:noFill/>
+          </a:ln>
+        </p:spPr>
+        <p:style>
+          <a:lnRef idx="1">
+            <a:schemeClr val="accent1"/>
+          </a:lnRef>
+          <a:fillRef idx="3">
+            <a:schemeClr val="accent1"/>
+          </a:fillRef>
+          <a:effectRef idx="2">
+            <a:schemeClr val="accent1"/>
+          </a:effectRef>
+          <a:fontRef idx="minor">
+            <a:schemeClr val="lt1"/>
+          </a:fontRef>
+        </p:style>
+        <p:txBody>
+          <a:bodyPr rtlCol="0" anchor="ctr"/>
+          <a:lstStyle/>
+          <a:p>
+            <a:pPr algn="ctr"/>
+          </a:p>
+        </p:txBody>
+      </p:sp>
+      <p:sp>
+        <p:nvSpPr>
+          <p:cNvPr id="35" name="TextBox 34"/>
           <p:cNvSpPr txBox="1"/>
           <p:nvPr/>
         </p:nvSpPr>
         <p:spPr>
           <a:xfrm>
-            <a:off x="603504" y="5285232"/>
-            <a:ext cx="5120640" cy="219456"/>
-          </a:xfrm>
-          <a:prstGeom prst="rect">
-            <a:avLst/>
-          </a:prstGeom>
-          <a:noFill/>
-        </p:spPr>
-        <p:txBody>
-          <a:bodyPr wrap="square" anchor="t"/>
-          <a:lstStyle/>
-          <a:p>
-            <a:pPr algn="l"/>
-            <a:r>
-              <a:rPr sz="1400" b="0">
-                <a:solidFill>
-                  <a:srgbClr val="6B7580"/>
-                </a:solidFill>
-                <a:latin typeface="Calibri"/>
-              </a:rPr>
-              <a:t>Strong in  measurement, pricing, drawing markup</a:t>
-            </a:r>
-          </a:p>
-        </p:txBody>
-      </p:sp>
-      <p:sp>
-        <p:nvSpPr>
-          <p:cNvPr id="37" name="TextBox 36"/>
-          <p:cNvSpPr txBox="1"/>
-          <p:nvPr/>
-        </p:nvSpPr>
-        <p:spPr>
-          <a:xfrm>
-            <a:off x="603504" y="5522976"/>
-            <a:ext cx="5120640" cy="365760"/>
+            <a:off x="621792" y="5577839"/>
+            <a:ext cx="5120640" cy="310896"/>
           </a:xfrm>
           <a:prstGeom prst="rect">
             <a:avLst/>
@@ -11472,7 +11436,7 @@
                 </a:solidFill>
                 <a:latin typeface="Calibri"/>
               </a:rPr>
-              <a:t>Where most of the market still sits, with </a:t>
+              <a:t>Most of the market still sits here, </a:t>
             </a:r>
             <a:r>
               <a:rPr sz="1400" b="1">
@@ -11488,7 +11452,7 @@
       </p:sp>
       <p:sp>
         <p:nvSpPr>
-          <p:cNvPr id="38" name="Rounded Rectangle 37"/>
+          <p:cNvPr id="36" name="Rounded Rectangle 35"/>
           <p:cNvSpPr/>
           <p:nvPr/>
         </p:nvSpPr>
@@ -11499,11 +11463,11 @@
           </a:xfrm>
           <a:prstGeom prst="roundRect">
             <a:avLst>
-              <a:gd name="adj" fmla="val 8000"/>
+              <a:gd name="adj" fmla="val 4000"/>
             </a:avLst>
           </a:prstGeom>
           <a:solidFill>
-            <a:srgbClr val="F7F9F9"/>
+            <a:srgbClr val="FFFFFF"/>
           </a:solidFill>
           <a:ln w="9525">
             <a:solidFill>
@@ -11535,13 +11499,13 @@
       </p:sp>
       <p:sp>
         <p:nvSpPr>
-          <p:cNvPr id="39" name="TextBox 38"/>
+          <p:cNvPr id="37" name="TextBox 36"/>
           <p:cNvSpPr txBox="1"/>
           <p:nvPr/>
         </p:nvSpPr>
         <p:spPr>
           <a:xfrm>
-            <a:off x="6199632" y="3986784"/>
+            <a:off x="6217920" y="4005072"/>
             <a:ext cx="5120640" cy="274320"/>
           </a:xfrm>
           <a:prstGeom prst="rect">
@@ -11579,47 +11543,14 @@
       </p:sp>
       <p:sp>
         <p:nvSpPr>
-          <p:cNvPr id="40" name="TextBox 39"/>
-          <p:cNvSpPr txBox="1"/>
-          <p:nvPr/>
-        </p:nvSpPr>
-        <p:spPr>
-          <a:xfrm>
-            <a:off x="6199632" y="4242816"/>
-            <a:ext cx="5120640" cy="256032"/>
-          </a:xfrm>
-          <a:prstGeom prst="rect">
-            <a:avLst/>
-          </a:prstGeom>
-          <a:noFill/>
-        </p:spPr>
-        <p:txBody>
-          <a:bodyPr wrap="square" anchor="t"/>
-          <a:lstStyle/>
-          <a:p>
-            <a:pPr algn="l"/>
-            <a:r>
-              <a:rPr sz="1400" b="0">
-                <a:solidFill>
-                  <a:srgbClr val="3A454F"/>
-                </a:solidFill>
-                <a:latin typeface="Calibri"/>
-              </a:rPr>
-              <a:t>Systems of record spanning stages through modules and configuration.</a:t>
-            </a:r>
-          </a:p>
-        </p:txBody>
-      </p:sp>
-      <p:sp>
-        <p:nvSpPr>
-          <p:cNvPr id="41" name="Rounded Rectangle 40"/>
+          <p:cNvPr id="38" name="Rounded Rectangle 37"/>
           <p:cNvSpPr/>
           <p:nvPr/>
         </p:nvSpPr>
         <p:spPr>
           <a:xfrm>
-            <a:off x="6199632" y="4553712"/>
-            <a:ext cx="1115568" cy="274320"/>
+            <a:off x="6217920" y="4425696"/>
+            <a:ext cx="1261872" cy="274320"/>
           </a:xfrm>
           <a:prstGeom prst="roundRect">
             <a:avLst>
@@ -11668,14 +11599,14 @@
       </p:sp>
       <p:sp>
         <p:nvSpPr>
-          <p:cNvPr id="42" name="Rounded Rectangle 41"/>
+          <p:cNvPr id="39" name="Rounded Rectangle 38"/>
           <p:cNvSpPr/>
           <p:nvPr/>
         </p:nvSpPr>
         <p:spPr>
           <a:xfrm>
-            <a:off x="7370064" y="4553712"/>
-            <a:ext cx="1115568" cy="274320"/>
+            <a:off x="7534656" y="4425696"/>
+            <a:ext cx="1261872" cy="274320"/>
           </a:xfrm>
           <a:prstGeom prst="roundRect">
             <a:avLst>
@@ -11724,14 +11655,14 @@
       </p:sp>
       <p:sp>
         <p:nvSpPr>
-          <p:cNvPr id="43" name="Rounded Rectangle 42"/>
+          <p:cNvPr id="40" name="Rounded Rectangle 39"/>
           <p:cNvSpPr/>
           <p:nvPr/>
         </p:nvSpPr>
         <p:spPr>
           <a:xfrm>
-            <a:off x="8540496" y="4553712"/>
-            <a:ext cx="1115568" cy="274320"/>
+            <a:off x="8851392" y="4425696"/>
+            <a:ext cx="1261872" cy="274320"/>
           </a:xfrm>
           <a:prstGeom prst="roundRect">
             <a:avLst>
@@ -11780,14 +11711,14 @@
       </p:sp>
       <p:sp>
         <p:nvSpPr>
-          <p:cNvPr id="44" name="Rounded Rectangle 43"/>
+          <p:cNvPr id="41" name="Rounded Rectangle 40"/>
           <p:cNvSpPr/>
           <p:nvPr/>
         </p:nvSpPr>
         <p:spPr>
           <a:xfrm>
-            <a:off x="9710928" y="4553712"/>
-            <a:ext cx="1115568" cy="274320"/>
+            <a:off x="10168128" y="4425696"/>
+            <a:ext cx="1261872" cy="274320"/>
           </a:xfrm>
           <a:prstGeom prst="roundRect">
             <a:avLst>
@@ -11836,14 +11767,14 @@
       </p:sp>
       <p:sp>
         <p:nvSpPr>
-          <p:cNvPr id="45" name="Rounded Rectangle 44"/>
+          <p:cNvPr id="42" name="Rounded Rectangle 41"/>
           <p:cNvSpPr/>
           <p:nvPr/>
         </p:nvSpPr>
         <p:spPr>
           <a:xfrm>
-            <a:off x="10881360" y="4553712"/>
-            <a:ext cx="1115568" cy="274320"/>
+            <a:off x="6217920" y="4754880"/>
+            <a:ext cx="1261872" cy="274320"/>
           </a:xfrm>
           <a:prstGeom prst="roundRect">
             <a:avLst>
@@ -11892,14 +11823,14 @@
       </p:sp>
       <p:sp>
         <p:nvSpPr>
-          <p:cNvPr id="46" name="Rounded Rectangle 45"/>
+          <p:cNvPr id="43" name="Rounded Rectangle 42"/>
           <p:cNvSpPr/>
           <p:nvPr/>
         </p:nvSpPr>
         <p:spPr>
           <a:xfrm>
-            <a:off x="6199632" y="4882896"/>
-            <a:ext cx="1115568" cy="274320"/>
+            <a:off x="7534656" y="4754880"/>
+            <a:ext cx="1261872" cy="274320"/>
           </a:xfrm>
           <a:prstGeom prst="roundRect">
             <a:avLst>
@@ -11948,14 +11879,14 @@
       </p:sp>
       <p:sp>
         <p:nvSpPr>
-          <p:cNvPr id="47" name="Rounded Rectangle 46"/>
+          <p:cNvPr id="44" name="Rounded Rectangle 43"/>
           <p:cNvSpPr/>
           <p:nvPr/>
         </p:nvSpPr>
         <p:spPr>
           <a:xfrm>
-            <a:off x="7370064" y="4882896"/>
-            <a:ext cx="1115568" cy="274320"/>
+            <a:off x="8851392" y="4754880"/>
+            <a:ext cx="1261872" cy="274320"/>
           </a:xfrm>
           <a:prstGeom prst="roundRect">
             <a:avLst>
@@ -12004,14 +11935,14 @@
       </p:sp>
       <p:sp>
         <p:nvSpPr>
-          <p:cNvPr id="48" name="Rounded Rectangle 47"/>
+          <p:cNvPr id="45" name="Rounded Rectangle 44"/>
           <p:cNvSpPr/>
           <p:nvPr/>
         </p:nvSpPr>
         <p:spPr>
           <a:xfrm>
-            <a:off x="8540496" y="4882896"/>
-            <a:ext cx="1115568" cy="274320"/>
+            <a:off x="10168128" y="4754880"/>
+            <a:ext cx="1261872" cy="274320"/>
           </a:xfrm>
           <a:prstGeom prst="roundRect">
             <a:avLst>
@@ -12060,14 +11991,14 @@
       </p:sp>
       <p:sp>
         <p:nvSpPr>
-          <p:cNvPr id="49" name="Rounded Rectangle 48"/>
+          <p:cNvPr id="46" name="Rounded Rectangle 45"/>
           <p:cNvSpPr/>
           <p:nvPr/>
         </p:nvSpPr>
         <p:spPr>
           <a:xfrm>
-            <a:off x="9710928" y="4882896"/>
-            <a:ext cx="1115568" cy="274320"/>
+            <a:off x="6217920" y="5084064"/>
+            <a:ext cx="1261872" cy="274320"/>
           </a:xfrm>
           <a:prstGeom prst="roundRect">
             <a:avLst>
@@ -12116,47 +12047,57 @@
       </p:sp>
       <p:sp>
         <p:nvSpPr>
-          <p:cNvPr id="50" name="TextBox 49"/>
+          <p:cNvPr id="47" name="Rectangle 46"/>
+          <p:cNvSpPr/>
+          <p:nvPr/>
+        </p:nvSpPr>
+        <p:spPr>
+          <a:xfrm>
+            <a:off x="6217920" y="5522975"/>
+            <a:ext cx="5148072" cy="9144"/>
+          </a:xfrm>
+          <a:prstGeom prst="rect">
+            <a:avLst/>
+          </a:prstGeom>
+          <a:solidFill>
+            <a:srgbClr val="E3E8E9"/>
+          </a:solidFill>
+          <a:ln>
+            <a:noFill/>
+          </a:ln>
+        </p:spPr>
+        <p:style>
+          <a:lnRef idx="1">
+            <a:schemeClr val="accent1"/>
+          </a:lnRef>
+          <a:fillRef idx="3">
+            <a:schemeClr val="accent1"/>
+          </a:fillRef>
+          <a:effectRef idx="2">
+            <a:schemeClr val="accent1"/>
+          </a:effectRef>
+          <a:fontRef idx="minor">
+            <a:schemeClr val="lt1"/>
+          </a:fontRef>
+        </p:style>
+        <p:txBody>
+          <a:bodyPr rtlCol="0" anchor="ctr"/>
+          <a:lstStyle/>
+          <a:p>
+            <a:pPr algn="ctr"/>
+          </a:p>
+        </p:txBody>
+      </p:sp>
+      <p:sp>
+        <p:nvSpPr>
+          <p:cNvPr id="48" name="TextBox 47"/>
           <p:cNvSpPr txBox="1"/>
           <p:nvPr/>
         </p:nvSpPr>
         <p:spPr>
           <a:xfrm>
-            <a:off x="6199632" y="5285232"/>
-            <a:ext cx="5120640" cy="219456"/>
-          </a:xfrm>
-          <a:prstGeom prst="rect">
-            <a:avLst/>
-          </a:prstGeom>
-          <a:noFill/>
-        </p:spPr>
-        <p:txBody>
-          <a:bodyPr wrap="square" anchor="t"/>
-          <a:lstStyle/>
-          <a:p>
-            <a:pPr algn="l"/>
-            <a:r>
-              <a:rPr sz="1400" b="0">
-                <a:solidFill>
-                  <a:srgbClr val="6B7580"/>
-                </a:solidFill>
-                <a:latin typeface="Calibri"/>
-              </a:rPr>
-              <a:t>Strong in  cost control, scheduling, procurement, documents</a:t>
-            </a:r>
-          </a:p>
-        </p:txBody>
-      </p:sp>
-      <p:sp>
-        <p:nvSpPr>
-          <p:cNvPr id="51" name="TextBox 50"/>
-          <p:cNvSpPr txBox="1"/>
-          <p:nvPr/>
-        </p:nvSpPr>
-        <p:spPr>
-          <a:xfrm>
-            <a:off x="6199632" y="5522976"/>
-            <a:ext cx="5120640" cy="365760"/>
+            <a:off x="6217920" y="5577839"/>
+            <a:ext cx="5120640" cy="310896"/>
           </a:xfrm>
           <a:prstGeom prst="rect">
             <a:avLst/>
@@ -12177,7 +12118,7 @@
                 </a:solidFill>
                 <a:latin typeface="Calibri"/>
               </a:rPr>
-              <a:t>Breadth without intelligence: </a:t>
+              <a:t>Broad but rules-based, </a:t>
             </a:r>
             <a:r>
               <a:rPr sz="1400" b="1">
@@ -12186,21 +12127,21 @@
                 </a:solidFill>
                 <a:latin typeface="Calibri"/>
               </a:rPr>
-              <a:t>more features, and harder to use.</a:t>
-            </a:r>
-          </a:p>
-        </p:txBody>
-      </p:sp>
-      <p:sp>
-        <p:nvSpPr>
-          <p:cNvPr id="52" name="Rounded Rectangle 51"/>
+              <a:t>more features and harder to use.</a:t>
+            </a:r>
+          </a:p>
+        </p:txBody>
+      </p:sp>
+      <p:sp>
+        <p:nvSpPr>
+          <p:cNvPr id="49" name="Rounded Rectangle 48"/>
           <p:cNvSpPr/>
           <p:nvPr/>
         </p:nvSpPr>
         <p:spPr>
           <a:xfrm>
-            <a:off x="1965960" y="3017520"/>
-            <a:ext cx="8183879" cy="804672"/>
+            <a:off x="2148840" y="3154680"/>
+            <a:ext cx="7818120" cy="694944"/>
           </a:xfrm>
           <a:prstGeom prst="roundRect">
             <a:avLst>
@@ -12208,7 +12149,7 @@
             </a:avLst>
           </a:prstGeom>
           <a:solidFill>
-            <a:srgbClr val="0E2A31"/>
+            <a:srgbClr val="0A5F59"/>
           </a:solidFill>
           <a:ln w="19050">
             <a:solidFill>
@@ -12231,108 +12172,23 @@
           </a:fontRef>
         </p:style>
         <p:txBody>
-          <a:bodyPr rtlCol="0" anchor="ctr" wrap="square" lIns="73152" rIns="73152" tIns="36576" bIns="36576"/>
-          <a:lstStyle/>
-          <a:p>
-            <a:pPr algn="l"/>
-            <a:r>
-              <a:rPr sz="1400" b="0">
-                <a:solidFill>
-                  <a:srgbClr val="26303A"/>
-                </a:solidFill>
-                <a:latin typeface="Calibri"/>
-              </a:rPr>
-              <a:t/>
-            </a:r>
-          </a:p>
-        </p:txBody>
-      </p:sp>
-      <p:sp>
-        <p:nvSpPr>
-          <p:cNvPr id="53" name="TextBox 52"/>
+          <a:bodyPr rtlCol="0" anchor="ctr"/>
+          <a:lstStyle/>
+          <a:p>
+            <a:pPr algn="ctr"/>
+          </a:p>
+        </p:txBody>
+      </p:sp>
+      <p:sp>
+        <p:nvSpPr>
+          <p:cNvPr id="50" name="TextBox 49"/>
           <p:cNvSpPr txBox="1"/>
           <p:nvPr/>
         </p:nvSpPr>
         <p:spPr>
           <a:xfrm>
-            <a:off x="2121408" y="3108960"/>
-            <a:ext cx="2148840" cy="621792"/>
-          </a:xfrm>
-          <a:prstGeom prst="rect">
-            <a:avLst/>
-          </a:prstGeom>
-          <a:noFill/>
-        </p:spPr>
-        <p:txBody>
-          <a:bodyPr wrap="square" anchor="ctr"/>
-          <a:lstStyle/>
-          <a:p>
-            <a:pPr algn="l"/>
-            <a:r>
-              <a:rPr sz="1600" b="1">
-                <a:solidFill>
-                  <a:srgbClr val="FFFFFF"/>
-                </a:solidFill>
-                <a:latin typeface="Calibri"/>
-              </a:rPr>
-              <a:t>Blue Currency</a:t>
-            </a:r>
-          </a:p>
-        </p:txBody>
-      </p:sp>
-      <p:sp>
-        <p:nvSpPr>
-          <p:cNvPr id="54" name="Rectangle 53"/>
-          <p:cNvSpPr/>
-          <p:nvPr/>
-        </p:nvSpPr>
-        <p:spPr>
-          <a:xfrm>
-            <a:off x="4297680" y="3182112"/>
-            <a:ext cx="13716" cy="475488"/>
-          </a:xfrm>
-          <a:prstGeom prst="rect">
-            <a:avLst/>
-          </a:prstGeom>
-          <a:solidFill>
-            <a:srgbClr val="FFFFFF"/>
-          </a:solidFill>
-          <a:ln>
-            <a:noFill/>
-          </a:ln>
-        </p:spPr>
-        <p:style>
-          <a:lnRef idx="1">
-            <a:schemeClr val="accent1"/>
-          </a:lnRef>
-          <a:fillRef idx="3">
-            <a:schemeClr val="accent1"/>
-          </a:fillRef>
-          <a:effectRef idx="2">
-            <a:schemeClr val="accent1"/>
-          </a:effectRef>
-          <a:fontRef idx="minor">
-            <a:schemeClr val="lt1"/>
-          </a:fontRef>
-        </p:style>
-        <p:txBody>
-          <a:bodyPr rtlCol="0" anchor="ctr"/>
-          <a:lstStyle/>
-          <a:p>
-            <a:pPr algn="ctr"/>
-          </a:p>
-        </p:txBody>
-      </p:sp>
-      <p:sp>
-        <p:nvSpPr>
-          <p:cNvPr id="55" name="TextBox 54"/>
-          <p:cNvSpPr txBox="1"/>
-          <p:nvPr/>
-        </p:nvSpPr>
-        <p:spPr>
-          <a:xfrm>
-            <a:off x="4443984" y="3127248"/>
-            <a:ext cx="5532120" cy="621792"/>
+            <a:off x="2377440" y="3209544"/>
+            <a:ext cx="7406640" cy="585216"/>
           </a:xfrm>
           <a:prstGeom prst="rect">
             <a:avLst/>
@@ -12345,7 +12201,7 @@
           </a:bodyPr>
           <a:lstStyle/>
           <a:p>
-            <a:pPr algn="l"/>
+            <a:pPr algn="ctr"/>
             <a:r>
               <a:rPr sz="1400" b="1">
                 <a:solidFill>
@@ -12353,7 +12209,7 @@
                 </a:solidFill>
                 <a:latin typeface="Calibri"/>
               </a:rPr>
-              <a:t>Deliberately in the middle.  </a:t>
+              <a:t>Blue Currency   </a:t>
             </a:r>
             <a:r>
               <a:rPr sz="1400" b="0">
@@ -12362,14 +12218,14 @@
                 </a:solidFill>
                 <a:latin typeface="Calibri"/>
               </a:rPr>
-              <a:t>Broader than the AI specialists, more AI-native than the enterprise suites.</a:t>
-            </a:r>
-          </a:p>
-        </p:txBody>
-      </p:sp>
-      <p:sp>
-        <p:nvSpPr>
-          <p:cNvPr id="56" name="TextBox 55"/>
+              <a:t>broader than the AI specialists, more AI-native than the enterprise suites</a:t>
+            </a:r>
+          </a:p>
+        </p:txBody>
+      </p:sp>
+      <p:sp>
+        <p:nvSpPr>
+          <p:cNvPr id="51" name="TextBox 50"/>
           <p:cNvSpPr txBox="1"/>
           <p:nvPr/>
         </p:nvSpPr>

</xml_diff>

<commit_message>
Page 1: new action title and a wider right column
Replace the page 1 action title with the end-to-end lifecycle wording,
keeping the closing phrase in <b> so it renders teal.

Shift width from the diagram to the summary column (1.12fr 1fr ->
0.9fr 1fr) so the module descriptions and value propositions get more
room. Trim the diagram padding, the module box padding and the bubble
gaps so the four module labels and the six asset bubbles keep the same
line counts in the narrower column.

Cost realization tracking now reads on one line and the second value
proposition drops from three lines to two. Page 1 measures 723px,
inside the 760px print height.

Co-authored-by: ersoysarp <ersoysarp@users.noreply.github.com>
</commit_message>
<xml_diff>
--- a/BlueCurrency.pptx
+++ b/BlueCurrency.pptx
@@ -505,7 +505,7 @@
           <a:lstStyle/>
           <a:p>
             <a:r>
-              <a:t>Page 1. Introduction. Blue Currency is the first agentic AI platform that runs the entire construction lifecycle, end to end. Modules: orchestration, unified BoQ, dynamic CAPEX, tender evaluation, procurement and progress tracking, plus optional Value Optimizer. Built on existing McKinsey assets.</a:t>
+              <a:t>Page 1. Introduction. The solution covers the end-to-end real estate development lifecycle with different modules, powered by an agentic AI core. Modules: orchestration, unified BoQ, dynamic CAPEX, tender evaluation, procurement and progress tracking, plus optional Value Optimizer. Built on existing McKinsey assets.</a:t>
             </a:r>
           </a:p>
         </p:txBody>
@@ -4044,7 +4044,7 @@
                 </a:solidFill>
                 <a:latin typeface="Calibri"/>
               </a:rPr>
-              <a:t>Blue Currency is the </a:t>
+              <a:t>The solution covers the end-to-end real estate development lifecycle with different modules, </a:t>
             </a:r>
             <a:r>
               <a:rPr sz="2500" b="1">
@@ -4053,16 +4053,7 @@
                 </a:solidFill>
                 <a:latin typeface="Calibri"/>
               </a:rPr>
-              <a:t>first agentic AI platform</a:t>
-            </a:r>
-            <a:r>
-              <a:rPr sz="2500" b="1">
-                <a:solidFill>
-                  <a:srgbClr val="26303A"/>
-                </a:solidFill>
-                <a:latin typeface="Calibri"/>
-              </a:rPr>
-              <a:t> that runs the entire construction lifecycle, end to end</a:t>
+              <a:t>powered by an agentic AI core</a:t>
             </a:r>
           </a:p>
         </p:txBody>

</xml_diff>

<commit_message>
Page 1: reword the assets heading to modular integration with McK assets
Co-authored-by: ersoysarp <ersoysarp@users.noreply.github.com>
</commit_message>
<xml_diff>
--- a/BlueCurrency.pptx
+++ b/BlueCurrency.pptx
@@ -505,7 +505,7 @@
           <a:lstStyle/>
           <a:p>
             <a:r>
-              <a:t>Page 1. Introduction. The solution covers the end-to-end real estate development lifecycle with different modules, powered by an agentic AI core. Modules: orchestration, unified BoQ, dynamic CAPEX, tender evaluation, procurement and progress tracking, plus optional Value Optimizer. Built on existing McKinsey assets.</a:t>
+              <a:t>Page 1. Introduction. The solution covers the end-to-end real estate development lifecycle with different modules, powered by an agentic AI core. Modules: orchestration, unified BoQ, dynamic CAPEX, tender evaluation, procurement and progress tracking, plus optional Value Optimizer. Modular, easy integration with McK assets.</a:t>
             </a:r>
           </a:p>
         </p:txBody>
@@ -4902,7 +4902,7 @@
                 </a:solidFill>
                 <a:latin typeface="Calibri"/>
               </a:rPr>
-              <a:t>BUILT ON EXISTING MCKINSEY ASSETS</a:t>
+              <a:t>MODULAR, EASY INTEGRATION WITH MCK ASSETS</a:t>
             </a:r>
           </a:p>
         </p:txBody>

</xml_diff>